<commit_message>
Actualizar materiales de clases 6, 7 y 8
</commit_message>
<xml_diff>
--- a/clase_7/teoria/Clase_7.pptx
+++ b/clase_7/teoria/Clase_7.pptx
@@ -296,7 +296,7 @@
       </p15:sldGuideLst>
     </p:ext>
     <p:ext uri="GoogleSlidesCustomDataVersion2">
-      <go:slidesCustomData xmlns="" xmlns:mc="http://schemas.openxmlformats.org/markup-compatibility/2006" xmlns:mv="urn:schemas-microsoft-com:mac:vml" xmlns:c="http://schemas.openxmlformats.org/drawingml/2006/chart" xmlns:dgm="http://schemas.openxmlformats.org/drawingml/2006/diagram" xmlns:o="urn:schemas-microsoft-com:office:office" xmlns:v="urn:schemas-microsoft-com:vml" xmlns:pvml="urn:schemas-microsoft-com:office:powerpoint" xmlns:com="http://schemas.openxmlformats.org/drawingml/2006/compatibility" xmlns:p14="http://schemas.microsoft.com/office/powerpoint/2010/main" xmlns:p15="http://schemas.microsoft.com/office/powerpoint/2012/main" xmlns:ahyp="http://schemas.microsoft.com/office/drawing/2018/hyperlinkcolor" xmlns:go="http://customooxmlschemas.google.com/" r:id="rId35" roundtripDataSignature="AMtx7mjFLyGGbKtZ6MKWK8o6r1g77If8Vw=="/>
+      <go:slidesCustomData xmlns:go="http://customooxmlschemas.google.com/" xmlns:ahyp="http://schemas.microsoft.com/office/drawing/2018/hyperlinkcolor" xmlns:p15="http://schemas.microsoft.com/office/powerpoint/2012/main" xmlns:p14="http://schemas.microsoft.com/office/powerpoint/2010/main" xmlns:com="http://schemas.openxmlformats.org/drawingml/2006/compatibility" xmlns:pvml="urn:schemas-microsoft-com:office:powerpoint" xmlns:v="urn:schemas-microsoft-com:vml" xmlns:o="urn:schemas-microsoft-com:office:office" xmlns:dgm="http://schemas.openxmlformats.org/drawingml/2006/diagram" xmlns:c="http://schemas.openxmlformats.org/drawingml/2006/chart" xmlns:mv="urn:schemas-microsoft-com:mac:vml" xmlns:mc="http://schemas.openxmlformats.org/markup-compatibility/2006" xmlns="" r:id="rId35" roundtripDataSignature="AMtx7mjFLyGGbKtZ6MKWK8o6r1g77If8Vw=="/>
     </p:ext>
   </p:extLst>
 </p:presentation>
@@ -651,657 +651,6 @@
     </pc:docChg>
   </pc:docChgLst>
 </pc:chgInfo>
-</file>
-
-<file path=ppt/ink/ink1.xml><?xml version="1.0" encoding="utf-8"?>
-<inkml:ink xmlns:inkml="http://www.w3.org/2003/InkML">
-  <inkml:definitions>
-    <inkml:context xml:id="ctx0">
-      <inkml:inkSource xml:id="inkSrc0">
-        <inkml:traceFormat>
-          <inkml:channel name="X" type="integer" min="-2.14748E9" max="2.14748E9" units="cm"/>
-          <inkml:channel name="Y" type="integer" min="-2.14748E9" max="2.14748E9" units="cm"/>
-          <inkml:channel name="F" type="integer" max="32767" units="dev"/>
-          <inkml:channel name="OA" type="integer" max="360" units="deg"/>
-          <inkml:channel name="OE" type="integer" max="90" units="deg"/>
-        </inkml:traceFormat>
-        <inkml:channelProperties>
-          <inkml:channelProperty channel="X" name="resolution" value="1000" units="1/cm"/>
-          <inkml:channelProperty channel="Y" name="resolution" value="1000" units="1/cm"/>
-          <inkml:channelProperty channel="F" name="resolution" value="0" units="1/dev"/>
-          <inkml:channelProperty channel="OA" name="resolution" value="1000" units="1/deg"/>
-          <inkml:channelProperty channel="OE" name="resolution" value="1000" units="1/deg"/>
-        </inkml:channelProperties>
-      </inkml:inkSource>
-      <inkml:timestamp xml:id="ts0" timeString="2025-06-11T00:43:25.175"/>
-    </inkml:context>
-    <inkml:brush xml:id="br0">
-      <inkml:brushProperty name="width" value="0.035" units="cm"/>
-      <inkml:brushProperty name="height" value="0.035" units="cm"/>
-    </inkml:brush>
-  </inkml:definitions>
-  <inkml:trace contextRef="#ctx0" brushRef="#br0">23 452 96 0 0,'-12'-4'-198'0'0,"2"4"4098"0"0,28-3 1075 0 0,16-3-4056 0 0,-1 2 0 0 0,1 1 1 0 0,0 2-1 0 0,52 4 0 0 0,303 24 2342 0 0,-129-4-2345 0 0,-137-17-753 0 0,0-5 0 0 0,158-18 0 0 0,20 16 703 0 0,-24 3 164 0 0,-95-7 992 0 0,41-4-905 0 0,387-15 1993 0 0,-214 15-2657 0 0,35 10 774 0 0,-175 4-782 0 0,598-22-199 0 0,-360 6 1024 0 0,-500 9-1168 0 0,1 0 0 0 0,0-1-1 0 0,1 0 1 0 0,-1 1 0 0 0,0-2-1 0 0,-6-4 1 0 0,-2-2 2 0 0,-51-33-87 0 0,3-3 0 0 0,2-3 0 0 0,2-2 1 0 0,-68-79-1 0 0,74 78-249 0 0,51 52 217 0 0,2 4-96 0 0,1 1 107 0 0,-1 0 0 0 0,1 0 0 0 0,-1 0 1 0 0,-1 0-1 0 0,3 9 0 0 0,-3-11 6 0 0,2 11-1 0 0,0 0 0 0 0,-1 1 0 0 0,-1-1 0 0 0,0 0-1 0 0,-1 1 1 0 0,0-1 0 0 0,-1 1 0 0 0,-4 17 0 0 0,-31 116-188 0 0,25-110 92 0 0,-8 19-170 0 0,-41 85 0 0 0,40-97 310 0 0,20-45-43 0 0,0 0-1 0 0,0 0 1 0 0,0-1 0 0 0,0 1 0 0 0,0 0-1 0 0,1 0 1 0 0,-1 0 0 0 0,0 0 0 0 0,0 0 0 0 0,0 0-1 0 0,0 0 1 0 0,0 0 0 0 0,0 0 0 0 0,0 0 0 0 0,0 0-1 0 0,0 0 1 0 0,1 0 0 0 0,-1-1 0 0 0,0 1 0 0 0,0 0-1 0 0,0 0 1 0 0,0 0 0 0 0,0 0 0 0 0,0 0 0 0 0,0 0-1 0 0,1 0 1 0 0,-1 0 0 0 0,0 0 0 0 0,0 0 0 0 0,0 0-1 0 0,0 0 1 0 0,0 0 0 0 0,0 1 0 0 0,0-1 0 0 0,1 0-1 0 0,-1 0 1 0 0,0 0 0 0 0,0 0 0 0 0,0 0 0 0 0,0 0-1 0 0,0 0 1 0 0,0 0 0 0 0,0 0 0 0 0,0 0-1 0 0,0 0 1 0 0,0 0 0 0 0,1 0 0 0 0,-1 1 0 0 0,0-1-1 0 0,0 0 1 0 0,0 0 0 0 0,0 0 0 0 0,0 0 0 0 0,0 0-1 0 0,0 0 1 0 0,0 0 0 0 0,0 1 0 0 0,0-1 0 0 0,0 0-1 0 0,0 0 1 0 0,0 0 0 0 0,0 0 0 0 0,0 0 0 0 0,0 0-1 0 0,0 1 1 0 0,17-11 126 0 0,17-13 123 0 0,-12 6-102 0 0,289-210 2383 0 0,-311 227-2584 0 0,0 0 0 0 0,0 0 1 0 0,1 0-1 0 0,-1 0 0 0 0,0 0 0 0 0,0 0 1 0 0,0 0-1 0 0,1 0 0 0 0,-1 0 0 0 0,0 0 1 0 0,0 0-1 0 0,0 0 0 0 0,1 0 0 0 0,-1 0 1 0 0,0 0-1 0 0,0 0 0 0 0,0 0 0 0 0,1 0 0 0 0,-1 0 1 0 0,0 1-1 0 0,0-1 0 0 0,0 0 0 0 0,0 0 1 0 0,0 0-1 0 0,1 0 0 0 0,-1 0 0 0 0,0 1 1 0 0,0-1-1 0 0,0 0 0 0 0,0 0 0 0 0,0 0 1 0 0,0 1-1 0 0,0-1 0 0 0,0 0 0 0 0,0 0 1 0 0,1 0-1 0 0,-1 0 0 0 0,0 1 0 0 0,0-1 0 0 0,0 0 1 0 0,0 0-1 0 0,0 0 0 0 0,0 1 0 0 0,0-1 1 0 0,0 0-1 0 0,-1 0 0 0 0,1 0 0 0 0,0 1 1 0 0,0-1-1 0 0,0 0 0 0 0,0 0 0 0 0,0 0 1 0 0,0 1-1 0 0,0-1 0 0 0,0 0 0 0 0,-1 0 0 0 0,-2 27-9292 0 0,-4 10-2663 0 0,3-19 7867 0 0,-9 24 356 0 0,11-35 3447 0 0</inkml:trace>
-</inkml:ink>
-</file>
-
-<file path=ppt/ink/ink10.xml><?xml version="1.0" encoding="utf-8"?>
-<inkml:ink xmlns:inkml="http://www.w3.org/2003/InkML">
-  <inkml:definitions>
-    <inkml:context xml:id="ctx0">
-      <inkml:inkSource xml:id="inkSrc0">
-        <inkml:traceFormat>
-          <inkml:channel name="X" type="integer" min="-2.14748E9" max="2.14748E9" units="cm"/>
-          <inkml:channel name="Y" type="integer" min="-2.14748E9" max="2.14748E9" units="cm"/>
-          <inkml:channel name="F" type="integer" max="32767" units="dev"/>
-          <inkml:channel name="OA" type="integer" max="360" units="deg"/>
-          <inkml:channel name="OE" type="integer" max="90" units="deg"/>
-        </inkml:traceFormat>
-        <inkml:channelProperties>
-          <inkml:channelProperty channel="X" name="resolution" value="1000" units="1/cm"/>
-          <inkml:channelProperty channel="Y" name="resolution" value="1000" units="1/cm"/>
-          <inkml:channelProperty channel="F" name="resolution" value="0" units="1/dev"/>
-          <inkml:channelProperty channel="OA" name="resolution" value="1000" units="1/deg"/>
-          <inkml:channelProperty channel="OE" name="resolution" value="1000" units="1/deg"/>
-        </inkml:channelProperties>
-      </inkml:inkSource>
-      <inkml:timestamp xml:id="ts0" timeString="2025-06-11T00:43:33.006"/>
-    </inkml:context>
-    <inkml:brush xml:id="br0">
-      <inkml:brushProperty name="width" value="0.035" units="cm"/>
-      <inkml:brushProperty name="height" value="0.035" units="cm"/>
-    </inkml:brush>
-  </inkml:definitions>
-  <inkml:trace contextRef="#ctx0" brushRef="#br0">1 36 68 0 0,'15'-30'1623'0'0,"-4"25"2567"0"0,-8 46-2396 0 0,-14 100-717 0 0,6-109-1643 0 0,2-1 1 0 0,1 1-1 0 0,1-1 0 0 0,2 1 0 0 0,8 52 0 0 0,-7-76 160 0 0,0 0-1 0 0,1-1 1 0 0,0 1-1 0 0,0-1 1 0 0,1 1 0 0 0,8 11-1 0 0,-10-15 263 0 0,0-1-1 0 0,1 0 1 0 0,0 0-1 0 0,-1 0 1 0 0,1 0 0 0 0,0 0-1 0 0,1-1 1 0 0,-1 1-1 0 0,0-1 1 0 0,1 0-1 0 0,-1 0 1 0 0,1 0 0 0 0,0 0-1 0 0,-1-1 1 0 0,8 2-1 0 0,-1-2-40 0 0</inkml:trace>
-</inkml:ink>
-</file>
-
-<file path=ppt/ink/ink11.xml><?xml version="1.0" encoding="utf-8"?>
-<inkml:ink xmlns:inkml="http://www.w3.org/2003/InkML">
-  <inkml:definitions>
-    <inkml:context xml:id="ctx0">
-      <inkml:inkSource xml:id="inkSrc0">
-        <inkml:traceFormat>
-          <inkml:channel name="X" type="integer" min="-2.14748E9" max="2.14748E9" units="cm"/>
-          <inkml:channel name="Y" type="integer" min="-2.14748E9" max="2.14748E9" units="cm"/>
-          <inkml:channel name="F" type="integer" max="32767" units="dev"/>
-          <inkml:channel name="OA" type="integer" max="360" units="deg"/>
-          <inkml:channel name="OE" type="integer" max="90" units="deg"/>
-        </inkml:traceFormat>
-        <inkml:channelProperties>
-          <inkml:channelProperty channel="X" name="resolution" value="1000" units="1/cm"/>
-          <inkml:channelProperty channel="Y" name="resolution" value="1000" units="1/cm"/>
-          <inkml:channelProperty channel="F" name="resolution" value="0" units="1/dev"/>
-          <inkml:channelProperty channel="OA" name="resolution" value="1000" units="1/deg"/>
-          <inkml:channelProperty channel="OE" name="resolution" value="1000" units="1/deg"/>
-        </inkml:channelProperties>
-      </inkml:inkSource>
-      <inkml:timestamp xml:id="ts0" timeString="2025-06-11T00:43:33.287"/>
-    </inkml:context>
-    <inkml:brush xml:id="br0">
-      <inkml:brushProperty name="width" value="0.035" units="cm"/>
-      <inkml:brushProperty name="height" value="0.035" units="cm"/>
-    </inkml:brush>
-  </inkml:definitions>
-  <inkml:trace contextRef="#ctx0" brushRef="#br0">0 17 132 0 0,'1'-2'83'0'0,"0"1"0"0"0,0 0 0 0 0,0-1 0 0 0,1 1 0 0 0,-1 0 0 0 0,0 0 0 0 0,0 0 1 0 0,1 0-1 0 0,-1 0 0 0 0,1 0 0 0 0,-1 0 0 0 0,1 1 0 0 0,-1-1 0 0 0,4 0 0 0 0,-4 1 17 0 0,0 0 0 0 0,-1 0-1 0 0,1 0 1 0 0,0 0 0 0 0,0 0-1 0 0,-1 0 1 0 0,1 0 0 0 0,0 1 0 0 0,0-1-1 0 0,-1 0 1 0 0,1 0 0 0 0,0 1 0 0 0,0-1-1 0 0,-1 1 1 0 0,1-1 0 0 0,0 1 0 0 0,-1-1-1 0 0,1 1 1 0 0,-1-1 0 0 0,1 1 0 0 0,-1-1-1 0 0,1 2 1 0 0,2 3 237 0 0,0 0-1 0 0,0 0 1 0 0,-1 1-1 0 0,0-1 1 0 0,0 1-1 0 0,2 10 1 0 0,1 10 75 0 0,-1-1 1 0 0,-2 1-1 0 0,-2 47 1 0 0,0-39-1081 0 0,5 47 1 0 0,-5-80 581 0 0,0 0 0 0 0,0 0 0 0 0,0 0-1 0 0,0 0 1 0 0,0 0 0 0 0,1 0 0 0 0,-1-1 0 0 0,0 1-1 0 0,0 0 1 0 0,1 0 0 0 0,-1 0 0 0 0,1 0-1 0 0,-1 0 1 0 0,1-1 0 0 0,-1 1 0 0 0,1 0 0 0 0,-1 0-1 0 0,1-1 1 0 0,0 1 0 0 0,-1-1 0 0 0,1 1-1 0 0,0 0 1 0 0,0-1 0 0 0,-1 1 0 0 0,1-1 0 0 0,0 1-1 0 0,0-1 1 0 0,0 0 0 0 0,0 1 0 0 0,0-1 0 0 0,-1 0-1 0 0,1 0 1 0 0,0 0 0 0 0,0 0 0 0 0,0 1-1 0 0,0-1 1 0 0,0 0 0 0 0,0 0 0 0 0,0-1 0 0 0,0 1-1 0 0,0 0 1 0 0,0 0 0 0 0,0 0 0 0 0,1-1-1 0 0,3-1-228 0 0,1-1-1 0 0,-1 1 0 0 0,0-1 1 0 0,0 1-1 0 0,0-2 0 0 0,4-3 0 0 0,-1 2 111 0 0</inkml:trace>
-</inkml:ink>
-</file>
-
-<file path=ppt/ink/ink12.xml><?xml version="1.0" encoding="utf-8"?>
-<inkml:ink xmlns:inkml="http://www.w3.org/2003/InkML">
-  <inkml:definitions>
-    <inkml:context xml:id="ctx0">
-      <inkml:inkSource xml:id="inkSrc0">
-        <inkml:traceFormat>
-          <inkml:channel name="X" type="integer" min="-2.14748E9" max="2.14748E9" units="cm"/>
-          <inkml:channel name="Y" type="integer" min="-2.14748E9" max="2.14748E9" units="cm"/>
-          <inkml:channel name="F" type="integer" max="32767" units="dev"/>
-          <inkml:channel name="OA" type="integer" max="360" units="deg"/>
-          <inkml:channel name="OE" type="integer" max="90" units="deg"/>
-        </inkml:traceFormat>
-        <inkml:channelProperties>
-          <inkml:channelProperty channel="X" name="resolution" value="1000" units="1/cm"/>
-          <inkml:channelProperty channel="Y" name="resolution" value="1000" units="1/cm"/>
-          <inkml:channelProperty channel="F" name="resolution" value="0" units="1/dev"/>
-          <inkml:channelProperty channel="OA" name="resolution" value="1000" units="1/deg"/>
-          <inkml:channelProperty channel="OE" name="resolution" value="1000" units="1/deg"/>
-        </inkml:channelProperties>
-      </inkml:inkSource>
-      <inkml:timestamp xml:id="ts0" timeString="2025-06-11T00:43:33.587"/>
-    </inkml:context>
-    <inkml:brush xml:id="br0">
-      <inkml:brushProperty name="width" value="0.035" units="cm"/>
-      <inkml:brushProperty name="height" value="0.035" units="cm"/>
-    </inkml:brush>
-  </inkml:definitions>
-  <inkml:trace contextRef="#ctx0" brushRef="#br0">0 1 180 0 0,'2'0'126'0'0,"0"0"0"0"0,0 0 0 0 0,-1-1 0 0 0,1 1 0 0 0,0 0 1 0 0,0 0-1 0 0,-1 1 0 0 0,1-1 0 0 0,0 0 0 0 0,0 1 0 0 0,-1-1 0 0 0,1 1 0 0 0,0-1 0 0 0,0 1 0 0 0,-1 0 1 0 0,1 0-1 0 0,-1-1 0 0 0,1 1 0 0 0,-1 0 0 0 0,1 1 0 0 0,-1-1 0 0 0,0 0 0 0 0,1 0 0 0 0,-1 1 0 0 0,0-1 0 0 0,0 0 1 0 0,0 1-1 0 0,0-1 0 0 0,0 1 0 0 0,0-1 0 0 0,0 1 0 0 0,0 2 0 0 0,5 8 520 0 0,-1 1 1 0 0,-1 0-1 0 0,5 19 0 0 0,-2-6-206 0 0,0-3-150 0 0,-1 0-1 0 0,-1 0 1 0 0,-2 0 0 0 0,2 36 0 0 0,-3-29-1112 0 0,12 56 0 0 0,-14-85 695 0 0,0 1 1 0 0,0-1-1 0 0,0 1 1 0 0,1-1-1 0 0,-1 1 1 0 0,1-1 0 0 0,-1 1-1 0 0,1-1 1 0 0,0 0-1 0 0,-1 1 1 0 0,1-1-1 0 0,0 0 1 0 0,0 0-1 0 0,0 1 1 0 0,0-1 0 0 0,0 0-1 0 0,0 0 1 0 0,0 0-1 0 0,0 0 1 0 0,1 0-1 0 0,-1 0 1 0 0,0-1-1 0 0,1 1 1 0 0,-1 0 0 0 0,0-1-1 0 0,1 1 1 0 0,-1-1-1 0 0,1 1 1 0 0,-1-1-1 0 0,1 1 1 0 0,-1-1-1 0 0,1 0 1 0 0,-1 0 0 0 0,1 0-1 0 0,-1 0 1 0 0,1 0-1 0 0,-1 0 1 0 0,1-1-1 0 0,-1 1 1 0 0,1 0-1 0 0,-1-1 1 0 0,1 1 0 0 0,-1-1-1 0 0,1 1 1 0 0,-1-1-1 0 0,0 0 1 0 0,1 0-1 0 0,-1 1 1 0 0,0-1-1 0 0,0 0 1 0 0,0 0 0 0 0,1 0-1 0 0,0-2 1 0 0,6-2-105 0 0</inkml:trace>
-</inkml:ink>
-</file>
-
-<file path=ppt/ink/ink13.xml><?xml version="1.0" encoding="utf-8"?>
-<inkml:ink xmlns:inkml="http://www.w3.org/2003/InkML">
-  <inkml:definitions>
-    <inkml:context xml:id="ctx0">
-      <inkml:inkSource xml:id="inkSrc0">
-        <inkml:traceFormat>
-          <inkml:channel name="X" type="integer" min="-2.14748E9" max="2.14748E9" units="cm"/>
-          <inkml:channel name="Y" type="integer" min="-2.14748E9" max="2.14748E9" units="cm"/>
-          <inkml:channel name="F" type="integer" max="32767" units="dev"/>
-          <inkml:channel name="OA" type="integer" max="360" units="deg"/>
-          <inkml:channel name="OE" type="integer" max="90" units="deg"/>
-        </inkml:traceFormat>
-        <inkml:channelProperties>
-          <inkml:channelProperty channel="X" name="resolution" value="1000" units="1/cm"/>
-          <inkml:channelProperty channel="Y" name="resolution" value="1000" units="1/cm"/>
-          <inkml:channelProperty channel="F" name="resolution" value="0" units="1/dev"/>
-          <inkml:channelProperty channel="OA" name="resolution" value="1000" units="1/deg"/>
-          <inkml:channelProperty channel="OE" name="resolution" value="1000" units="1/deg"/>
-        </inkml:channelProperties>
-      </inkml:inkSource>
-      <inkml:timestamp xml:id="ts0" timeString="2025-06-11T00:43:33.867"/>
-    </inkml:context>
-    <inkml:brush xml:id="br0">
-      <inkml:brushProperty name="width" value="0.035" units="cm"/>
-      <inkml:brushProperty name="height" value="0.035" units="cm"/>
-    </inkml:brush>
-  </inkml:definitions>
-  <inkml:trace contextRef="#ctx0" brushRef="#br0">1 1 164 0 0,'1'0'107'0'0,"0"0"-1"0"0,0 1 1 0 0,0-1 0 0 0,1 0-1 0 0,-1 1 1 0 0,0-1 0 0 0,0 1-1 0 0,0 0 1 0 0,0-1 0 0 0,0 1 0 0 0,0 0-1 0 0,0 0 1 0 0,-1 0 0 0 0,1 0-1 0 0,0 0 1 0 0,0 0 0 0 0,-1 0-1 0 0,1 0 1 0 0,0 0 0 0 0,-1 0-1 0 0,1 0 1 0 0,-1 0 0 0 0,1 0-1 0 0,-1 0 1 0 0,0 0 0 0 0,1 1-1 0 0,-1-1 1 0 0,0 0 0 0 0,0 2-1 0 0,4 45 2999 0 0,-3-34-2643 0 0,5 76 1181 0 0,-5-47-1159 0 0,2-1-1 0 0,2 1 0 0 0,1-1 1 0 0,22 73-1 0 0,-27-113-677 0 0,0 1 0 0 0,0-1 0 0 0,0 1 0 0 0,0-1-1 0 0,0 1 1 0 0,1-1 0 0 0,-1 1 0 0 0,1-1 0 0 0,-1 0 0 0 0,1 0 0 0 0,0 0 0 0 0,0 0-1 0 0,0 0 1 0 0,0 0 0 0 0,0-1 0 0 0,0 1 0 0 0,1-1 0 0 0,-1 1 0 0 0,0-1 0 0 0,1 0 0 0 0,-1 0-1 0 0,1 0 1 0 0,-1 0 0 0 0,1-1 0 0 0,0 1 0 0 0,3 0 0 0 0,-1-1-137 0 0,-1-1 0 0 0,1 1 0 0 0,-1-1 0 0 0,1 0 1 0 0,-1 0-1 0 0,0-1 0 0 0,1 1 0 0 0,-1-1 0 0 0,0 0 0 0 0,0 0 0 0 0,0 0 0 0 0,-1-1 1 0 0,1 1-1 0 0,0-1 0 0 0,3-4 0 0 0,2-1 75 0 0</inkml:trace>
-</inkml:ink>
-</file>
-
-<file path=ppt/ink/ink14.xml><?xml version="1.0" encoding="utf-8"?>
-<inkml:ink xmlns:inkml="http://www.w3.org/2003/InkML">
-  <inkml:definitions>
-    <inkml:context xml:id="ctx0">
-      <inkml:inkSource xml:id="inkSrc0">
-        <inkml:traceFormat>
-          <inkml:channel name="X" type="integer" min="-2.14748E9" max="2.14748E9" units="cm"/>
-          <inkml:channel name="Y" type="integer" min="-2.14748E9" max="2.14748E9" units="cm"/>
-          <inkml:channel name="F" type="integer" max="32767" units="dev"/>
-          <inkml:channel name="OA" type="integer" max="360" units="deg"/>
-          <inkml:channel name="OE" type="integer" max="90" units="deg"/>
-        </inkml:traceFormat>
-        <inkml:channelProperties>
-          <inkml:channelProperty channel="X" name="resolution" value="1000" units="1/cm"/>
-          <inkml:channelProperty channel="Y" name="resolution" value="1000" units="1/cm"/>
-          <inkml:channelProperty channel="F" name="resolution" value="0" units="1/dev"/>
-          <inkml:channelProperty channel="OA" name="resolution" value="1000" units="1/deg"/>
-          <inkml:channelProperty channel="OE" name="resolution" value="1000" units="1/deg"/>
-        </inkml:channelProperties>
-      </inkml:inkSource>
-      <inkml:timestamp xml:id="ts0" timeString="2025-06-11T00:43:34.165"/>
-    </inkml:context>
-    <inkml:brush xml:id="br0">
-      <inkml:brushProperty name="width" value="0.035" units="cm"/>
-      <inkml:brushProperty name="height" value="0.035" units="cm"/>
-    </inkml:brush>
-  </inkml:definitions>
-  <inkml:trace contextRef="#ctx0" brushRef="#br0">1 0 20 0 0,'3'3'283'0'0,"1"0"1"0"0,-1 0-1 0 0,0 0 0 0 0,0 1 0 0 0,0-1 1 0 0,0 1-1 0 0,-1-1 0 0 0,0 1 1 0 0,1 0-1 0 0,-1 0 0 0 0,-1 0 0 0 0,1 0 1 0 0,-1 1-1 0 0,2 5 0 0 0,13 73 2683 0 0,-12-53-2702 0 0,3 15 315 0 0,12 59 515 0 0,-17-94-1160 0 0,1 0 1 0 0,0 0 0 0 0,1 0 0 0 0,0 0 0 0 0,1-1-1 0 0,0 0 1 0 0,9 12 0 0 0,-13-19-78 0 0,0-1 0 0 0,1 0 0 0 0,-1 1 0 0 0,0-1 0 0 0,1 0 0 0 0,0 0 0 0 0,-1 0 0 0 0,1 0-1 0 0,-1 0 1 0 0,1-1 0 0 0,0 1 0 0 0,0 0 0 0 0,-1-1 0 0 0,1 0 0 0 0,0 1 0 0 0,0-1 0 0 0,0 0 0 0 0,0 0 0 0 0,-1 0 0 0 0,1 0 0 0 0,0 0 0 0 0,0 0 0 0 0,0 0-1 0 0,0-1 1 0 0,-1 1 0 0 0,1-1 0 0 0,0 1 0 0 0,0-1 0 0 0,-1 0 0 0 0,1 0 0 0 0,0 1 0 0 0,-1-1 0 0 0,1 0 0 0 0,-1-1 0 0 0,1 1 0 0 0,-1 0 0 0 0,3-3-1 0 0,6-5-572 0 0,1-1 0 0 0,-2 0-1 0 0,15-19 1 0 0,-20 25 701 0 0,6-9-226 0 0</inkml:trace>
-</inkml:ink>
-</file>
-
-<file path=ppt/ink/ink15.xml><?xml version="1.0" encoding="utf-8"?>
-<inkml:ink xmlns:inkml="http://www.w3.org/2003/InkML">
-  <inkml:definitions>
-    <inkml:context xml:id="ctx0">
-      <inkml:inkSource xml:id="inkSrc0">
-        <inkml:traceFormat>
-          <inkml:channel name="X" type="integer" min="-2.14748E9" max="2.14748E9" units="cm"/>
-          <inkml:channel name="Y" type="integer" min="-2.14748E9" max="2.14748E9" units="cm"/>
-          <inkml:channel name="F" type="integer" max="32767" units="dev"/>
-          <inkml:channel name="OA" type="integer" max="360" units="deg"/>
-          <inkml:channel name="OE" type="integer" max="90" units="deg"/>
-        </inkml:traceFormat>
-        <inkml:channelProperties>
-          <inkml:channelProperty channel="X" name="resolution" value="1000" units="1/cm"/>
-          <inkml:channelProperty channel="Y" name="resolution" value="1000" units="1/cm"/>
-          <inkml:channelProperty channel="F" name="resolution" value="0" units="1/dev"/>
-          <inkml:channelProperty channel="OA" name="resolution" value="1000" units="1/deg"/>
-          <inkml:channelProperty channel="OE" name="resolution" value="1000" units="1/deg"/>
-        </inkml:channelProperties>
-      </inkml:inkSource>
-      <inkml:timestamp xml:id="ts0" timeString="2025-06-11T00:43:34.386"/>
-    </inkml:context>
-    <inkml:brush xml:id="br0">
-      <inkml:brushProperty name="width" value="0.035" units="cm"/>
-      <inkml:brushProperty name="height" value="0.035" units="cm"/>
-    </inkml:brush>
-  </inkml:definitions>
-  <inkml:trace contextRef="#ctx0" brushRef="#br0">4 0 88 0 0,'3'4'225'0'0,"-2"0"-1"0"0,1 0 1 0 0,0 0 0 0 0,-1 0-1 0 0,1 0 1 0 0,-1 0 0 0 0,0 0-1 0 0,-1 0 1 0 0,1 0-1 0 0,-1 0 1 0 0,0 9 0 0 0,-6 55 2649 0 0,2-32-1297 0 0,1 12-1037 0 0,-1 70 513 0 0,4-106-1139 0 0,1 0 0 0 0,1 0 0 0 0,0 0 0 0 0,1 0 0 0 0,0-1-1 0 0,1 1 1 0 0,7 17 0 0 0,-9-26-102 0 0,0-1 0 0 0,1 1 0 0 0,-1 0 0 0 0,0-1 0 0 0,1 1 0 0 0,-1-1 0 0 0,1 0 0 0 0,0 0 0 0 0,0 0 0 0 0,0 0 0 0 0,0 0 0 0 0,0-1 0 0 0,0 1 0 0 0,0-1 0 0 0,0 0 0 0 0,1 0 0 0 0,-1 0 0 0 0,1 0 0 0 0,-1-1 0 0 0,0 1 0 0 0,1-1 0 0 0,-1 0 0 0 0,1 0 0 0 0,-1 0 0 0 0,1 0 0 0 0,-1-1 0 0 0,1 1 0 0 0,-1-1 0 0 0,0 0 0 0 0,1 0 0 0 0,-1-1 0 0 0,0 1 0 0 0,0 0 0 0 0,0-1 0 0 0,0 0 0 0 0,0 0 0 0 0,0 0 0 0 0,0 0 0 0 0,-1 0 0 0 0,1-1 0 0 0,2-2 0 0 0,2-4-27 0 0</inkml:trace>
-</inkml:ink>
-</file>
-
-<file path=ppt/ink/ink16.xml><?xml version="1.0" encoding="utf-8"?>
-<inkml:ink xmlns:inkml="http://www.w3.org/2003/InkML">
-  <inkml:definitions>
-    <inkml:context xml:id="ctx0">
-      <inkml:inkSource xml:id="inkSrc0">
-        <inkml:traceFormat>
-          <inkml:channel name="X" type="integer" min="-2.14748E9" max="2.14748E9" units="cm"/>
-          <inkml:channel name="Y" type="integer" min="-2.14748E9" max="2.14748E9" units="cm"/>
-          <inkml:channel name="F" type="integer" max="32767" units="dev"/>
-          <inkml:channel name="OA" type="integer" max="360" units="deg"/>
-          <inkml:channel name="OE" type="integer" max="90" units="deg"/>
-        </inkml:traceFormat>
-        <inkml:channelProperties>
-          <inkml:channelProperty channel="X" name="resolution" value="1000" units="1/cm"/>
-          <inkml:channelProperty channel="Y" name="resolution" value="1000" units="1/cm"/>
-          <inkml:channelProperty channel="F" name="resolution" value="0" units="1/dev"/>
-          <inkml:channelProperty channel="OA" name="resolution" value="1000" units="1/deg"/>
-          <inkml:channelProperty channel="OE" name="resolution" value="1000" units="1/deg"/>
-        </inkml:channelProperties>
-      </inkml:inkSource>
-      <inkml:timestamp xml:id="ts0" timeString="2025-06-11T00:43:34.634"/>
-    </inkml:context>
-    <inkml:brush xml:id="br0">
-      <inkml:brushProperty name="width" value="0.035" units="cm"/>
-      <inkml:brushProperty name="height" value="0.035" units="cm"/>
-    </inkml:brush>
-  </inkml:definitions>
-  <inkml:trace contextRef="#ctx0" brushRef="#br0">1 1 136 0 0,'9'8'502'0'0,"1"0"-1"0"0,-1 0 1 0 0,0 1 0 0 0,-1 1 0 0 0,0-1-1 0 0,-1 1 1 0 0,0 1 0 0 0,9 17 0 0 0,40 97 2774 0 0,-47-104-3002 0 0,36 129 1188 0 0,-10-29-3140 0 0,-27-101-87 0 0,0-1-1 0 0,0 1 0 0 0,22 32 0 0 0,-26-48 1170 0 0,-2 0 365 0 0</inkml:trace>
-</inkml:ink>
-</file>
-
-<file path=ppt/ink/ink17.xml><?xml version="1.0" encoding="utf-8"?>
-<inkml:ink xmlns:inkml="http://www.w3.org/2003/InkML">
-  <inkml:definitions>
-    <inkml:context xml:id="ctx0">
-      <inkml:inkSource xml:id="inkSrc0">
-        <inkml:traceFormat>
-          <inkml:channel name="X" type="integer" min="-2.14748E9" max="2.14748E9" units="cm"/>
-          <inkml:channel name="Y" type="integer" min="-2.14748E9" max="2.14748E9" units="cm"/>
-          <inkml:channel name="F" type="integer" max="32767" units="dev"/>
-          <inkml:channel name="OA" type="integer" max="360" units="deg"/>
-          <inkml:channel name="OE" type="integer" max="90" units="deg"/>
-        </inkml:traceFormat>
-        <inkml:channelProperties>
-          <inkml:channelProperty channel="X" name="resolution" value="1000" units="1/cm"/>
-          <inkml:channelProperty channel="Y" name="resolution" value="1000" units="1/cm"/>
-          <inkml:channelProperty channel="F" name="resolution" value="0" units="1/dev"/>
-          <inkml:channelProperty channel="OA" name="resolution" value="1000" units="1/deg"/>
-          <inkml:channelProperty channel="OE" name="resolution" value="1000" units="1/deg"/>
-        </inkml:channelProperties>
-      </inkml:inkSource>
-      <inkml:timestamp xml:id="ts0" timeString="2025-06-11T00:43:35.615"/>
-    </inkml:context>
-    <inkml:brush xml:id="br0">
-      <inkml:brushProperty name="width" value="0.035" units="cm"/>
-      <inkml:brushProperty name="height" value="0.035" units="cm"/>
-    </inkml:brush>
-  </inkml:definitions>
-  <inkml:trace contextRef="#ctx0" brushRef="#br0">175 1 24 0 0,'0'0'102'0'0,"0"0"0"0"0,-1 0 0 0 0,1 0 1 0 0,0 0-1 0 0,0 0 0 0 0,-1 0 0 0 0,1 0 0 0 0,0-1 0 0 0,-1 1 0 0 0,1 0 1 0 0,0 0-1 0 0,0 0 0 0 0,-1 0 0 0 0,1 0 0 0 0,0 0 0 0 0,-1 0 1 0 0,1 0-1 0 0,0 0 0 0 0,0 1 0 0 0,-1-1 0 0 0,1 0 0 0 0,0 0 0 0 0,-1 0 1 0 0,1 0-1 0 0,0 0 0 0 0,0 0 0 0 0,-1 1 0 0 0,1-1 0 0 0,0 0 0 0 0,0 0 1 0 0,-1 0-1 0 0,1 1 0 0 0,0-1 0 0 0,0 0 0 0 0,0 0 0 0 0,-1 1 1 0 0,1-1-1 0 0,0 0 0 0 0,0 0 0 0 0,0 1 0 0 0,0-1 0 0 0,0 0 0 0 0,0 0 1 0 0,0 1-1 0 0,0-1 0 0 0,0 0 0 0 0,-1 1 0 0 0,-10 16 1804 0 0,-19 129 1503 0 0,23-101-5571 0 0,-2 0 0 0 0,-20 59 0 0 0,27-98 1933 0 0,0 0 0 0 0,-1-1 0 0 0,0 1 1 0 0,0-1-1 0 0,0 0 0 0 0,0 1 0 0 0,-1-2 0 0 0,0 1 1 0 0,0 0-1 0 0,-1-1 0 0 0,1 1 0 0 0,-1-1 1 0 0,0-1-1 0 0,-10 7 0 0 0,2-4-67 0 0</inkml:trace>
-</inkml:ink>
-</file>
-
-<file path=ppt/ink/ink18.xml><?xml version="1.0" encoding="utf-8"?>
-<inkml:ink xmlns:inkml="http://www.w3.org/2003/InkML">
-  <inkml:definitions>
-    <inkml:context xml:id="ctx0">
-      <inkml:inkSource xml:id="inkSrc0">
-        <inkml:traceFormat>
-          <inkml:channel name="X" type="integer" min="-2.14748E9" max="2.14748E9" units="cm"/>
-          <inkml:channel name="Y" type="integer" min="-2.14748E9" max="2.14748E9" units="cm"/>
-          <inkml:channel name="F" type="integer" max="32767" units="dev"/>
-          <inkml:channel name="OA" type="integer" max="360" units="deg"/>
-          <inkml:channel name="OE" type="integer" max="90" units="deg"/>
-        </inkml:traceFormat>
-        <inkml:channelProperties>
-          <inkml:channelProperty channel="X" name="resolution" value="1000" units="1/cm"/>
-          <inkml:channelProperty channel="Y" name="resolution" value="1000" units="1/cm"/>
-          <inkml:channelProperty channel="F" name="resolution" value="0" units="1/dev"/>
-          <inkml:channelProperty channel="OA" name="resolution" value="1000" units="1/deg"/>
-          <inkml:channelProperty channel="OE" name="resolution" value="1000" units="1/deg"/>
-        </inkml:channelProperties>
-      </inkml:inkSource>
-      <inkml:timestamp xml:id="ts0" timeString="2025-06-11T00:42:29.473"/>
-    </inkml:context>
-    <inkml:brush xml:id="br0">
-      <inkml:brushProperty name="width" value="0.035" units="cm"/>
-      <inkml:brushProperty name="height" value="0.035" units="cm"/>
-    </inkml:brush>
-  </inkml:definitions>
-  <inkml:trace contextRef="#ctx0" brushRef="#br0">569 3715 184 0 0,'-9'20'1641'0'0,"8"-12"7435"0"0,-22-34-6913 0 0,15 5-1726 0 0,-15-41 146 0 0,2 0 0 0 0,-16-82 0 0 0,15 21-520 0 0,-43-281 42 0 0,18-116 66 0 0,29 278-225 0 0,5-439-231 0 0,14 454 280 0 0,24-170-106 0 0,-4 136 54 0 0,-17 177 67 0 0,9-173 86 0 0,-10 85-52 0 0,-3 168-21 0 0,0-2 36 0 0,0-1 0 0 0,0 0 0 0 0,-1 0 0 0 0,1 0 0 0 0,-2 0 0 0 0,-1-6 0 0 0,3 12 629 0 0,-31 38-59 0 0,-14 28-623 0 0,-9 16-26 0 0,-129 146 0 0 0,170-215 111 0 0,12-11-116 0 0,-1 0 0 0 0,1 0 1 0 0,0 0-1 0 0,-1 0 0 0 0,1 0 0 0 0,0 1 1 0 0,0-1-1 0 0,0 0 0 0 0,0 1 0 0 0,0-1 1 0 0,1 1-1 0 0,-1-1 0 0 0,0 1 0 0 0,0 1 1 0 0,2-1-1 0 0,0-1 0 0 0,0 0 0 0 0,1-1 1 0 0,-1 1-1 0 0,1 0 0 0 0,-1 0 0 0 0,1 0 1 0 0,-1-1-1 0 0,1 1 0 0 0,-1-1 0 0 0,1 1 1 0 0,-1-1-1 0 0,1 0 0 0 0,0 0 0 0 0,-1 1 1 0 0,1-1-1 0 0,-1 0 0 0 0,1-1 1 0 0,2 1-1 0 0,24 2-3 0 0,0-2 0 0 0,1 0 0 0 0,-1-2 1 0 0,0-1-1 0 0,0-1 0 0 0,32-10 0 0 0,-46 10 39 0 0,-1 0 0 0 0,0 0 0 0 0,0-1 0 0 0,-1-1 0 0 0,0 0 0 0 0,0-1 0 0 0,0 0 0 0 0,-1-1 0 0 0,1 0 0 0 0,-2-1 0 0 0,0 0 0 0 0,0-1 0 0 0,0 0 0 0 0,13-19 0 0 0,-21 26 29 0 0,-1 1 0 0 0,0 0 0 0 0,0 0-1 0 0,0-1 1 0 0,0 1 0 0 0,0 0 0 0 0,-1-1 0 0 0,1 1 0 0 0,-1-1 0 0 0,1 1 0 0 0,-1-1 0 0 0,0 1 0 0 0,0-1 0 0 0,0 1-1 0 0,-1-1 1 0 0,1 1 0 0 0,0-1 0 0 0,-1 1 0 0 0,0 0 0 0 0,1-1 0 0 0,-3-2 0 0 0,1 0 104 0 0,-1 0 1 0 0,0 0-1 0 0,0 1 1 0 0,-1-1-1 0 0,1 1 1 0 0,-1 0-1 0 0,0 0 0 0 0,0 0 1 0 0,-7-4-1 0 0,2 2-390 0 0,1 0 0 0 0,-1 1-1 0 0,0 0 1 0 0,0 1 0 0 0,0 0-1 0 0,-1 0 1 0 0,1 1 0 0 0,-1 0-1 0 0,0 1 1 0 0,-17-3-1 0 0,25 5-103 0 0,-1 1 0 0 0,1-1 0 0 0,-1 0 0 0 0,1 1 0 0 0,0-1 0 0 0,-1 1 0 0 0,1 0 0 0 0,-1-1 0 0 0,1 1 0 0 0,0 1 0 0 0,0-1 0 0 0,-1 0 0 0 0,1 0 0 0 0,0 1 0 0 0,0-1 0 0 0,0 1 0 0 0,1 0 0 0 0,-1-1 0 0 0,-2 4 0 0 0,1 0-217 0 0,-1 0 0 0 0,1 0 0 0 0,1 0 0 0 0,-1 1 0 0 0,1-1 0 0 0,0 1 0 0 0,-3 11 0 0 0,1 6-305 0 0,1 0-1 0 0,1 0 0 0 0,1 27 1 0 0,1-49 862 0 0,0 24-280 0 0,2 1 39 0 0</inkml:trace>
-</inkml:ink>
-</file>
-
-<file path=ppt/ink/ink19.xml><?xml version="1.0" encoding="utf-8"?>
-<inkml:ink xmlns:inkml="http://www.w3.org/2003/InkML">
-  <inkml:definitions>
-    <inkml:context xml:id="ctx0">
-      <inkml:inkSource xml:id="inkSrc0">
-        <inkml:traceFormat>
-          <inkml:channel name="X" type="integer" min="-2.14748E9" max="2.14748E9" units="cm"/>
-          <inkml:channel name="Y" type="integer" min="-2.14748E9" max="2.14748E9" units="cm"/>
-          <inkml:channel name="F" type="integer" max="32767" units="dev"/>
-          <inkml:channel name="OA" type="integer" max="360" units="deg"/>
-          <inkml:channel name="OE" type="integer" max="90" units="deg"/>
-        </inkml:traceFormat>
-        <inkml:channelProperties>
-          <inkml:channelProperty channel="X" name="resolution" value="1000" units="1/cm"/>
-          <inkml:channelProperty channel="Y" name="resolution" value="1000" units="1/cm"/>
-          <inkml:channelProperty channel="F" name="resolution" value="0" units="1/dev"/>
-          <inkml:channelProperty channel="OA" name="resolution" value="1000" units="1/deg"/>
-          <inkml:channelProperty channel="OE" name="resolution" value="1000" units="1/deg"/>
-        </inkml:channelProperties>
-      </inkml:inkSource>
-      <inkml:timestamp xml:id="ts0" timeString="2025-06-11T00:42:30.718"/>
-    </inkml:context>
-    <inkml:brush xml:id="br0">
-      <inkml:brushProperty name="width" value="0.035" units="cm"/>
-      <inkml:brushProperty name="height" value="0.035" units="cm"/>
-    </inkml:brush>
-  </inkml:definitions>
-  <inkml:trace contextRef="#ctx0" brushRef="#br0">363 61 80 0 0,'-16'-42'1451'0'0,"15"40"-1187"0"0,1 1 0 0 0,-1 0 0 0 0,-1-1 0 0 0,1 1 0 0 0,0-1 0 0 0,0 1-1 0 0,0 0 1 0 0,-1 0 0 0 0,1 0 0 0 0,-1 0 0 0 0,1 0 0 0 0,-1 0 0 0 0,1 0 0 0 0,-3 0 0 0 0,3 1-139 0 0,0 0 1 0 0,0 0-1 0 0,-1 0 1 0 0,1 1-1 0 0,0-1 1 0 0,0 0-1 0 0,-1 1 1 0 0,1-1-1 0 0,0 1 1 0 0,0 0-1 0 0,0-1 1 0 0,0 1-1 0 0,0 0 1 0 0,0 0-1 0 0,0-1 1 0 0,0 1-1 0 0,0 0 1 0 0,0 0-1 0 0,0 0 1 0 0,0 0-1 0 0,1 0 0 0 0,-1 1 1 0 0,0-1-1 0 0,1 0 1 0 0,-1 0-1 0 0,1 0 1 0 0,-1 0-1 0 0,1 1 1 0 0,0-1-1 0 0,-1 2 1 0 0,-11 42 774 0 0,11-43-794 0 0,-10 74 785 0 0,3 1 0 0 0,2 93-1 0 0,2-45-273 0 0,-6 691 1000 0 0,76 159-1597 0 0,-50-819 172 0 0,44 278 493 0 0,-53-407-664 0 0,-2-1-184 0 0,-28-51 211 0 0,-14-28 220 0 0,3 2 158 0 0,-1 2 1 0 0,-3 1-1 0 0,-2 3 1 0 0,-67-62-1 0 0,106 106-375 0 0,-37-26 1022 0 0,36 25-928 0 0,0 1 1 0 0,0 0-1 0 0,0 0 1 0 0,0 0-1 0 0,0 0 0 0 0,0 0 1 0 0,0 0-1 0 0,0 0 1 0 0,0 1-1 0 0,0-1 1 0 0,0 1-1 0 0,-1 0 0 0 0,1 0 1 0 0,0-1-1 0 0,0 2 1 0 0,0-1-1 0 0,-5 0 1 0 0,7 1-105 0 0,0-1 0 0 0,-1 0 0 0 0,1 0 0 0 0,0 0 0 0 0,0 0 0 0 0,-1 1 0 0 0,1-1 0 0 0,0 0 0 0 0,0 0 1 0 0,0 0-1 0 0,-1 1 0 0 0,1-1 0 0 0,0 0 0 0 0,0 0 0 0 0,0 1 0 0 0,0-1 0 0 0,-1 0 0 0 0,1 1 0 0 0,0-1 0 0 0,0 0 0 0 0,0 0 1 0 0,0 1-1 0 0,0-1 0 0 0,0 0 0 0 0,0 1 0 0 0,0-1 0 0 0,0 0 0 0 0,0 0 0 0 0,0 1 0 0 0,0-1 0 0 0,0 0 0 0 0,0 1 0 0 0,0-1 1 0 0,0 0-1 0 0,1 1 0 0 0,-1-1 0 0 0,0 0 0 0 0,0 0 0 0 0,0 1 0 0 0,1-1 0 0 0,11 16 181 0 0,20 11-523 0 0,-16-16 278 0 0,1 0 0 0 0,0-2 1 0 0,1 0-1 0 0,-1 0 1 0 0,33 9-1 0 0,95 15 99 0 0,-59-16 28 0 0,-82-17-95 0 0,0 1 1 0 0,0 0 0 0 0,0 1 0 0 0,-1-1-1 0 0,1 0 1 0 0,0 1 0 0 0,0 0 0 0 0,-1 0 0 0 0,1 0-1 0 0,-1 1 1 0 0,0-1 0 0 0,1 1 0 0 0,-1 0-1 0 0,0-1 1 0 0,-1 2 0 0 0,1-1 0 0 0,0 0 0 0 0,-1 0-1 0 0,0 1 1 0 0,0-1 0 0 0,0 1 0 0 0,0 0-1 0 0,0 0 1 0 0,0 3 0 0 0,0 3-7 0 0,0 0 0 0 0,-1-1 1 0 0,0 1-1 0 0,-1 0 0 0 0,0 0 0 0 0,-1-1 1 0 0,0 1-1 0 0,0 0 0 0 0,-4 11 0 0 0,3-13-362 0 0,-17 57 856 0 0,2-37-2562 0 0,-9-9-5281 0 0</inkml:trace>
-</inkml:ink>
-</file>
-
-<file path=ppt/ink/ink2.xml><?xml version="1.0" encoding="utf-8"?>
-<inkml:ink xmlns:inkml="http://www.w3.org/2003/InkML">
-  <inkml:definitions>
-    <inkml:context xml:id="ctx0">
-      <inkml:inkSource xml:id="inkSrc0">
-        <inkml:traceFormat>
-          <inkml:channel name="X" type="integer" min="-2.14748E9" max="2.14748E9" units="cm"/>
-          <inkml:channel name="Y" type="integer" min="-2.14748E9" max="2.14748E9" units="cm"/>
-          <inkml:channel name="F" type="integer" max="32767" units="dev"/>
-          <inkml:channel name="OA" type="integer" max="360" units="deg"/>
-          <inkml:channel name="OE" type="integer" max="90" units="deg"/>
-        </inkml:traceFormat>
-        <inkml:channelProperties>
-          <inkml:channelProperty channel="X" name="resolution" value="1000" units="1/cm"/>
-          <inkml:channelProperty channel="Y" name="resolution" value="1000" units="1/cm"/>
-          <inkml:channelProperty channel="F" name="resolution" value="0" units="1/dev"/>
-          <inkml:channelProperty channel="OA" name="resolution" value="1000" units="1/deg"/>
-          <inkml:channelProperty channel="OE" name="resolution" value="1000" units="1/deg"/>
-        </inkml:channelProperties>
-      </inkml:inkSource>
-      <inkml:timestamp xml:id="ts0" timeString="2025-06-11T00:43:29.916"/>
-    </inkml:context>
-    <inkml:brush xml:id="br0">
-      <inkml:brushProperty name="width" value="0.035" units="cm"/>
-      <inkml:brushProperty name="height" value="0.035" units="cm"/>
-    </inkml:brush>
-  </inkml:definitions>
-  <inkml:trace contextRef="#ctx0" brushRef="#br0">251 476 132 0 0,'-23'6'5216'0'0,"20"-3"-4947"0"0,-1 1 1 0 0,1 1 0 0 0,0-1-1 0 0,0 0 1 0 0,1 1 0 0 0,-1-1-1 0 0,1 1 1 0 0,0 0-1 0 0,1 0 1 0 0,-1 0 0 0 0,-1 9-1 0 0,-7 64 857 0 0,8-51-869 0 0,-29 329 973 0 0,-49 343 251 0 0,52-544-1151 0 0,-14 247 0 0 0,39-279-218 0 0,14 141 1 0 0,-5-211-86 0 0,2 0 0 0 0,2-1 0 0 0,3 0 0 0 0,2-1 0 0 0,26 61 0 0 0,144 255 202 0 0,-155-319-206 0 0,1-2 0 0 0,3 0 0 0 0,2-3 0 0 0,1-1 0 0 0,55 48 0 0 0,-36-45-38 0 0,2-2 0 0 0,2-2-1 0 0,2-3 1 0 0,80 36 0 0 0,-50-35-21 0 0,1-3-1 0 0,147 35 0 0 0,-32-29 273 0 0,1-10 0 0 0,269 8 0 0 0,-351-39-260 0 0,-1-5 0 0 0,0-6 1 0 0,-1-5-1 0 0,178-46 1 0 0,-225 41-76 0 0,-1-3 1 0 0,-1-4 0 0 0,-1-3 0 0 0,111-63 0 0 0,-137 65 169 0 0,-2-3-1 0 0,-1-2 1 0 0,-1-1 0 0 0,-2-3 0 0 0,-1-1-1 0 0,-3-3 1 0 0,48-60 0 0 0,-67 74-3 0 0,-1-1 0 0 0,-2-1 0 0 0,-1-1 0 0 0,-1 0-1 0 0,-1 0 1 0 0,-2-2 0 0 0,-1 0 0 0 0,12-57 0 0 0,-20 73-97 0 0,-1 0 0 0 0,-1 1 1 0 0,0-1-1 0 0,-1 0 0 0 0,-1 0 0 0 0,-1 1 1 0 0,0-1-1 0 0,0 1 0 0 0,-2-1 1 0 0,0 1-1 0 0,-1 0 0 0 0,0 0 0 0 0,-1 1 1 0 0,-1-1-1 0 0,0 1 0 0 0,-1 1 0 0 0,0 0 1 0 0,-2 0-1 0 0,1 0 0 0 0,-20-18 0 0 0,3 7 62 0 0,-1 2-1 0 0,0 2 1 0 0,-2 0-1 0 0,-1 2 1 0 0,0 1 0 0 0,-48-20-1 0 0,-208-61 786 0 0,129 49-378 0 0,96 27-584 0 0,1-2 0 0 0,1-2 1 0 0,1-4-1 0 0,2-1 0 0 0,1-3 1 0 0,2-3-1 0 0,1-1 0 0 0,3-3 0 0 0,0-2 1 0 0,-64-76-1 0 0,98 98 38 0 0,0 0 1 0 0,1-1-1 0 0,1 0 1 0 0,1-1-1 0 0,2-1 1 0 0,-13-39-1 0 0,12 26 310 0 0,1 0-1 0 0,2-1 1 0 0,-4-68-1 0 0,13 72-152 0 0,1 1-1 0 0,2-1 1 0 0,2 1-1 0 0,1 0 0 0 0,1 0 1 0 0,22-53-1 0 0,6-30-246 0 0,-20 56-37 0 0,12-103-1 0 0,-26 136 221 0 0,0 0 0 0 0,-2 1 0 0 0,-1-1 0 0 0,-1 0 0 0 0,-1 1-1 0 0,-10-39 1 0 0,3 40 342 0 0,-1 0-1 0 0,0 0 0 0 0,-2 1 1 0 0,-1 0-1 0 0,-20-25 0 0 0,-20-36 418 0 0,22 29-622 0 0,-2 1 1 0 0,-56-67-1 0 0,66 94-70 0 0,-2 0 1 0 0,-1 2-1 0 0,-1 1 0 0 0,-1 1 0 0 0,-46-29 1 0 0,-173-82-480 0 0,207 117 332 0 0,0 2 0 0 0,-1 1 0 0 0,-1 3 0 0 0,-59-10 0 0 0,40 13 234 0 0,0 3 1 0 0,-118 3 0 0 0,144 6-7 0 0,0 1 0 0 0,0 2-1 0 0,0 2 1 0 0,1 1 0 0 0,0 2 0 0 0,-46 20 0 0 0,36-10-184 0 0,1 2 0 0 0,1 2 1 0 0,2 2-1 0 0,0 2 0 0 0,2 1 0 0 0,1 2 0 0 0,1 2 1 0 0,2 1-1 0 0,2 2 0 0 0,-31 43 0 0 0,-137 209-859 0 0,161-225-2759 0 0,3 0-3420 0 0,36-62 6820 0 0,0 0-1 0 0,0 0 1 0 0,0 0 0 0 0,0 0-1 0 0,0 0 1 0 0,0 0 0 0 0,1 0 0 0 0,-1 0-1 0 0,0 0 1 0 0,1 0 0 0 0,0 0-1 0 0,0 1 1 0 0,0-1 0 0 0,0 0-1 0 0,0 0 1 0 0,0 0 0 0 0,0 1 0 0 0,1-1-1 0 0,-1 0 1 0 0,1 3 0 0 0,2 0 34 0 0</inkml:trace>
-</inkml:ink>
-</file>
-
-<file path=ppt/ink/ink20.xml><?xml version="1.0" encoding="utf-8"?>
-<inkml:ink xmlns:inkml="http://www.w3.org/2003/InkML">
-  <inkml:definitions>
-    <inkml:context xml:id="ctx0">
-      <inkml:inkSource xml:id="inkSrc0">
-        <inkml:traceFormat>
-          <inkml:channel name="X" type="integer" min="-2.14748E9" max="2.14748E9" units="cm"/>
-          <inkml:channel name="Y" type="integer" min="-2.14748E9" max="2.14748E9" units="cm"/>
-          <inkml:channel name="F" type="integer" max="32767" units="dev"/>
-          <inkml:channel name="OA" type="integer" max="360" units="deg"/>
-          <inkml:channel name="OE" type="integer" max="90" units="deg"/>
-        </inkml:traceFormat>
-        <inkml:channelProperties>
-          <inkml:channelProperty channel="X" name="resolution" value="1000" units="1/cm"/>
-          <inkml:channelProperty channel="Y" name="resolution" value="1000" units="1/cm"/>
-          <inkml:channelProperty channel="F" name="resolution" value="0" units="1/dev"/>
-          <inkml:channelProperty channel="OA" name="resolution" value="1000" units="1/deg"/>
-          <inkml:channelProperty channel="OE" name="resolution" value="1000" units="1/deg"/>
-        </inkml:channelProperties>
-      </inkml:inkSource>
-      <inkml:timestamp xml:id="ts0" timeString="2025-06-11T00:42:33.884"/>
-    </inkml:context>
-    <inkml:brush xml:id="br0">
-      <inkml:brushProperty name="width" value="0.035" units="cm"/>
-      <inkml:brushProperty name="height" value="0.035" units="cm"/>
-    </inkml:brush>
-  </inkml:definitions>
-  <inkml:trace contextRef="#ctx0" brushRef="#br0">523 2458 188 0 0,'-40'39'2886'0'0,"35"-33"579"0"0,-12-35-2316 0 0,6-4-824 0 0,2 0 0 0 0,1-1 1 0 0,-7-61-1 0 0,7 33-62 0 0,-9-71 202 0 0,0-160-1 0 0,22-138-39 0 0,1 101-290 0 0,-4-558 190 0 0,-12 747 236 0 0,10 141-49 0 0,-3 2-501 0 0,0 0-1 0 0,1 0 1 0 0,-1 0-1 0 0,0 0 1 0 0,1 1-1 0 0,0-1 1 0 0,0 1-1 0 0,0 0 1 0 0,0 0-1 0 0,0 0 1 0 0,0 0-1 0 0,1 0 1 0 0,-2 3-1 0 0,-5 7-30 0 0,-45 64-59 0 0,-91 118 45 0 0,110-156 33 0 0,-74 90-53 0 0,172-142-406 0 0,-26-3 473 0 0,-1-2-1 0 0,-1-1 1 0 0,-1-2-1 0 0,0-1 0 0 0,-2-2 1 0 0,-1-1-1 0 0,0-1 1 0 0,-2-2-1 0 0,-2-2 0 0 0,0 0 1 0 0,29-44-1 0 0,-54 70 26 0 0,1-1 52 0 0,0 0 0 0 0,0 0 0 0 0,-1-1 0 0 0,0 1 0 0 0,0-1 0 0 0,-1 0 0 0 0,1 0 1 0 0,-1 0-1 0 0,2-12 0 0 0,-9 12 88 0 0,0 0 0 0 0,-1 1 1 0 0,0-1-1 0 0,0 1 0 0 0,0 0 1 0 0,-1 1-1 0 0,0 0 0 0 0,-7-4 1 0 0,9 5-234 0 0,8 26-9081 0 0,11 53 5815 0 0,-11-58 2546 0 0,4 26 93 0 0,-3-20 432 0 0</inkml:trace>
-</inkml:ink>
-</file>
-
-<file path=ppt/ink/ink21.xml><?xml version="1.0" encoding="utf-8"?>
-<inkml:ink xmlns:inkml="http://www.w3.org/2003/InkML">
-  <inkml:definitions>
-    <inkml:context xml:id="ctx0">
-      <inkml:inkSource xml:id="inkSrc0">
-        <inkml:traceFormat>
-          <inkml:channel name="X" type="integer" min="-2.14748E9" max="2.14748E9" units="cm"/>
-          <inkml:channel name="Y" type="integer" min="-2.14748E9" max="2.14748E9" units="cm"/>
-          <inkml:channel name="F" type="integer" max="32767" units="dev"/>
-          <inkml:channel name="OA" type="integer" max="360" units="deg"/>
-          <inkml:channel name="OE" type="integer" max="90" units="deg"/>
-        </inkml:traceFormat>
-        <inkml:channelProperties>
-          <inkml:channelProperty channel="X" name="resolution" value="1000" units="1/cm"/>
-          <inkml:channelProperty channel="Y" name="resolution" value="1000" units="1/cm"/>
-          <inkml:channelProperty channel="F" name="resolution" value="0" units="1/dev"/>
-          <inkml:channelProperty channel="OA" name="resolution" value="1000" units="1/deg"/>
-          <inkml:channelProperty channel="OE" name="resolution" value="1000" units="1/deg"/>
-        </inkml:channelProperties>
-      </inkml:inkSource>
-      <inkml:timestamp xml:id="ts0" timeString="2025-06-11T00:42:34.976"/>
-    </inkml:context>
-    <inkml:brush xml:id="br0">
-      <inkml:brushProperty name="width" value="0.035" units="cm"/>
-      <inkml:brushProperty name="height" value="0.035" units="cm"/>
-    </inkml:brush>
-  </inkml:definitions>
-  <inkml:trace contextRef="#ctx0" brushRef="#br0">285 83 64 0 0,'-2'-8'243'0'0,"0"0"0"0"0,-1 0 1 0 0,0 0-1 0 0,0 0 0 0 0,-1 1 0 0 0,-5-10 1 0 0,8 16-131 0 0,0-1 0 0 0,0 1 0 0 0,0 0 1 0 0,0-1-1 0 0,0 1 0 0 0,0 0 1 0 0,0 0-1 0 0,0 0 0 0 0,-1-1 0 0 0,1 1 1 0 0,0 1-1 0 0,-1-1 0 0 0,1 0 1 0 0,-1 0-1 0 0,1 0 0 0 0,-3 0 0 0 0,3 1-45 0 0,0 0-1 0 0,0 1 1 0 0,0-1-1 0 0,0 0 1 0 0,0 1-1 0 0,0-1 1 0 0,0 0-1 0 0,0 1 1 0 0,0-1-1 0 0,0 1 0 0 0,0 0 1 0 0,0-1-1 0 0,0 1 1 0 0,0 0-1 0 0,0-1 1 0 0,0 1-1 0 0,1 0 1 0 0,-1 0-1 0 0,0 0 1 0 0,1 0-1 0 0,-1 0 0 0 0,0 0 1 0 0,1 0-1 0 0,-1 0 1 0 0,1 0-1 0 0,0 0 1 0 0,-1 2-1 0 0,-4 12 40 0 0,1 0 1 0 0,1 1-1 0 0,0-1 0 0 0,1 1 1 0 0,1 0-1 0 0,0 0 0 0 0,1 0 1 0 0,3 21-1 0 0,-2 10-4 0 0,-1 80 190 0 0,5 595 974 0 0,35-3-817 0 0,-15-515-337 0 0,57 227-1 0 0,-75-410-77 0 0,3 15 26 0 0,-10-35 102 0 0,-4-3-80 0 0,0-1 1 0 0,1 1 0 0 0,-1-1 0 0 0,1 1 0 0 0,0-1 0 0 0,0 0 0 0 0,0 0-1 0 0,-4-5 1 0 0,-2-2 30 0 0,-40-35 128 0 0,14 11-166 0 0,-2 2 0 0 0,0 2 0 0 0,-47-29 0 0 0,3 4 333 0 0,81 54-426 0 0,31-8-221 0 0,-4 3 222 0 0,0 1-1 0 0,1 2 0 0 0,-1 0 1 0 0,42 3-1 0 0,109 17 119 0 0,-165-15-26 0 0,0 0-1 0 0,-1 1 1 0 0,0 0 0 0 0,0 1 0 0 0,0 0-1 0 0,0 1 1 0 0,0 1 0 0 0,-1-1 0 0 0,0 2-1 0 0,11 8 1 0 0,-16-10 37 0 0,-1 0-1 0 0,0 0 1 0 0,0 0-1 0 0,-1 1 1 0 0,0 0 0 0 0,0 0-1 0 0,0 0 1 0 0,0 0 0 0 0,-1 1-1 0 0,0 0 1 0 0,-1-1 0 0 0,1 1-1 0 0,-1 0 1 0 0,-1 0-1 0 0,1 0 1 0 0,-1 0 0 0 0,0 0-1 0 0,-1 1 1 0 0,0 7 0 0 0,0-3 9 0 0,0 0 0 0 0,-1 1 1 0 0,0-1-1 0 0,-1 0 0 0 0,-5 21 1 0 0,6-31-270 0 0,0 0-1 0 0,0 0 1 0 0,0 0 0 0 0,0 0 0 0 0,0-1 0 0 0,0 1-1 0 0,0 0 1 0 0,-1 0 0 0 0,1-1 0 0 0,0 1 0 0 0,-1-1 0 0 0,0 1-1 0 0,1-1 1 0 0,-1 0 0 0 0,0 0 0 0 0,-3 2 0 0 0,3-2-270 0 0,0-1 1 0 0,-1 1 0 0 0,1-1-1 0 0,-1 0 1 0 0,1 1 0 0 0,-1-1 0 0 0,1 0-1 0 0,-1-1 1 0 0,1 1 0 0 0,-1 0-1 0 0,1-1 1 0 0,0 1 0 0 0,-1-1-1 0 0,1 0 1 0 0,-1 0 0 0 0,1 0-1 0 0,-4-2 1 0 0,-54-40-3664 0 0,48 35 3773 0 0</inkml:trace>
-</inkml:ink>
-</file>
-
-<file path=ppt/ink/ink3.xml><?xml version="1.0" encoding="utf-8"?>
-<inkml:ink xmlns:inkml="http://www.w3.org/2003/InkML">
-  <inkml:definitions>
-    <inkml:context xml:id="ctx0">
-      <inkml:inkSource xml:id="inkSrc0">
-        <inkml:traceFormat>
-          <inkml:channel name="X" type="integer" min="-2.14748E9" max="2.14748E9" units="cm"/>
-          <inkml:channel name="Y" type="integer" min="-2.14748E9" max="2.14748E9" units="cm"/>
-          <inkml:channel name="F" type="integer" max="32767" units="dev"/>
-          <inkml:channel name="OA" type="integer" max="360" units="deg"/>
-          <inkml:channel name="OE" type="integer" max="90" units="deg"/>
-        </inkml:traceFormat>
-        <inkml:channelProperties>
-          <inkml:channelProperty channel="X" name="resolution" value="1000" units="1/cm"/>
-          <inkml:channelProperty channel="Y" name="resolution" value="1000" units="1/cm"/>
-          <inkml:channelProperty channel="F" name="resolution" value="0" units="1/dev"/>
-          <inkml:channelProperty channel="OA" name="resolution" value="1000" units="1/deg"/>
-          <inkml:channelProperty channel="OE" name="resolution" value="1000" units="1/deg"/>
-        </inkml:channelProperties>
-      </inkml:inkSource>
-      <inkml:timestamp xml:id="ts0" timeString="2025-06-11T00:43:30.833"/>
-    </inkml:context>
-    <inkml:brush xml:id="br0">
-      <inkml:brushProperty name="width" value="0.035" units="cm"/>
-      <inkml:brushProperty name="height" value="0.035" units="cm"/>
-    </inkml:brush>
-  </inkml:definitions>
-  <inkml:trace contextRef="#ctx0" brushRef="#br0">124 1 220 0 0,'0'0'555'0'0,"-19"34"3735"0"0,-22 45-3961 0 0,-2 50-4415 0 0,28-84 3171 0 0,9-30 682 0 0</inkml:trace>
-</inkml:ink>
-</file>
-
-<file path=ppt/ink/ink4.xml><?xml version="1.0" encoding="utf-8"?>
-<inkml:ink xmlns:inkml="http://www.w3.org/2003/InkML">
-  <inkml:definitions>
-    <inkml:context xml:id="ctx0">
-      <inkml:inkSource xml:id="inkSrc0">
-        <inkml:traceFormat>
-          <inkml:channel name="X" type="integer" min="-2.14748E9" max="2.14748E9" units="cm"/>
-          <inkml:channel name="Y" type="integer" min="-2.14748E9" max="2.14748E9" units="cm"/>
-          <inkml:channel name="F" type="integer" max="32767" units="dev"/>
-          <inkml:channel name="OA" type="integer" max="360" units="deg"/>
-          <inkml:channel name="OE" type="integer" max="90" units="deg"/>
-        </inkml:traceFormat>
-        <inkml:channelProperties>
-          <inkml:channelProperty channel="X" name="resolution" value="1000" units="1/cm"/>
-          <inkml:channelProperty channel="Y" name="resolution" value="1000" units="1/cm"/>
-          <inkml:channelProperty channel="F" name="resolution" value="0" units="1/dev"/>
-          <inkml:channelProperty channel="OA" name="resolution" value="1000" units="1/deg"/>
-          <inkml:channelProperty channel="OE" name="resolution" value="1000" units="1/deg"/>
-        </inkml:channelProperties>
-      </inkml:inkSource>
-      <inkml:timestamp xml:id="ts0" timeString="2025-06-11T00:43:30.976"/>
-    </inkml:context>
-    <inkml:brush xml:id="br0">
-      <inkml:brushProperty name="width" value="0.035" units="cm"/>
-      <inkml:brushProperty name="height" value="0.035" units="cm"/>
-    </inkml:brush>
-  </inkml:definitions>
-  <inkml:trace contextRef="#ctx0" brushRef="#br0">126 0 176 0 0,'-6'33'1294'0'0,"-2"-1"0"0"0,-1 0 1 0 0,-27 60-1 0 0,-4 17-3763 0 0,16-42-158 0 0,21-58 2410 0 0</inkml:trace>
-</inkml:ink>
-</file>
-
-<file path=ppt/ink/ink5.xml><?xml version="1.0" encoding="utf-8"?>
-<inkml:ink xmlns:inkml="http://www.w3.org/2003/InkML">
-  <inkml:definitions>
-    <inkml:context xml:id="ctx0">
-      <inkml:inkSource xml:id="inkSrc0">
-        <inkml:traceFormat>
-          <inkml:channel name="X" type="integer" min="-2.14748E9" max="2.14748E9" units="cm"/>
-          <inkml:channel name="Y" type="integer" min="-2.14748E9" max="2.14748E9" units="cm"/>
-          <inkml:channel name="F" type="integer" max="32767" units="dev"/>
-          <inkml:channel name="OA" type="integer" max="360" units="deg"/>
-          <inkml:channel name="OE" type="integer" max="90" units="deg"/>
-        </inkml:traceFormat>
-        <inkml:channelProperties>
-          <inkml:channelProperty channel="X" name="resolution" value="1000" units="1/cm"/>
-          <inkml:channelProperty channel="Y" name="resolution" value="1000" units="1/cm"/>
-          <inkml:channelProperty channel="F" name="resolution" value="0" units="1/dev"/>
-          <inkml:channelProperty channel="OA" name="resolution" value="1000" units="1/deg"/>
-          <inkml:channelProperty channel="OE" name="resolution" value="1000" units="1/deg"/>
-        </inkml:channelProperties>
-      </inkml:inkSource>
-      <inkml:timestamp xml:id="ts0" timeString="2025-06-11T00:43:31.099"/>
-    </inkml:context>
-    <inkml:brush xml:id="br0">
-      <inkml:brushProperty name="width" value="0.035" units="cm"/>
-      <inkml:brushProperty name="height" value="0.035" units="cm"/>
-    </inkml:brush>
-  </inkml:definitions>
-  <inkml:trace contextRef="#ctx0" brushRef="#br0">96 0 68 0 0,'-3'64'1980'0'0,"-2"0"1"0"0,-18 85-1 0 0,-16 34-6043 0 0,18-103 2394 0 0,17-65 1452 0 0</inkml:trace>
-</inkml:ink>
-</file>
-
-<file path=ppt/ink/ink6.xml><?xml version="1.0" encoding="utf-8"?>
-<inkml:ink xmlns:inkml="http://www.w3.org/2003/InkML">
-  <inkml:definitions>
-    <inkml:context xml:id="ctx0">
-      <inkml:inkSource xml:id="inkSrc0">
-        <inkml:traceFormat>
-          <inkml:channel name="X" type="integer" min="-2.14748E9" max="2.14748E9" units="cm"/>
-          <inkml:channel name="Y" type="integer" min="-2.14748E9" max="2.14748E9" units="cm"/>
-          <inkml:channel name="F" type="integer" max="32767" units="dev"/>
-          <inkml:channel name="OA" type="integer" max="360" units="deg"/>
-          <inkml:channel name="OE" type="integer" max="90" units="deg"/>
-        </inkml:traceFormat>
-        <inkml:channelProperties>
-          <inkml:channelProperty channel="X" name="resolution" value="1000" units="1/cm"/>
-          <inkml:channelProperty channel="Y" name="resolution" value="1000" units="1/cm"/>
-          <inkml:channelProperty channel="F" name="resolution" value="0" units="1/dev"/>
-          <inkml:channelProperty channel="OA" name="resolution" value="1000" units="1/deg"/>
-          <inkml:channelProperty channel="OE" name="resolution" value="1000" units="1/deg"/>
-        </inkml:channelProperties>
-      </inkml:inkSource>
-      <inkml:timestamp xml:id="ts0" timeString="2025-06-11T00:43:31.256"/>
-    </inkml:context>
-    <inkml:brush xml:id="br0">
-      <inkml:brushProperty name="width" value="0.035" units="cm"/>
-      <inkml:brushProperty name="height" value="0.035" units="cm"/>
-    </inkml:brush>
-  </inkml:definitions>
-  <inkml:trace contextRef="#ctx0" brushRef="#br0">60 0 180 0 0,'1'21'913'0'0,"-2"1"-1"0"0,0-1 1 0 0,-2 0-1 0 0,0 0 1 0 0,-1 0-1 0 0,-8 22 1 0 0,-8 43-2029 0 0,14-52-609 0 0,2-20 1037 0 0,2 0 0 0 0,0 1-1 0 0,1-1 1 0 0,0 23-1 0 0,3-25 472 0 0</inkml:trace>
-</inkml:ink>
-</file>
-
-<file path=ppt/ink/ink7.xml><?xml version="1.0" encoding="utf-8"?>
-<inkml:ink xmlns:inkml="http://www.w3.org/2003/InkML">
-  <inkml:definitions>
-    <inkml:context xml:id="ctx0">
-      <inkml:inkSource xml:id="inkSrc0">
-        <inkml:traceFormat>
-          <inkml:channel name="X" type="integer" min="-2.14748E9" max="2.14748E9" units="cm"/>
-          <inkml:channel name="Y" type="integer" min="-2.14748E9" max="2.14748E9" units="cm"/>
-          <inkml:channel name="F" type="integer" max="32767" units="dev"/>
-          <inkml:channel name="OA" type="integer" max="360" units="deg"/>
-          <inkml:channel name="OE" type="integer" max="90" units="deg"/>
-        </inkml:traceFormat>
-        <inkml:channelProperties>
-          <inkml:channelProperty channel="X" name="resolution" value="1000" units="1/cm"/>
-          <inkml:channelProperty channel="Y" name="resolution" value="1000" units="1/cm"/>
-          <inkml:channelProperty channel="F" name="resolution" value="0" units="1/dev"/>
-          <inkml:channelProperty channel="OA" name="resolution" value="1000" units="1/deg"/>
-          <inkml:channelProperty channel="OE" name="resolution" value="1000" units="1/deg"/>
-        </inkml:channelProperties>
-      </inkml:inkSource>
-      <inkml:timestamp xml:id="ts0" timeString="2025-06-11T00:43:31.380"/>
-    </inkml:context>
-    <inkml:brush xml:id="br0">
-      <inkml:brushProperty name="width" value="0.035" units="cm"/>
-      <inkml:brushProperty name="height" value="0.035" units="cm"/>
-    </inkml:brush>
-  </inkml:definitions>
-  <inkml:trace contextRef="#ctx0" brushRef="#br0">81 0 152 0 0,'1'14'671'0'0,"-1"0"-1"0"0,0 0 1 0 0,-1-1-1 0 0,-1 1 1 0 0,0 0-1 0 0,-5 18 1 0 0,-15 37 601 0 0,7-26-4040 0 0,13-40 2400 0 0,-25 58-2405 0 0,24-54 2568 0 0</inkml:trace>
-</inkml:ink>
-</file>
-
-<file path=ppt/ink/ink8.xml><?xml version="1.0" encoding="utf-8"?>
-<inkml:ink xmlns:inkml="http://www.w3.org/2003/InkML">
-  <inkml:definitions>
-    <inkml:context xml:id="ctx0">
-      <inkml:inkSource xml:id="inkSrc0">
-        <inkml:traceFormat>
-          <inkml:channel name="X" type="integer" min="-2.14748E9" max="2.14748E9" units="cm"/>
-          <inkml:channel name="Y" type="integer" min="-2.14748E9" max="2.14748E9" units="cm"/>
-          <inkml:channel name="F" type="integer" max="32767" units="dev"/>
-          <inkml:channel name="OA" type="integer" max="360" units="deg"/>
-          <inkml:channel name="OE" type="integer" max="90" units="deg"/>
-        </inkml:traceFormat>
-        <inkml:channelProperties>
-          <inkml:channelProperty channel="X" name="resolution" value="1000" units="1/cm"/>
-          <inkml:channelProperty channel="Y" name="resolution" value="1000" units="1/cm"/>
-          <inkml:channelProperty channel="F" name="resolution" value="0" units="1/dev"/>
-          <inkml:channelProperty channel="OA" name="resolution" value="1000" units="1/deg"/>
-          <inkml:channelProperty channel="OE" name="resolution" value="1000" units="1/deg"/>
-        </inkml:channelProperties>
-      </inkml:inkSource>
-      <inkml:timestamp xml:id="ts0" timeString="2025-06-11T00:43:31.521"/>
-    </inkml:context>
-    <inkml:brush xml:id="br0">
-      <inkml:brushProperty name="width" value="0.035" units="cm"/>
-      <inkml:brushProperty name="height" value="0.035" units="cm"/>
-    </inkml:brush>
-  </inkml:definitions>
-  <inkml:trace contextRef="#ctx0" brushRef="#br0">109 1 232 0 0,'0'11'481'0'0,"0"0"0"0"0,-1 0-1 0 0,0-1 1 0 0,-1 1 0 0 0,0 0 0 0 0,-1 0-1 0 0,0-1 1 0 0,0 1 0 0 0,-7 11 0 0 0,-6 25 1810 0 0,-14 36-2355 0 0,20-60-1408 0 0,2 0 0 0 0,0 0-1 0 0,-4 27 1 0 0,14-43 327 0 0,-2-7 940 0 0</inkml:trace>
-</inkml:ink>
-</file>
-
-<file path=ppt/ink/ink9.xml><?xml version="1.0" encoding="utf-8"?>
-<inkml:ink xmlns:inkml="http://www.w3.org/2003/InkML">
-  <inkml:definitions>
-    <inkml:context xml:id="ctx0">
-      <inkml:inkSource xml:id="inkSrc0">
-        <inkml:traceFormat>
-          <inkml:channel name="X" type="integer" min="-2.14748E9" max="2.14748E9" units="cm"/>
-          <inkml:channel name="Y" type="integer" min="-2.14748E9" max="2.14748E9" units="cm"/>
-          <inkml:channel name="F" type="integer" max="32767" units="dev"/>
-          <inkml:channel name="OA" type="integer" max="360" units="deg"/>
-          <inkml:channel name="OE" type="integer" max="90" units="deg"/>
-        </inkml:traceFormat>
-        <inkml:channelProperties>
-          <inkml:channelProperty channel="X" name="resolution" value="1000" units="1/cm"/>
-          <inkml:channelProperty channel="Y" name="resolution" value="1000" units="1/cm"/>
-          <inkml:channelProperty channel="F" name="resolution" value="0" units="1/dev"/>
-          <inkml:channelProperty channel="OA" name="resolution" value="1000" units="1/deg"/>
-          <inkml:channelProperty channel="OE" name="resolution" value="1000" units="1/deg"/>
-        </inkml:channelProperties>
-      </inkml:inkSource>
-      <inkml:timestamp xml:id="ts0" timeString="2025-06-11T00:43:31.677"/>
-    </inkml:context>
-    <inkml:brush xml:id="br0">
-      <inkml:brushProperty name="width" value="0.035" units="cm"/>
-      <inkml:brushProperty name="height" value="0.035" units="cm"/>
-    </inkml:brush>
-  </inkml:definitions>
-  <inkml:trace contextRef="#ctx0" brushRef="#br0">100 0 216 0 0,'1'1'110'0'0,"0"0"1"0"0,0-1-1 0 0,0 1 0 0 0,0 0 1 0 0,0-1-1 0 0,-1 1 0 0 0,1 0 1 0 0,0 0-1 0 0,0 0 0 0 0,-1 0 1 0 0,1 0-1 0 0,-1 0 0 0 0,1 0 1 0 0,-1 0-1 0 0,1 0 0 0 0,-1 0 1 0 0,1 0-1 0 0,-1 0 0 0 0,0 0 1 0 0,0 0-1 0 0,0 0 0 0 0,1 0 1 0 0,-1 0-1 0 0,0 1 0 0 0,0-1 1 0 0,-1 0-1 0 0,1 0 0 0 0,0 0 1 0 0,0 0-1 0 0,0 0 0 0 0,-1 0 1 0 0,1 0-1 0 0,-1 0 0 0 0,0 2 1 0 0,-17 42 5169 0 0,16-40-4349 0 0,-86 148 1034 0 0,88-153-2040 0 0,0 0 0 0 0,-1 1 0 0 0,1-1 0 0 0,0 0 0 0 0,0 1 0 0 0,0-1 0 0 0,0 1 0 0 0,0-1 0 0 0,0 0-1 0 0,0 1 1 0 0,0-1 0 0 0,0 0 0 0 0,0 1 0 0 0,0-1 0 0 0,0 1 0 0 0,0-1 0 0 0,0 0 0 0 0,0 1 0 0 0,0-1-1 0 0,0 0 1 0 0,0 1 0 0 0,0-1 0 0 0,0 1 0 0 0,1-1 0 0 0,-1 0 0 0 0,0 1 0 0 0,0-1 0 0 0,0 0 0 0 0,1 0-1 0 0,-1 1 1 0 0,0-1 0 0 0,0 0 0 0 0,1 1 0 0 0,-1-1 0 0 0,0 0 0 0 0,1 0 0 0 0,-1 0 0 0 0,0 1 0 0 0,1-1-1 0 0,20 2-2277 0 0,20-10-172 0 0,-26 0 2009 0 0,-11 7 314 0 0,-1 0-1 0 0,0 0 1 0 0,0-1-1 0 0,0 0 1 0 0,0 0 0 0 0,0 1-1 0 0,0-2 1 0 0,0 1-1 0 0,-1 0 1 0 0,1-1-1 0 0,-1 1 1 0 0,1-1-1 0 0,-1 1 1 0 0,0-1-1 0 0,0 0 1 0 0,0 0-1 0 0,1-4 1 0 0,-2 1 14 0 0</inkml:trace>
-</inkml:ink>
 </file>
 
 <file path=ppt/notesMasters/notesMaster1.xml><?xml version="1.0" encoding="utf-8"?>
@@ -18962,915 +18311,6 @@
           </a:p>
         </p:txBody>
       </p:sp>
-      <mc:AlternateContent xmlns:mc="http://schemas.openxmlformats.org/markup-compatibility/2006">
-        <mc:Choice xmlns:p14="http://schemas.microsoft.com/office/powerpoint/2010/main" Requires="p14">
-          <p:contentPart p14:bwMode="auto" r:id="rId3">
-            <p14:nvContentPartPr>
-              <p14:cNvPr id="2" name="Ink 1">
-                <a:extLst>
-                  <a:ext uri="{FF2B5EF4-FFF2-40B4-BE49-F238E27FC236}">
-                    <a16:creationId xmlns:a16="http://schemas.microsoft.com/office/drawing/2014/main" id="{4D9FA1D6-1835-33D9-16E7-3827158B3994}"/>
-                  </a:ext>
-                </a:extLst>
-              </p14:cNvPr>
-              <p14:cNvContentPartPr/>
-              <p14:nvPr/>
-            </p14:nvContentPartPr>
-            <p14:xfrm>
-              <a:off x="3620173" y="2794238"/>
-              <a:ext cx="1958400" cy="225360"/>
-            </p14:xfrm>
-          </p:contentPart>
-        </mc:Choice>
-        <mc:Fallback>
-          <p:pic>
-            <p:nvPicPr>
-              <p:cNvPr id="2" name="Ink 1">
-                <a:extLst>
-                  <a:ext uri="{FF2B5EF4-FFF2-40B4-BE49-F238E27FC236}">
-                    <a16:creationId xmlns:a16="http://schemas.microsoft.com/office/drawing/2014/main" id="{4D9FA1D6-1835-33D9-16E7-3827158B3994}"/>
-                  </a:ext>
-                </a:extLst>
-              </p:cNvPr>
-              <p:cNvPicPr/>
-              <p:nvPr/>
-            </p:nvPicPr>
-            <p:blipFill>
-              <a:blip r:embed="rId4"/>
-              <a:stretch>
-                <a:fillRect/>
-              </a:stretch>
-            </p:blipFill>
-            <p:spPr>
-              <a:xfrm>
-                <a:off x="3614053" y="2788118"/>
-                <a:ext cx="1970640" cy="237600"/>
-              </a:xfrm>
-              <a:prstGeom prst="rect">
-                <a:avLst/>
-              </a:prstGeom>
-            </p:spPr>
-          </p:pic>
-        </mc:Fallback>
-      </mc:AlternateContent>
-      <p:grpSp>
-        <p:nvGrpSpPr>
-          <p:cNvPr id="11" name="Group 10">
-            <a:extLst>
-              <a:ext uri="{FF2B5EF4-FFF2-40B4-BE49-F238E27FC236}">
-                <a16:creationId xmlns:a16="http://schemas.microsoft.com/office/drawing/2014/main" id="{9F848F3A-48F5-CCA6-BC6E-EB35599213CF}"/>
-              </a:ext>
-            </a:extLst>
-          </p:cNvPr>
-          <p:cNvGrpSpPr/>
-          <p:nvPr/>
-        </p:nvGrpSpPr>
-        <p:grpSpPr>
-          <a:xfrm>
-            <a:off x="214933" y="1247318"/>
-            <a:ext cx="1542600" cy="1697400"/>
-            <a:chOff x="214933" y="1247318"/>
-            <a:chExt cx="1542600" cy="1697400"/>
-          </a:xfrm>
-        </p:grpSpPr>
-        <mc:AlternateContent xmlns:mc="http://schemas.openxmlformats.org/markup-compatibility/2006">
-          <mc:Choice xmlns:p14="http://schemas.microsoft.com/office/powerpoint/2010/main" Requires="p14">
-            <p:contentPart p14:bwMode="auto" r:id="rId5">
-              <p14:nvContentPartPr>
-                <p14:cNvPr id="3" name="Ink 2">
-                  <a:extLst>
-                    <a:ext uri="{FF2B5EF4-FFF2-40B4-BE49-F238E27FC236}">
-                      <a16:creationId xmlns:a16="http://schemas.microsoft.com/office/drawing/2014/main" id="{BC72456B-2051-D521-A06E-4E41FE19FB31}"/>
-                    </a:ext>
-                  </a:extLst>
-                </p14:cNvPr>
-                <p14:cNvContentPartPr/>
-                <p14:nvPr/>
-              </p14:nvContentPartPr>
-              <p14:xfrm>
-                <a:off x="281893" y="1247318"/>
-                <a:ext cx="1475640" cy="1514160"/>
-              </p14:xfrm>
-            </p:contentPart>
-          </mc:Choice>
-          <mc:Fallback>
-            <p:pic>
-              <p:nvPicPr>
-                <p:cNvPr id="3" name="Ink 2">
-                  <a:extLst>
-                    <a:ext uri="{FF2B5EF4-FFF2-40B4-BE49-F238E27FC236}">
-                      <a16:creationId xmlns:a16="http://schemas.microsoft.com/office/drawing/2014/main" id="{BC72456B-2051-D521-A06E-4E41FE19FB31}"/>
-                    </a:ext>
-                  </a:extLst>
-                </p:cNvPr>
-                <p:cNvPicPr/>
-                <p:nvPr/>
-              </p:nvPicPr>
-              <p:blipFill>
-                <a:blip r:embed="rId6"/>
-                <a:stretch>
-                  <a:fillRect/>
-                </a:stretch>
-              </p:blipFill>
-              <p:spPr>
-                <a:xfrm>
-                  <a:off x="275773" y="1241198"/>
-                  <a:ext cx="1487880" cy="1526400"/>
-                </a:xfrm>
-                <a:prstGeom prst="rect">
-                  <a:avLst/>
-                </a:prstGeom>
-              </p:spPr>
-            </p:pic>
-          </mc:Fallback>
-        </mc:AlternateContent>
-        <mc:AlternateContent xmlns:mc="http://schemas.openxmlformats.org/markup-compatibility/2006">
-          <mc:Choice xmlns:p14="http://schemas.microsoft.com/office/powerpoint/2010/main" Requires="p14">
-            <p:contentPart p14:bwMode="auto" r:id="rId7">
-              <p14:nvContentPartPr>
-                <p14:cNvPr id="4" name="Ink 3">
-                  <a:extLst>
-                    <a:ext uri="{FF2B5EF4-FFF2-40B4-BE49-F238E27FC236}">
-                      <a16:creationId xmlns:a16="http://schemas.microsoft.com/office/drawing/2014/main" id="{BE06EFA0-1AAD-0834-6FDC-335D21B6B5BC}"/>
-                    </a:ext>
-                  </a:extLst>
-                </p14:cNvPr>
-                <p14:cNvContentPartPr/>
-                <p14:nvPr/>
-              </p14:nvContentPartPr>
-              <p14:xfrm>
-                <a:off x="284053" y="1563038"/>
-                <a:ext cx="44640" cy="109080"/>
-              </p14:xfrm>
-            </p:contentPart>
-          </mc:Choice>
-          <mc:Fallback>
-            <p:pic>
-              <p:nvPicPr>
-                <p:cNvPr id="4" name="Ink 3">
-                  <a:extLst>
-                    <a:ext uri="{FF2B5EF4-FFF2-40B4-BE49-F238E27FC236}">
-                      <a16:creationId xmlns:a16="http://schemas.microsoft.com/office/drawing/2014/main" id="{BE06EFA0-1AAD-0834-6FDC-335D21B6B5BC}"/>
-                    </a:ext>
-                  </a:extLst>
-                </p:cNvPr>
-                <p:cNvPicPr/>
-                <p:nvPr/>
-              </p:nvPicPr>
-              <p:blipFill>
-                <a:blip r:embed="rId8"/>
-                <a:stretch>
-                  <a:fillRect/>
-                </a:stretch>
-              </p:blipFill>
-              <p:spPr>
-                <a:xfrm>
-                  <a:off x="277933" y="1556918"/>
-                  <a:ext cx="56880" cy="121320"/>
-                </a:xfrm>
-                <a:prstGeom prst="rect">
-                  <a:avLst/>
-                </a:prstGeom>
-              </p:spPr>
-            </p:pic>
-          </mc:Fallback>
-        </mc:AlternateContent>
-        <mc:AlternateContent xmlns:mc="http://schemas.openxmlformats.org/markup-compatibility/2006">
-          <mc:Choice xmlns:p14="http://schemas.microsoft.com/office/powerpoint/2010/main" Requires="p14">
-            <p:contentPart p14:bwMode="auto" r:id="rId9">
-              <p14:nvContentPartPr>
-                <p14:cNvPr id="5" name="Ink 4">
-                  <a:extLst>
-                    <a:ext uri="{FF2B5EF4-FFF2-40B4-BE49-F238E27FC236}">
-                      <a16:creationId xmlns:a16="http://schemas.microsoft.com/office/drawing/2014/main" id="{E2EC51D4-2500-EF12-E9EA-C4A5CF151353}"/>
-                    </a:ext>
-                  </a:extLst>
-                </p14:cNvPr>
-                <p14:cNvContentPartPr/>
-                <p14:nvPr/>
-              </p14:nvContentPartPr>
-              <p14:xfrm>
-                <a:off x="234373" y="1780478"/>
-                <a:ext cx="45360" cy="135000"/>
-              </p14:xfrm>
-            </p:contentPart>
-          </mc:Choice>
-          <mc:Fallback>
-            <p:pic>
-              <p:nvPicPr>
-                <p:cNvPr id="5" name="Ink 4">
-                  <a:extLst>
-                    <a:ext uri="{FF2B5EF4-FFF2-40B4-BE49-F238E27FC236}">
-                      <a16:creationId xmlns:a16="http://schemas.microsoft.com/office/drawing/2014/main" id="{E2EC51D4-2500-EF12-E9EA-C4A5CF151353}"/>
-                    </a:ext>
-                  </a:extLst>
-                </p:cNvPr>
-                <p:cNvPicPr/>
-                <p:nvPr/>
-              </p:nvPicPr>
-              <p:blipFill>
-                <a:blip r:embed="rId10"/>
-                <a:stretch>
-                  <a:fillRect/>
-                </a:stretch>
-              </p:blipFill>
-              <p:spPr>
-                <a:xfrm>
-                  <a:off x="228253" y="1774358"/>
-                  <a:ext cx="57600" cy="147240"/>
-                </a:xfrm>
-                <a:prstGeom prst="rect">
-                  <a:avLst/>
-                </a:prstGeom>
-              </p:spPr>
-            </p:pic>
-          </mc:Fallback>
-        </mc:AlternateContent>
-        <mc:AlternateContent xmlns:mc="http://schemas.openxmlformats.org/markup-compatibility/2006">
-          <mc:Choice xmlns:p14="http://schemas.microsoft.com/office/powerpoint/2010/main" Requires="p14">
-            <p:contentPart p14:bwMode="auto" r:id="rId11">
-              <p14:nvContentPartPr>
-                <p14:cNvPr id="6" name="Ink 5">
-                  <a:extLst>
-                    <a:ext uri="{FF2B5EF4-FFF2-40B4-BE49-F238E27FC236}">
-                      <a16:creationId xmlns:a16="http://schemas.microsoft.com/office/drawing/2014/main" id="{981DD12F-FAD1-422C-7B8D-5A364A78EB13}"/>
-                    </a:ext>
-                  </a:extLst>
-                </p14:cNvPr>
-                <p14:cNvContentPartPr/>
-                <p14:nvPr/>
-              </p14:nvContentPartPr>
-              <p14:xfrm>
-                <a:off x="214933" y="2006918"/>
-                <a:ext cx="34560" cy="200160"/>
-              </p14:xfrm>
-            </p:contentPart>
-          </mc:Choice>
-          <mc:Fallback>
-            <p:pic>
-              <p:nvPicPr>
-                <p:cNvPr id="6" name="Ink 5">
-                  <a:extLst>
-                    <a:ext uri="{FF2B5EF4-FFF2-40B4-BE49-F238E27FC236}">
-                      <a16:creationId xmlns:a16="http://schemas.microsoft.com/office/drawing/2014/main" id="{981DD12F-FAD1-422C-7B8D-5A364A78EB13}"/>
-                    </a:ext>
-                  </a:extLst>
-                </p:cNvPr>
-                <p:cNvPicPr/>
-                <p:nvPr/>
-              </p:nvPicPr>
-              <p:blipFill>
-                <a:blip r:embed="rId12"/>
-                <a:stretch>
-                  <a:fillRect/>
-                </a:stretch>
-              </p:blipFill>
-              <p:spPr>
-                <a:xfrm>
-                  <a:off x="208813" y="2000798"/>
-                  <a:ext cx="46800" cy="212400"/>
-                </a:xfrm>
-                <a:prstGeom prst="rect">
-                  <a:avLst/>
-                </a:prstGeom>
-              </p:spPr>
-            </p:pic>
-          </mc:Fallback>
-        </mc:AlternateContent>
-        <mc:AlternateContent xmlns:mc="http://schemas.openxmlformats.org/markup-compatibility/2006">
-          <mc:Choice xmlns:p14="http://schemas.microsoft.com/office/powerpoint/2010/main" Requires="p14">
-            <p:contentPart p14:bwMode="auto" r:id="rId13">
-              <p14:nvContentPartPr>
-                <p14:cNvPr id="7" name="Ink 6">
-                  <a:extLst>
-                    <a:ext uri="{FF2B5EF4-FFF2-40B4-BE49-F238E27FC236}">
-                      <a16:creationId xmlns:a16="http://schemas.microsoft.com/office/drawing/2014/main" id="{E4F5640B-B450-5BF7-C2EA-C33207B7E2E1}"/>
-                    </a:ext>
-                  </a:extLst>
-                </p14:cNvPr>
-                <p14:cNvContentPartPr/>
-                <p14:nvPr/>
-              </p14:nvContentPartPr>
-              <p14:xfrm>
-                <a:off x="224653" y="2328038"/>
-                <a:ext cx="21960" cy="142920"/>
-              </p14:xfrm>
-            </p:contentPart>
-          </mc:Choice>
-          <mc:Fallback>
-            <p:pic>
-              <p:nvPicPr>
-                <p:cNvPr id="7" name="Ink 6">
-                  <a:extLst>
-                    <a:ext uri="{FF2B5EF4-FFF2-40B4-BE49-F238E27FC236}">
-                      <a16:creationId xmlns:a16="http://schemas.microsoft.com/office/drawing/2014/main" id="{E4F5640B-B450-5BF7-C2EA-C33207B7E2E1}"/>
-                    </a:ext>
-                  </a:extLst>
-                </p:cNvPr>
-                <p:cNvPicPr/>
-                <p:nvPr/>
-              </p:nvPicPr>
-              <p:blipFill>
-                <a:blip r:embed="rId14"/>
-                <a:stretch>
-                  <a:fillRect/>
-                </a:stretch>
-              </p:blipFill>
-              <p:spPr>
-                <a:xfrm>
-                  <a:off x="218533" y="2321918"/>
-                  <a:ext cx="34200" cy="155160"/>
-                </a:xfrm>
-                <a:prstGeom prst="rect">
-                  <a:avLst/>
-                </a:prstGeom>
-              </p:spPr>
-            </p:pic>
-          </mc:Fallback>
-        </mc:AlternateContent>
-        <mc:AlternateContent xmlns:mc="http://schemas.openxmlformats.org/markup-compatibility/2006">
-          <mc:Choice xmlns:p14="http://schemas.microsoft.com/office/powerpoint/2010/main" Requires="p14">
-            <p:contentPart p14:bwMode="auto" r:id="rId15">
-              <p14:nvContentPartPr>
-                <p14:cNvPr id="8" name="Ink 7">
-                  <a:extLst>
-                    <a:ext uri="{FF2B5EF4-FFF2-40B4-BE49-F238E27FC236}">
-                      <a16:creationId xmlns:a16="http://schemas.microsoft.com/office/drawing/2014/main" id="{DE1ED292-C0AE-89DC-8FB2-35F138F57625}"/>
-                    </a:ext>
-                  </a:extLst>
-                </p14:cNvPr>
-                <p14:cNvContentPartPr/>
-                <p14:nvPr/>
-              </p14:nvContentPartPr>
-              <p14:xfrm>
-                <a:off x="224653" y="2554478"/>
-                <a:ext cx="29520" cy="107640"/>
-              </p14:xfrm>
-            </p:contentPart>
-          </mc:Choice>
-          <mc:Fallback>
-            <p:pic>
-              <p:nvPicPr>
-                <p:cNvPr id="8" name="Ink 7">
-                  <a:extLst>
-                    <a:ext uri="{FF2B5EF4-FFF2-40B4-BE49-F238E27FC236}">
-                      <a16:creationId xmlns:a16="http://schemas.microsoft.com/office/drawing/2014/main" id="{DE1ED292-C0AE-89DC-8FB2-35F138F57625}"/>
-                    </a:ext>
-                  </a:extLst>
-                </p:cNvPr>
-                <p:cNvPicPr/>
-                <p:nvPr/>
-              </p:nvPicPr>
-              <p:blipFill>
-                <a:blip r:embed="rId16"/>
-                <a:stretch>
-                  <a:fillRect/>
-                </a:stretch>
-              </p:blipFill>
-              <p:spPr>
-                <a:xfrm>
-                  <a:off x="218533" y="2548358"/>
-                  <a:ext cx="41760" cy="119880"/>
-                </a:xfrm>
-                <a:prstGeom prst="rect">
-                  <a:avLst/>
-                </a:prstGeom>
-              </p:spPr>
-            </p:pic>
-          </mc:Fallback>
-        </mc:AlternateContent>
-        <mc:AlternateContent xmlns:mc="http://schemas.openxmlformats.org/markup-compatibility/2006">
-          <mc:Choice xmlns:p14="http://schemas.microsoft.com/office/powerpoint/2010/main" Requires="p14">
-            <p:contentPart p14:bwMode="auto" r:id="rId17">
-              <p14:nvContentPartPr>
-                <p14:cNvPr id="9" name="Ink 8">
-                  <a:extLst>
-                    <a:ext uri="{FF2B5EF4-FFF2-40B4-BE49-F238E27FC236}">
-                      <a16:creationId xmlns:a16="http://schemas.microsoft.com/office/drawing/2014/main" id="{889C69DD-0C29-3F0D-9577-298E06A2C258}"/>
-                    </a:ext>
-                  </a:extLst>
-                </p14:cNvPr>
-                <p14:cNvContentPartPr/>
-                <p14:nvPr/>
-              </p14:nvContentPartPr>
-              <p14:xfrm>
-                <a:off x="241213" y="2718278"/>
-                <a:ext cx="39600" cy="135720"/>
-              </p14:xfrm>
-            </p:contentPart>
-          </mc:Choice>
-          <mc:Fallback>
-            <p:pic>
-              <p:nvPicPr>
-                <p:cNvPr id="9" name="Ink 8">
-                  <a:extLst>
-                    <a:ext uri="{FF2B5EF4-FFF2-40B4-BE49-F238E27FC236}">
-                      <a16:creationId xmlns:a16="http://schemas.microsoft.com/office/drawing/2014/main" id="{889C69DD-0C29-3F0D-9577-298E06A2C258}"/>
-                    </a:ext>
-                  </a:extLst>
-                </p:cNvPr>
-                <p:cNvPicPr/>
-                <p:nvPr/>
-              </p:nvPicPr>
-              <p:blipFill>
-                <a:blip r:embed="rId18"/>
-                <a:stretch>
-                  <a:fillRect/>
-                </a:stretch>
-              </p:blipFill>
-              <p:spPr>
-                <a:xfrm>
-                  <a:off x="235093" y="2712158"/>
-                  <a:ext cx="51840" cy="147960"/>
-                </a:xfrm>
-                <a:prstGeom prst="rect">
-                  <a:avLst/>
-                </a:prstGeom>
-              </p:spPr>
-            </p:pic>
-          </mc:Fallback>
-        </mc:AlternateContent>
-        <mc:AlternateContent xmlns:mc="http://schemas.openxmlformats.org/markup-compatibility/2006">
-          <mc:Choice xmlns:p14="http://schemas.microsoft.com/office/powerpoint/2010/main" Requires="p14">
-            <p:contentPart p14:bwMode="auto" r:id="rId19">
-              <p14:nvContentPartPr>
-                <p14:cNvPr id="10" name="Ink 9">
-                  <a:extLst>
-                    <a:ext uri="{FF2B5EF4-FFF2-40B4-BE49-F238E27FC236}">
-                      <a16:creationId xmlns:a16="http://schemas.microsoft.com/office/drawing/2014/main" id="{343AF7B7-3880-887E-E397-36893BC14E22}"/>
-                    </a:ext>
-                  </a:extLst>
-                </p14:cNvPr>
-                <p14:cNvContentPartPr/>
-                <p14:nvPr/>
-              </p14:nvContentPartPr>
-              <p14:xfrm>
-                <a:off x="247333" y="2852918"/>
-                <a:ext cx="48240" cy="91800"/>
-              </p14:xfrm>
-            </p:contentPart>
-          </mc:Choice>
-          <mc:Fallback>
-            <p:pic>
-              <p:nvPicPr>
-                <p:cNvPr id="10" name="Ink 9">
-                  <a:extLst>
-                    <a:ext uri="{FF2B5EF4-FFF2-40B4-BE49-F238E27FC236}">
-                      <a16:creationId xmlns:a16="http://schemas.microsoft.com/office/drawing/2014/main" id="{343AF7B7-3880-887E-E397-36893BC14E22}"/>
-                    </a:ext>
-                  </a:extLst>
-                </p:cNvPr>
-                <p:cNvPicPr/>
-                <p:nvPr/>
-              </p:nvPicPr>
-              <p:blipFill>
-                <a:blip r:embed="rId20"/>
-                <a:stretch>
-                  <a:fillRect/>
-                </a:stretch>
-              </p:blipFill>
-              <p:spPr>
-                <a:xfrm>
-                  <a:off x="241213" y="2846798"/>
-                  <a:ext cx="60480" cy="104040"/>
-                </a:xfrm>
-                <a:prstGeom prst="rect">
-                  <a:avLst/>
-                </a:prstGeom>
-              </p:spPr>
-            </p:pic>
-          </mc:Fallback>
-        </mc:AlternateContent>
-      </p:grpSp>
-      <p:grpSp>
-        <p:nvGrpSpPr>
-          <p:cNvPr id="21" name="Group 20">
-            <a:extLst>
-              <a:ext uri="{FF2B5EF4-FFF2-40B4-BE49-F238E27FC236}">
-                <a16:creationId xmlns:a16="http://schemas.microsoft.com/office/drawing/2014/main" id="{093613DD-4AFD-D80A-9313-667DE20AC2C8}"/>
-              </a:ext>
-            </a:extLst>
-          </p:cNvPr>
-          <p:cNvGrpSpPr/>
-          <p:nvPr/>
-        </p:nvGrpSpPr>
-        <p:grpSpPr>
-          <a:xfrm>
-            <a:off x="3637093" y="2790278"/>
-            <a:ext cx="1833480" cy="280800"/>
-            <a:chOff x="3637093" y="2790278"/>
-            <a:chExt cx="1833480" cy="280800"/>
-          </a:xfrm>
-        </p:grpSpPr>
-        <mc:AlternateContent xmlns:mc="http://schemas.openxmlformats.org/markup-compatibility/2006">
-          <mc:Choice xmlns:p14="http://schemas.microsoft.com/office/powerpoint/2010/main" Requires="p14">
-            <p:contentPart p14:bwMode="auto" r:id="rId21">
-              <p14:nvContentPartPr>
-                <p14:cNvPr id="12" name="Ink 11">
-                  <a:extLst>
-                    <a:ext uri="{FF2B5EF4-FFF2-40B4-BE49-F238E27FC236}">
-                      <a16:creationId xmlns:a16="http://schemas.microsoft.com/office/drawing/2014/main" id="{69D8163F-1867-AF97-979C-E8F99AB9356E}"/>
-                    </a:ext>
-                  </a:extLst>
-                </p14:cNvPr>
-                <p14:cNvContentPartPr/>
-                <p14:nvPr/>
-              </p14:nvContentPartPr>
-              <p14:xfrm>
-                <a:off x="3637093" y="2837438"/>
-                <a:ext cx="41040" cy="191520"/>
-              </p14:xfrm>
-            </p:contentPart>
-          </mc:Choice>
-          <mc:Fallback>
-            <p:pic>
-              <p:nvPicPr>
-                <p:cNvPr id="12" name="Ink 11">
-                  <a:extLst>
-                    <a:ext uri="{FF2B5EF4-FFF2-40B4-BE49-F238E27FC236}">
-                      <a16:creationId xmlns:a16="http://schemas.microsoft.com/office/drawing/2014/main" id="{69D8163F-1867-AF97-979C-E8F99AB9356E}"/>
-                    </a:ext>
-                  </a:extLst>
-                </p:cNvPr>
-                <p:cNvPicPr/>
-                <p:nvPr/>
-              </p:nvPicPr>
-              <p:blipFill>
-                <a:blip r:embed="rId22"/>
-                <a:stretch>
-                  <a:fillRect/>
-                </a:stretch>
-              </p:blipFill>
-              <p:spPr>
-                <a:xfrm>
-                  <a:off x="3630973" y="2831318"/>
-                  <a:ext cx="53280" cy="203760"/>
-                </a:xfrm>
-                <a:prstGeom prst="rect">
-                  <a:avLst/>
-                </a:prstGeom>
-              </p:spPr>
-            </p:pic>
-          </mc:Fallback>
-        </mc:AlternateContent>
-        <mc:AlternateContent xmlns:mc="http://schemas.openxmlformats.org/markup-compatibility/2006">
-          <mc:Choice xmlns:p14="http://schemas.microsoft.com/office/powerpoint/2010/main" Requires="p14">
-            <p:contentPart p14:bwMode="auto" r:id="rId23">
-              <p14:nvContentPartPr>
-                <p14:cNvPr id="13" name="Ink 12">
-                  <a:extLst>
-                    <a:ext uri="{FF2B5EF4-FFF2-40B4-BE49-F238E27FC236}">
-                      <a16:creationId xmlns:a16="http://schemas.microsoft.com/office/drawing/2014/main" id="{106369E5-C291-D0A6-7B93-F3FCBF68CF62}"/>
-                    </a:ext>
-                  </a:extLst>
-                </p14:cNvPr>
-                <p14:cNvContentPartPr/>
-                <p14:nvPr/>
-              </p14:nvContentPartPr>
-              <p14:xfrm>
-                <a:off x="3900253" y="2898998"/>
-                <a:ext cx="55080" cy="124200"/>
-              </p14:xfrm>
-            </p:contentPart>
-          </mc:Choice>
-          <mc:Fallback>
-            <p:pic>
-              <p:nvPicPr>
-                <p:cNvPr id="13" name="Ink 12">
-                  <a:extLst>
-                    <a:ext uri="{FF2B5EF4-FFF2-40B4-BE49-F238E27FC236}">
-                      <a16:creationId xmlns:a16="http://schemas.microsoft.com/office/drawing/2014/main" id="{106369E5-C291-D0A6-7B93-F3FCBF68CF62}"/>
-                    </a:ext>
-                  </a:extLst>
-                </p:cNvPr>
-                <p:cNvPicPr/>
-                <p:nvPr/>
-              </p:nvPicPr>
-              <p:blipFill>
-                <a:blip r:embed="rId24"/>
-                <a:stretch>
-                  <a:fillRect/>
-                </a:stretch>
-              </p:blipFill>
-              <p:spPr>
-                <a:xfrm>
-                  <a:off x="3894133" y="2892878"/>
-                  <a:ext cx="67320" cy="136440"/>
-                </a:xfrm>
-                <a:prstGeom prst="rect">
-                  <a:avLst/>
-                </a:prstGeom>
-              </p:spPr>
-            </p:pic>
-          </mc:Fallback>
-        </mc:AlternateContent>
-        <mc:AlternateContent xmlns:mc="http://schemas.openxmlformats.org/markup-compatibility/2006">
-          <mc:Choice xmlns:p14="http://schemas.microsoft.com/office/powerpoint/2010/main" Requires="p14">
-            <p:contentPart p14:bwMode="auto" r:id="rId25">
-              <p14:nvContentPartPr>
-                <p14:cNvPr id="14" name="Ink 13">
-                  <a:extLst>
-                    <a:ext uri="{FF2B5EF4-FFF2-40B4-BE49-F238E27FC236}">
-                      <a16:creationId xmlns:a16="http://schemas.microsoft.com/office/drawing/2014/main" id="{7BD8A32C-24AD-753E-ED11-FD76BA20D5AF}"/>
-                    </a:ext>
-                  </a:extLst>
-                </p14:cNvPr>
-                <p14:cNvContentPartPr/>
-                <p14:nvPr/>
-              </p14:nvContentPartPr>
-              <p14:xfrm>
-                <a:off x="4199413" y="2829878"/>
-                <a:ext cx="69120" cy="153360"/>
-              </p14:xfrm>
-            </p:contentPart>
-          </mc:Choice>
-          <mc:Fallback>
-            <p:pic>
-              <p:nvPicPr>
-                <p:cNvPr id="14" name="Ink 13">
-                  <a:extLst>
-                    <a:ext uri="{FF2B5EF4-FFF2-40B4-BE49-F238E27FC236}">
-                      <a16:creationId xmlns:a16="http://schemas.microsoft.com/office/drawing/2014/main" id="{7BD8A32C-24AD-753E-ED11-FD76BA20D5AF}"/>
-                    </a:ext>
-                  </a:extLst>
-                </p:cNvPr>
-                <p:cNvPicPr/>
-                <p:nvPr/>
-              </p:nvPicPr>
-              <p:blipFill>
-                <a:blip r:embed="rId26"/>
-                <a:stretch>
-                  <a:fillRect/>
-                </a:stretch>
-              </p:blipFill>
-              <p:spPr>
-                <a:xfrm>
-                  <a:off x="4193293" y="2823758"/>
-                  <a:ext cx="81360" cy="165600"/>
-                </a:xfrm>
-                <a:prstGeom prst="rect">
-                  <a:avLst/>
-                </a:prstGeom>
-              </p:spPr>
-            </p:pic>
-          </mc:Fallback>
-        </mc:AlternateContent>
-        <mc:AlternateContent xmlns:mc="http://schemas.openxmlformats.org/markup-compatibility/2006">
-          <mc:Choice xmlns:p14="http://schemas.microsoft.com/office/powerpoint/2010/main" Requires="p14">
-            <p:contentPart p14:bwMode="auto" r:id="rId27">
-              <p14:nvContentPartPr>
-                <p14:cNvPr id="15" name="Ink 14">
-                  <a:extLst>
-                    <a:ext uri="{FF2B5EF4-FFF2-40B4-BE49-F238E27FC236}">
-                      <a16:creationId xmlns:a16="http://schemas.microsoft.com/office/drawing/2014/main" id="{74CC715D-8AB5-858E-5BCE-7203DE58DE4D}"/>
-                    </a:ext>
-                  </a:extLst>
-                </p14:cNvPr>
-                <p14:cNvContentPartPr/>
-                <p14:nvPr/>
-              </p14:nvContentPartPr>
-              <p14:xfrm>
-                <a:off x="4505053" y="2812238"/>
-                <a:ext cx="75960" cy="184320"/>
-              </p14:xfrm>
-            </p:contentPart>
-          </mc:Choice>
-          <mc:Fallback>
-            <p:pic>
-              <p:nvPicPr>
-                <p:cNvPr id="15" name="Ink 14">
-                  <a:extLst>
-                    <a:ext uri="{FF2B5EF4-FFF2-40B4-BE49-F238E27FC236}">
-                      <a16:creationId xmlns:a16="http://schemas.microsoft.com/office/drawing/2014/main" id="{74CC715D-8AB5-858E-5BCE-7203DE58DE4D}"/>
-                    </a:ext>
-                  </a:extLst>
-                </p:cNvPr>
-                <p:cNvPicPr/>
-                <p:nvPr/>
-              </p:nvPicPr>
-              <p:blipFill>
-                <a:blip r:embed="rId28"/>
-                <a:stretch>
-                  <a:fillRect/>
-                </a:stretch>
-              </p:blipFill>
-              <p:spPr>
-                <a:xfrm>
-                  <a:off x="4498933" y="2806118"/>
-                  <a:ext cx="88200" cy="196560"/>
-                </a:xfrm>
-                <a:prstGeom prst="rect">
-                  <a:avLst/>
-                </a:prstGeom>
-              </p:spPr>
-            </p:pic>
-          </mc:Fallback>
-        </mc:AlternateContent>
-        <mc:AlternateContent xmlns:mc="http://schemas.openxmlformats.org/markup-compatibility/2006">
-          <mc:Choice xmlns:p14="http://schemas.microsoft.com/office/powerpoint/2010/main" Requires="p14">
-            <p:contentPart p14:bwMode="auto" r:id="rId29">
-              <p14:nvContentPartPr>
-                <p14:cNvPr id="16" name="Ink 15">
-                  <a:extLst>
-                    <a:ext uri="{FF2B5EF4-FFF2-40B4-BE49-F238E27FC236}">
-                      <a16:creationId xmlns:a16="http://schemas.microsoft.com/office/drawing/2014/main" id="{659AE97B-AA6F-1C85-ED78-5C18361C8888}"/>
-                    </a:ext>
-                  </a:extLst>
-                </p14:cNvPr>
-                <p14:cNvContentPartPr/>
-                <p14:nvPr/>
-              </p14:nvContentPartPr>
-              <p14:xfrm>
-                <a:off x="4804933" y="2796398"/>
-                <a:ext cx="92880" cy="154080"/>
-              </p14:xfrm>
-            </p:contentPart>
-          </mc:Choice>
-          <mc:Fallback>
-            <p:pic>
-              <p:nvPicPr>
-                <p:cNvPr id="16" name="Ink 15">
-                  <a:extLst>
-                    <a:ext uri="{FF2B5EF4-FFF2-40B4-BE49-F238E27FC236}">
-                      <a16:creationId xmlns:a16="http://schemas.microsoft.com/office/drawing/2014/main" id="{659AE97B-AA6F-1C85-ED78-5C18361C8888}"/>
-                    </a:ext>
-                  </a:extLst>
-                </p:cNvPr>
-                <p:cNvPicPr/>
-                <p:nvPr/>
-              </p:nvPicPr>
-              <p:blipFill>
-                <a:blip r:embed="rId30"/>
-                <a:stretch>
-                  <a:fillRect/>
-                </a:stretch>
-              </p:blipFill>
-              <p:spPr>
-                <a:xfrm>
-                  <a:off x="4798813" y="2790278"/>
-                  <a:ext cx="105120" cy="166320"/>
-                </a:xfrm>
-                <a:prstGeom prst="rect">
-                  <a:avLst/>
-                </a:prstGeom>
-              </p:spPr>
-            </p:pic>
-          </mc:Fallback>
-        </mc:AlternateContent>
-        <mc:AlternateContent xmlns:mc="http://schemas.openxmlformats.org/markup-compatibility/2006">
-          <mc:Choice xmlns:p14="http://schemas.microsoft.com/office/powerpoint/2010/main" Requires="p14">
-            <p:contentPart p14:bwMode="auto" r:id="rId31">
-              <p14:nvContentPartPr>
-                <p14:cNvPr id="17" name="Ink 16">
-                  <a:extLst>
-                    <a:ext uri="{FF2B5EF4-FFF2-40B4-BE49-F238E27FC236}">
-                      <a16:creationId xmlns:a16="http://schemas.microsoft.com/office/drawing/2014/main" id="{F4B00B80-5E0C-29EA-DB0E-F152B04FC0E5}"/>
-                    </a:ext>
-                  </a:extLst>
-                </p14:cNvPr>
-                <p14:cNvContentPartPr/>
-                <p14:nvPr/>
-              </p14:nvContentPartPr>
-              <p14:xfrm>
-                <a:off x="5095453" y="2790278"/>
-                <a:ext cx="58680" cy="171720"/>
-              </p14:xfrm>
-            </p:contentPart>
-          </mc:Choice>
-          <mc:Fallback>
-            <p:pic>
-              <p:nvPicPr>
-                <p:cNvPr id="17" name="Ink 16">
-                  <a:extLst>
-                    <a:ext uri="{FF2B5EF4-FFF2-40B4-BE49-F238E27FC236}">
-                      <a16:creationId xmlns:a16="http://schemas.microsoft.com/office/drawing/2014/main" id="{F4B00B80-5E0C-29EA-DB0E-F152B04FC0E5}"/>
-                    </a:ext>
-                  </a:extLst>
-                </p:cNvPr>
-                <p:cNvPicPr/>
-                <p:nvPr/>
-              </p:nvPicPr>
-              <p:blipFill>
-                <a:blip r:embed="rId32"/>
-                <a:stretch>
-                  <a:fillRect/>
-                </a:stretch>
-              </p:blipFill>
-              <p:spPr>
-                <a:xfrm>
-                  <a:off x="5089333" y="2784158"/>
-                  <a:ext cx="70920" cy="183960"/>
-                </a:xfrm>
-                <a:prstGeom prst="rect">
-                  <a:avLst/>
-                </a:prstGeom>
-              </p:spPr>
-            </p:pic>
-          </mc:Fallback>
-        </mc:AlternateContent>
-        <mc:AlternateContent xmlns:mc="http://schemas.openxmlformats.org/markup-compatibility/2006">
-          <mc:Choice xmlns:p14="http://schemas.microsoft.com/office/powerpoint/2010/main" Requires="p14">
-            <p:contentPart p14:bwMode="auto" r:id="rId33">
-              <p14:nvContentPartPr>
-                <p14:cNvPr id="18" name="Ink 17">
-                  <a:extLst>
-                    <a:ext uri="{FF2B5EF4-FFF2-40B4-BE49-F238E27FC236}">
-                      <a16:creationId xmlns:a16="http://schemas.microsoft.com/office/drawing/2014/main" id="{A6B49830-5580-A509-52D3-C028A0725562}"/>
-                    </a:ext>
-                  </a:extLst>
-                </p14:cNvPr>
-                <p14:cNvContentPartPr/>
-                <p14:nvPr/>
-              </p14:nvContentPartPr>
-              <p14:xfrm>
-                <a:off x="5319013" y="2841398"/>
-                <a:ext cx="104040" cy="229680"/>
-              </p14:xfrm>
-            </p:contentPart>
-          </mc:Choice>
-          <mc:Fallback>
-            <p:pic>
-              <p:nvPicPr>
-                <p:cNvPr id="18" name="Ink 17">
-                  <a:extLst>
-                    <a:ext uri="{FF2B5EF4-FFF2-40B4-BE49-F238E27FC236}">
-                      <a16:creationId xmlns:a16="http://schemas.microsoft.com/office/drawing/2014/main" id="{A6B49830-5580-A509-52D3-C028A0725562}"/>
-                    </a:ext>
-                  </a:extLst>
-                </p:cNvPr>
-                <p:cNvPicPr/>
-                <p:nvPr/>
-              </p:nvPicPr>
-              <p:blipFill>
-                <a:blip r:embed="rId34"/>
-                <a:stretch>
-                  <a:fillRect/>
-                </a:stretch>
-              </p:blipFill>
-              <p:spPr>
-                <a:xfrm>
-                  <a:off x="5312893" y="2835278"/>
-                  <a:ext cx="116280" cy="241920"/>
-                </a:xfrm>
-                <a:prstGeom prst="rect">
-                  <a:avLst/>
-                </a:prstGeom>
-              </p:spPr>
-            </p:pic>
-          </mc:Fallback>
-        </mc:AlternateContent>
-        <mc:AlternateContent xmlns:mc="http://schemas.openxmlformats.org/markup-compatibility/2006">
-          <mc:Choice xmlns:p14="http://schemas.microsoft.com/office/powerpoint/2010/main" Requires="p14">
-            <p:contentPart p14:bwMode="auto" r:id="rId35">
-              <p14:nvContentPartPr>
-                <p14:cNvPr id="20" name="Ink 19">
-                  <a:extLst>
-                    <a:ext uri="{FF2B5EF4-FFF2-40B4-BE49-F238E27FC236}">
-                      <a16:creationId xmlns:a16="http://schemas.microsoft.com/office/drawing/2014/main" id="{A9E4511E-9A1B-CE02-D5AE-24AE6626BED3}"/>
-                    </a:ext>
-                  </a:extLst>
-                </p14:cNvPr>
-                <p14:cNvContentPartPr/>
-                <p14:nvPr/>
-              </p14:nvContentPartPr>
-              <p14:xfrm>
-                <a:off x="5407213" y="2829878"/>
-                <a:ext cx="63360" cy="162000"/>
-              </p14:xfrm>
-            </p:contentPart>
-          </mc:Choice>
-          <mc:Fallback>
-            <p:pic>
-              <p:nvPicPr>
-                <p:cNvPr id="20" name="Ink 19">
-                  <a:extLst>
-                    <a:ext uri="{FF2B5EF4-FFF2-40B4-BE49-F238E27FC236}">
-                      <a16:creationId xmlns:a16="http://schemas.microsoft.com/office/drawing/2014/main" id="{A9E4511E-9A1B-CE02-D5AE-24AE6626BED3}"/>
-                    </a:ext>
-                  </a:extLst>
-                </p:cNvPr>
-                <p:cNvPicPr/>
-                <p:nvPr/>
-              </p:nvPicPr>
-              <p:blipFill>
-                <a:blip r:embed="rId36"/>
-                <a:stretch>
-                  <a:fillRect/>
-                </a:stretch>
-              </p:blipFill>
-              <p:spPr>
-                <a:xfrm>
-                  <a:off x="5401093" y="2823758"/>
-                  <a:ext cx="75600" cy="174240"/>
-                </a:xfrm>
-                <a:prstGeom prst="rect">
-                  <a:avLst/>
-                </a:prstGeom>
-              </p:spPr>
-            </p:pic>
-          </mc:Fallback>
-        </mc:AlternateContent>
-      </p:grpSp>
     </p:spTree>
   </p:cSld>
   <p:clrMapOvr>
@@ -21392,7 +19832,7 @@
           <a:prstGeom prst="straightConnector1">
             <a:avLst/>
           </a:prstGeom>
-          <a:ln>
+          <a:ln w="28575">
             <a:solidFill>
               <a:schemeClr val="accent2"/>
             </a:solidFill>
@@ -23945,8 +22385,8 @@
         </p:blipFill>
         <p:spPr>
           <a:xfrm>
-            <a:off x="1665802" y="1431769"/>
-            <a:ext cx="5657850" cy="3400425"/>
+            <a:off x="3207349" y="1366093"/>
+            <a:ext cx="5762671" cy="3532204"/>
           </a:xfrm>
           <a:prstGeom prst="rect">
             <a:avLst/>
@@ -23957,210 +22397,137 @@
           </a:ln>
         </p:spPr>
       </p:pic>
-      <mc:AlternateContent xmlns:mc="http://schemas.openxmlformats.org/markup-compatibility/2006">
-        <mc:Choice xmlns:p14="http://schemas.microsoft.com/office/powerpoint/2010/main" Requires="p14">
-          <p:contentPart p14:bwMode="auto" r:id="rId4">
-            <p14:nvContentPartPr>
-              <p14:cNvPr id="2" name="Ink 1">
-                <a:extLst>
-                  <a:ext uri="{FF2B5EF4-FFF2-40B4-BE49-F238E27FC236}">
-                    <a16:creationId xmlns:a16="http://schemas.microsoft.com/office/drawing/2014/main" id="{61BEB62F-8CEC-9ABA-505E-4C8F9A4664D6}"/>
-                  </a:ext>
-                </a:extLst>
-              </p14:cNvPr>
-              <p14:cNvContentPartPr/>
-              <p14:nvPr/>
-            </p14:nvContentPartPr>
-            <p14:xfrm>
-              <a:off x="1412293" y="1331198"/>
-              <a:ext cx="204840" cy="1347480"/>
-            </p14:xfrm>
-          </p:contentPart>
-        </mc:Choice>
-        <mc:Fallback>
-          <p:pic>
-            <p:nvPicPr>
-              <p:cNvPr id="2" name="Ink 1">
-                <a:extLst>
-                  <a:ext uri="{FF2B5EF4-FFF2-40B4-BE49-F238E27FC236}">
-                    <a16:creationId xmlns:a16="http://schemas.microsoft.com/office/drawing/2014/main" id="{61BEB62F-8CEC-9ABA-505E-4C8F9A4664D6}"/>
-                  </a:ext>
-                </a:extLst>
-              </p:cNvPr>
-              <p:cNvPicPr/>
-              <p:nvPr/>
-            </p:nvPicPr>
-            <p:blipFill>
-              <a:blip r:embed="rId5"/>
-              <a:stretch>
-                <a:fillRect/>
-              </a:stretch>
-            </p:blipFill>
-            <p:spPr>
-              <a:xfrm>
-                <a:off x="1406173" y="1325078"/>
-                <a:ext cx="217080" cy="1359720"/>
-              </a:xfrm>
-              <a:prstGeom prst="rect">
-                <a:avLst/>
-              </a:prstGeom>
-            </p:spPr>
-          </p:pic>
-        </mc:Fallback>
-      </mc:AlternateContent>
-      <mc:AlternateContent xmlns:mc="http://schemas.openxmlformats.org/markup-compatibility/2006">
-        <mc:Choice xmlns:p14="http://schemas.microsoft.com/office/powerpoint/2010/main" Requires="p14">
-          <p:contentPart p14:bwMode="auto" r:id="rId6">
-            <p14:nvContentPartPr>
-              <p14:cNvPr id="3" name="Ink 2">
-                <a:extLst>
-                  <a:ext uri="{FF2B5EF4-FFF2-40B4-BE49-F238E27FC236}">
-                    <a16:creationId xmlns:a16="http://schemas.microsoft.com/office/drawing/2014/main" id="{DB186C97-1C67-BBB1-E855-37DAB8A23615}"/>
-                  </a:ext>
-                </a:extLst>
-              </p14:cNvPr>
-              <p14:cNvContentPartPr/>
-              <p14:nvPr/>
-            </p14:nvContentPartPr>
-            <p14:xfrm>
-              <a:off x="1513813" y="3432518"/>
-              <a:ext cx="178200" cy="1082160"/>
-            </p14:xfrm>
-          </p:contentPart>
-        </mc:Choice>
-        <mc:Fallback>
-          <p:pic>
-            <p:nvPicPr>
-              <p:cNvPr id="3" name="Ink 2">
-                <a:extLst>
-                  <a:ext uri="{FF2B5EF4-FFF2-40B4-BE49-F238E27FC236}">
-                    <a16:creationId xmlns:a16="http://schemas.microsoft.com/office/drawing/2014/main" id="{DB186C97-1C67-BBB1-E855-37DAB8A23615}"/>
-                  </a:ext>
-                </a:extLst>
-              </p:cNvPr>
-              <p:cNvPicPr/>
-              <p:nvPr/>
-            </p:nvPicPr>
-            <p:blipFill>
-              <a:blip r:embed="rId7"/>
-              <a:stretch>
-                <a:fillRect/>
-              </a:stretch>
-            </p:blipFill>
-            <p:spPr>
-              <a:xfrm>
-                <a:off x="1507693" y="3426398"/>
-                <a:ext cx="190440" cy="1094400"/>
-              </a:xfrm>
-              <a:prstGeom prst="rect">
-                <a:avLst/>
-              </a:prstGeom>
-            </p:spPr>
-          </p:pic>
-        </mc:Fallback>
-      </mc:AlternateContent>
-      <mc:AlternateContent xmlns:mc="http://schemas.openxmlformats.org/markup-compatibility/2006">
-        <mc:Choice xmlns:p14="http://schemas.microsoft.com/office/powerpoint/2010/main" Requires="p14">
-          <p:contentPart p14:bwMode="auto" r:id="rId8">
-            <p14:nvContentPartPr>
-              <p14:cNvPr id="4" name="Ink 3">
-                <a:extLst>
-                  <a:ext uri="{FF2B5EF4-FFF2-40B4-BE49-F238E27FC236}">
-                    <a16:creationId xmlns:a16="http://schemas.microsoft.com/office/drawing/2014/main" id="{6D57C7DB-EFB1-88F9-0EF2-A9980A5BF594}"/>
-                  </a:ext>
-                </a:extLst>
-              </p14:cNvPr>
-              <p14:cNvContentPartPr/>
-              <p14:nvPr/>
-            </p14:nvContentPartPr>
-            <p14:xfrm>
-              <a:off x="7351213" y="1795598"/>
-              <a:ext cx="188640" cy="901080"/>
-            </p14:xfrm>
-          </p:contentPart>
-        </mc:Choice>
-        <mc:Fallback>
-          <p:pic>
-            <p:nvPicPr>
-              <p:cNvPr id="4" name="Ink 3">
-                <a:extLst>
-                  <a:ext uri="{FF2B5EF4-FFF2-40B4-BE49-F238E27FC236}">
-                    <a16:creationId xmlns:a16="http://schemas.microsoft.com/office/drawing/2014/main" id="{6D57C7DB-EFB1-88F9-0EF2-A9980A5BF594}"/>
-                  </a:ext>
-                </a:extLst>
-              </p:cNvPr>
-              <p:cNvPicPr/>
-              <p:nvPr/>
-            </p:nvPicPr>
-            <p:blipFill>
-              <a:blip r:embed="rId9"/>
-              <a:stretch>
-                <a:fillRect/>
-              </a:stretch>
-            </p:blipFill>
-            <p:spPr>
-              <a:xfrm>
-                <a:off x="7345093" y="1789478"/>
-                <a:ext cx="200880" cy="913320"/>
-              </a:xfrm>
-              <a:prstGeom prst="rect">
-                <a:avLst/>
-              </a:prstGeom>
-            </p:spPr>
-          </p:pic>
-        </mc:Fallback>
-      </mc:AlternateContent>
-      <mc:AlternateContent xmlns:mc="http://schemas.openxmlformats.org/markup-compatibility/2006">
-        <mc:Choice xmlns:p14="http://schemas.microsoft.com/office/powerpoint/2010/main" Requires="p14">
-          <p:contentPart p14:bwMode="auto" r:id="rId10">
-            <p14:nvContentPartPr>
-              <p14:cNvPr id="5" name="Ink 4">
-                <a:extLst>
-                  <a:ext uri="{FF2B5EF4-FFF2-40B4-BE49-F238E27FC236}">
-                    <a16:creationId xmlns:a16="http://schemas.microsoft.com/office/drawing/2014/main" id="{33F455F8-6173-F745-4E1C-4015D681A74E}"/>
-                  </a:ext>
-                </a:extLst>
-              </p14:cNvPr>
-              <p14:cNvContentPartPr/>
-              <p14:nvPr/>
-            </p14:nvContentPartPr>
-            <p14:xfrm>
-              <a:off x="7471813" y="3501278"/>
-              <a:ext cx="212400" cy="901440"/>
-            </p14:xfrm>
-          </p:contentPart>
-        </mc:Choice>
-        <mc:Fallback>
-          <p:pic>
-            <p:nvPicPr>
-              <p:cNvPr id="5" name="Ink 4">
-                <a:extLst>
-                  <a:ext uri="{FF2B5EF4-FFF2-40B4-BE49-F238E27FC236}">
-                    <a16:creationId xmlns:a16="http://schemas.microsoft.com/office/drawing/2014/main" id="{33F455F8-6173-F745-4E1C-4015D681A74E}"/>
-                  </a:ext>
-                </a:extLst>
-              </p:cNvPr>
-              <p:cNvPicPr/>
-              <p:nvPr/>
-            </p:nvPicPr>
-            <p:blipFill>
-              <a:blip r:embed="rId11"/>
-              <a:stretch>
-                <a:fillRect/>
-              </a:stretch>
-            </p:blipFill>
-            <p:spPr>
-              <a:xfrm>
-                <a:off x="7465693" y="3495158"/>
-                <a:ext cx="224640" cy="913680"/>
-              </a:xfrm>
-              <a:prstGeom prst="rect">
-                <a:avLst/>
-              </a:prstGeom>
-            </p:spPr>
-          </p:pic>
-        </mc:Fallback>
-      </mc:AlternateContent>
+      <p:sp>
+        <p:nvSpPr>
+          <p:cNvPr id="7" name="TextBox 6">
+            <a:extLst>
+              <a:ext uri="{FF2B5EF4-FFF2-40B4-BE49-F238E27FC236}">
+                <a16:creationId xmlns:a16="http://schemas.microsoft.com/office/drawing/2014/main" id="{0CEBF2D2-C42F-D99B-6036-FEBB7FA07C62}"/>
+              </a:ext>
+            </a:extLst>
+          </p:cNvPr>
+          <p:cNvSpPr txBox="1"/>
+          <p:nvPr/>
+        </p:nvSpPr>
+        <p:spPr>
+          <a:xfrm>
+            <a:off x="-1" y="1727233"/>
+            <a:ext cx="3207351" cy="3293209"/>
+          </a:xfrm>
+          <a:prstGeom prst="rect">
+            <a:avLst/>
+          </a:prstGeom>
+          <a:noFill/>
+        </p:spPr>
+        <p:txBody>
+          <a:bodyPr wrap="square">
+            <a:spAutoFit/>
+          </a:bodyPr>
+          <a:lstStyle/>
+          <a:p>
+            <a:pPr algn="ctr">
+              <a:buNone/>
+            </a:pPr>
+            <a:r>
+              <a:rPr lang="es-ES" sz="1600" dirty="0"/>
+              <a:t>Aquí me pongo a cantar </a:t>
+            </a:r>
+            <a:br>
+              <a:rPr lang="es-ES" sz="1600" dirty="0"/>
+            </a:br>
+            <a:r>
+              <a:rPr lang="es-ES" sz="1600" dirty="0"/>
+              <a:t>al compás de la </a:t>
+            </a:r>
+            <a:r>
+              <a:rPr lang="es-ES" sz="1600" dirty="0" err="1"/>
+              <a:t>vigüela</a:t>
+            </a:r>
+            <a:r>
+              <a:rPr lang="es-ES" sz="1600" dirty="0"/>
+              <a:t>, </a:t>
+            </a:r>
+            <a:br>
+              <a:rPr lang="es-ES" sz="1600" dirty="0"/>
+            </a:br>
+            <a:r>
+              <a:rPr lang="es-ES" sz="1600" dirty="0"/>
+              <a:t>que el hombre que lo desvela </a:t>
+            </a:r>
+            <a:br>
+              <a:rPr lang="es-ES" sz="1600" dirty="0"/>
+            </a:br>
+            <a:r>
+              <a:rPr lang="es-ES" sz="1600" dirty="0"/>
+              <a:t>una pena </a:t>
+            </a:r>
+            <a:r>
+              <a:rPr lang="es-ES" sz="1600" dirty="0" err="1"/>
+              <a:t>estraordinaria</a:t>
+            </a:r>
+            <a:r>
+              <a:rPr lang="es-ES" sz="1600" dirty="0"/>
+              <a:t>, </a:t>
+            </a:r>
+            <a:br>
+              <a:rPr lang="es-ES" sz="1600" dirty="0"/>
+            </a:br>
+            <a:r>
+              <a:rPr lang="es-ES" sz="1600" dirty="0"/>
+              <a:t>como la ave solitaria con el cantar se consuela.</a:t>
+            </a:r>
+          </a:p>
+          <a:p>
+            <a:pPr algn="ctr">
+              <a:buNone/>
+            </a:pPr>
+            <a:endParaRPr lang="es-ES" sz="1600" dirty="0"/>
+          </a:p>
+          <a:p>
+            <a:pPr algn="ctr">
+              <a:buNone/>
+            </a:pPr>
+            <a:r>
+              <a:rPr lang="es-ES" sz="1600" dirty="0"/>
+              <a:t>Pido a los Santos del Cielo </a:t>
+            </a:r>
+            <a:br>
+              <a:rPr lang="es-ES" sz="1600" dirty="0"/>
+            </a:br>
+            <a:r>
+              <a:rPr lang="es-ES" sz="1600" dirty="0"/>
+              <a:t>que ayuden mi pensamiento, </a:t>
+            </a:r>
+            <a:br>
+              <a:rPr lang="es-ES" sz="1600" dirty="0"/>
+            </a:br>
+            <a:r>
+              <a:rPr lang="es-ES" sz="1600" dirty="0"/>
+              <a:t>les pido en este momento que voy a cantar mi historia.</a:t>
+            </a:r>
+          </a:p>
+          <a:p>
+            <a:pPr algn="ctr">
+              <a:buNone/>
+            </a:pPr>
+            <a:endParaRPr lang="es-ES" sz="1600" dirty="0"/>
+          </a:p>
+          <a:p>
+            <a:pPr algn="ctr">
+              <a:buNone/>
+            </a:pPr>
+            <a:r>
+              <a:rPr lang="es-ES" sz="1600" dirty="0"/>
+              <a:t>“Martín Fierro” J. </a:t>
+            </a:r>
+            <a:r>
+              <a:rPr lang="es-ES" sz="1600" dirty="0" err="1"/>
+              <a:t>Hernandez</a:t>
+            </a:r>
+            <a:endParaRPr lang="es-ES" sz="1600" dirty="0"/>
+          </a:p>
+        </p:txBody>
+      </p:sp>
     </p:spTree>
   </p:cSld>
   <p:clrMapOvr>

</xml_diff>

<commit_message>
material clase 6 actualizado
</commit_message>
<xml_diff>
--- a/clase_7/teoria/Clase_7.pptx
+++ b/clase_7/teoria/Clase_7.pptx
@@ -296,7 +296,7 @@
       </p15:sldGuideLst>
     </p:ext>
     <p:ext uri="GoogleSlidesCustomDataVersion2">
-      <go:slidesCustomData xmlns:go="http://customooxmlschemas.google.com/" xmlns:ahyp="http://schemas.microsoft.com/office/drawing/2018/hyperlinkcolor" xmlns:p15="http://schemas.microsoft.com/office/powerpoint/2012/main" xmlns:p14="http://schemas.microsoft.com/office/powerpoint/2010/main" xmlns:com="http://schemas.openxmlformats.org/drawingml/2006/compatibility" xmlns:pvml="urn:schemas-microsoft-com:office:powerpoint" xmlns:v="urn:schemas-microsoft-com:vml" xmlns:o="urn:schemas-microsoft-com:office:office" xmlns:dgm="http://schemas.openxmlformats.org/drawingml/2006/diagram" xmlns:c="http://schemas.openxmlformats.org/drawingml/2006/chart" xmlns:mv="urn:schemas-microsoft-com:mac:vml" xmlns:mc="http://schemas.openxmlformats.org/markup-compatibility/2006" xmlns="" r:id="rId35" roundtripDataSignature="AMtx7mjFLyGGbKtZ6MKWK8o6r1g77If8Vw=="/>
+      <go:slidesCustomData xmlns="" xmlns:mc="http://schemas.openxmlformats.org/markup-compatibility/2006" xmlns:mv="urn:schemas-microsoft-com:mac:vml" xmlns:c="http://schemas.openxmlformats.org/drawingml/2006/chart" xmlns:dgm="http://schemas.openxmlformats.org/drawingml/2006/diagram" xmlns:o="urn:schemas-microsoft-com:office:office" xmlns:v="urn:schemas-microsoft-com:vml" xmlns:pvml="urn:schemas-microsoft-com:office:powerpoint" xmlns:com="http://schemas.openxmlformats.org/drawingml/2006/compatibility" xmlns:p14="http://schemas.microsoft.com/office/powerpoint/2010/main" xmlns:p15="http://schemas.microsoft.com/office/powerpoint/2012/main" xmlns:ahyp="http://schemas.microsoft.com/office/drawing/2018/hyperlinkcolor" xmlns:go="http://customooxmlschemas.google.com/" r:id="rId35" roundtripDataSignature="AMtx7mjFLyGGbKtZ6MKWK8o6r1g77If8Vw=="/>
     </p:ext>
   </p:extLst>
 </p:presentation>
@@ -4913,7 +4913,7 @@
             </a:pPr>
             <a:fld id="{00000000-1234-1234-1234-123412341234}" type="slidenum">
               <a:rPr lang="en"/>
-              <a:t>‹#›</a:t>
+              <a:t>‹Nº›</a:t>
             </a:fld>
             <a:endParaRPr/>
           </a:p>
@@ -5612,7 +5612,7 @@
             </a:pPr>
             <a:fld id="{00000000-1234-1234-1234-123412341234}" type="slidenum">
               <a:rPr lang="en"/>
-              <a:t>‹#›</a:t>
+              <a:t>‹Nº›</a:t>
             </a:fld>
             <a:endParaRPr/>
           </a:p>
@@ -5926,7 +5926,7 @@
             </a:pPr>
             <a:fld id="{00000000-1234-1234-1234-123412341234}" type="slidenum">
               <a:rPr lang="en"/>
-              <a:t>‹#›</a:t>
+              <a:t>‹Nº›</a:t>
             </a:fld>
             <a:endParaRPr/>
           </a:p>
@@ -7118,7 +7118,7 @@
             </a:pPr>
             <a:fld id="{00000000-1234-1234-1234-123412341234}" type="slidenum">
               <a:rPr lang="en"/>
-              <a:t>‹#›</a:t>
+              <a:t>‹Nº›</a:t>
             </a:fld>
             <a:endParaRPr/>
           </a:p>
@@ -7870,7 +7870,7 @@
             </a:pPr>
             <a:fld id="{00000000-1234-1234-1234-123412341234}" type="slidenum">
               <a:rPr lang="en"/>
-              <a:t>‹#›</a:t>
+              <a:t>‹Nº›</a:t>
             </a:fld>
             <a:endParaRPr/>
           </a:p>
@@ -8462,7 +8462,7 @@
             </a:pPr>
             <a:fld id="{00000000-1234-1234-1234-123412341234}" type="slidenum">
               <a:rPr lang="en"/>
-              <a:t>‹#›</a:t>
+              <a:t>‹Nº›</a:t>
             </a:fld>
             <a:endParaRPr/>
           </a:p>
@@ -8928,7 +8928,7 @@
             </a:pPr>
             <a:fld id="{00000000-1234-1234-1234-123412341234}" type="slidenum">
               <a:rPr lang="en"/>
-              <a:t>‹#›</a:t>
+              <a:t>‹Nº›</a:t>
             </a:fld>
             <a:endParaRPr/>
           </a:p>
@@ -9840,7 +9840,7 @@
             </a:pPr>
             <a:fld id="{00000000-1234-1234-1234-123412341234}" type="slidenum">
               <a:rPr lang="en"/>
-              <a:t>‹#›</a:t>
+              <a:t>‹Nº›</a:t>
             </a:fld>
             <a:endParaRPr/>
           </a:p>
@@ -10655,7 +10655,7 @@
             </a:pPr>
             <a:fld id="{00000000-1234-1234-1234-123412341234}" type="slidenum">
               <a:rPr lang="en"/>
-              <a:t>‹#›</a:t>
+              <a:t>‹Nº›</a:t>
             </a:fld>
             <a:endParaRPr/>
           </a:p>
@@ -11121,7 +11121,7 @@
             </a:pPr>
             <a:fld id="{00000000-1234-1234-1234-123412341234}" type="slidenum">
               <a:rPr lang="en"/>
-              <a:t>‹#›</a:t>
+              <a:t>‹Nº›</a:t>
             </a:fld>
             <a:endParaRPr/>
           </a:p>
@@ -12159,7 +12159,7 @@
             </a:pPr>
             <a:fld id="{00000000-1234-1234-1234-123412341234}" type="slidenum">
               <a:rPr lang="en"/>
-              <a:t>‹#›</a:t>
+              <a:t>‹Nº›</a:t>
             </a:fld>
             <a:endParaRPr/>
           </a:p>
@@ -12646,7 +12646,7 @@
             </a:pPr>
             <a:fld id="{00000000-1234-1234-1234-123412341234}" type="slidenum">
               <a:rPr lang="en"/>
-              <a:t>‹#›</a:t>
+              <a:t>‹Nº›</a:t>
             </a:fld>
             <a:endParaRPr/>
           </a:p>
@@ -13496,7 +13496,7 @@
             </a:pPr>
             <a:fld id="{00000000-1234-1234-1234-123412341234}" type="slidenum">
               <a:rPr lang="en"/>
-              <a:t>‹#›</a:t>
+              <a:t>‹Nº›</a:t>
             </a:fld>
             <a:endParaRPr/>
           </a:p>
@@ -14374,7 +14374,7 @@
         </p:spPr>
         <p:txBody>
           <a:bodyPr spcFirstLastPara="1" wrap="square" lIns="91425" tIns="91425" rIns="91425" bIns="91425" anchor="t" anchorCtr="0">
-            <a:normAutofit fontScale="85000" lnSpcReduction="20000"/>
+            <a:normAutofit/>
           </a:bodyPr>
           <a:lstStyle/>
           <a:p>
@@ -14414,29 +14414,6 @@
             <a:r>
               <a:rPr lang="pt-BR" sz="2600" dirty="0"/>
               <a:t>Marcos Maillot</a:t>
-            </a:r>
-          </a:p>
-          <a:p>
-            <a:pPr marL="0" lvl="0" indent="0" algn="l" rtl="0">
-              <a:spcBef>
-                <a:spcPts val="0"/>
-              </a:spcBef>
-              <a:spcAft>
-                <a:spcPts val="0"/>
-              </a:spcAft>
-              <a:buNone/>
-            </a:pPr>
-            <a:r>
-              <a:rPr lang="pt-BR" sz="2600" dirty="0"/>
-              <a:t>		</a:t>
-            </a:r>
-            <a:r>
-              <a:rPr lang="pt-BR" sz="2600" dirty="0" err="1"/>
-              <a:t>Antonio</a:t>
-            </a:r>
-            <a:r>
-              <a:rPr lang="pt-BR" sz="2600" dirty="0"/>
-              <a:t> Zarauz</a:t>
             </a:r>
           </a:p>
           <a:p>

</xml_diff>

<commit_message>
material clase 7 actualizado
</commit_message>
<xml_diff>
--- a/clase_7/teoria/Clase_7.pptx
+++ b/clase_7/teoria/Clase_7.pptx
@@ -5,7 +5,7 @@
     <p:sldMasterId id="2147483648" r:id="rId1"/>
   </p:sldMasterIdLst>
   <p:notesMasterIdLst>
-    <p:notesMasterId r:id="rId29"/>
+    <p:notesMasterId r:id="rId32"/>
   </p:notesMasterIdLst>
   <p:sldIdLst>
     <p:sldId id="256" r:id="rId2"/>
@@ -24,31 +24,34 @@
     <p:sldId id="266" r:id="rId15"/>
     <p:sldId id="267" r:id="rId16"/>
     <p:sldId id="268" r:id="rId17"/>
-    <p:sldId id="269" r:id="rId18"/>
-    <p:sldId id="272" r:id="rId19"/>
-    <p:sldId id="273" r:id="rId20"/>
-    <p:sldId id="274" r:id="rId21"/>
-    <p:sldId id="275" r:id="rId22"/>
-    <p:sldId id="276" r:id="rId23"/>
-    <p:sldId id="282" r:id="rId24"/>
-    <p:sldId id="277" r:id="rId25"/>
-    <p:sldId id="278" r:id="rId26"/>
-    <p:sldId id="279" r:id="rId27"/>
-    <p:sldId id="280" r:id="rId28"/>
+    <p:sldId id="285" r:id="rId18"/>
+    <p:sldId id="284" r:id="rId19"/>
+    <p:sldId id="286" r:id="rId20"/>
+    <p:sldId id="269" r:id="rId21"/>
+    <p:sldId id="272" r:id="rId22"/>
+    <p:sldId id="273" r:id="rId23"/>
+    <p:sldId id="274" r:id="rId24"/>
+    <p:sldId id="275" r:id="rId25"/>
+    <p:sldId id="276" r:id="rId26"/>
+    <p:sldId id="282" r:id="rId27"/>
+    <p:sldId id="277" r:id="rId28"/>
+    <p:sldId id="278" r:id="rId29"/>
+    <p:sldId id="279" r:id="rId30"/>
+    <p:sldId id="280" r:id="rId31"/>
   </p:sldIdLst>
   <p:sldSz cx="9144000" cy="5143500" type="screen16x9"/>
   <p:notesSz cx="6858000" cy="9144000"/>
   <p:embeddedFontLst>
     <p:embeddedFont>
       <p:font typeface="Cambria Math" panose="02040503050406030204" pitchFamily="18" charset="0"/>
-      <p:regular r:id="rId30"/>
+      <p:regular r:id="rId33"/>
     </p:embeddedFont>
     <p:embeddedFont>
       <p:font typeface="Roboto" panose="02000000000000000000" pitchFamily="2" charset="0"/>
-      <p:regular r:id="rId31"/>
-      <p:bold r:id="rId32"/>
-      <p:italic r:id="rId33"/>
-      <p:boldItalic r:id="rId34"/>
+      <p:regular r:id="rId34"/>
+      <p:bold r:id="rId35"/>
+      <p:italic r:id="rId36"/>
+      <p:boldItalic r:id="rId37"/>
     </p:embeddedFont>
   </p:embeddedFontLst>
   <p:defaultTextStyle>
@@ -296,7 +299,7 @@
       </p15:sldGuideLst>
     </p:ext>
     <p:ext uri="GoogleSlidesCustomDataVersion2">
-      <go:slidesCustomData xmlns="" xmlns:mc="http://schemas.openxmlformats.org/markup-compatibility/2006" xmlns:mv="urn:schemas-microsoft-com:mac:vml" xmlns:c="http://schemas.openxmlformats.org/drawingml/2006/chart" xmlns:dgm="http://schemas.openxmlformats.org/drawingml/2006/diagram" xmlns:o="urn:schemas-microsoft-com:office:office" xmlns:v="urn:schemas-microsoft-com:vml" xmlns:pvml="urn:schemas-microsoft-com:office:powerpoint" xmlns:com="http://schemas.openxmlformats.org/drawingml/2006/compatibility" xmlns:p14="http://schemas.microsoft.com/office/powerpoint/2010/main" xmlns:p15="http://schemas.microsoft.com/office/powerpoint/2012/main" xmlns:ahyp="http://schemas.microsoft.com/office/drawing/2018/hyperlinkcolor" xmlns:go="http://customooxmlschemas.google.com/" r:id="rId35" roundtripDataSignature="AMtx7mjFLyGGbKtZ6MKWK8o6r1g77If8Vw=="/>
+      <go:slidesCustomData xmlns:go="http://customooxmlschemas.google.com/" xmlns:ahyp="http://schemas.microsoft.com/office/drawing/2018/hyperlinkcolor" xmlns:p15="http://schemas.microsoft.com/office/powerpoint/2012/main" xmlns:p14="http://schemas.microsoft.com/office/powerpoint/2010/main" xmlns:com="http://schemas.openxmlformats.org/drawingml/2006/compatibility" xmlns:pvml="urn:schemas-microsoft-com:office:powerpoint" xmlns:v="urn:schemas-microsoft-com:vml" xmlns:o="urn:schemas-microsoft-com:office:office" xmlns:dgm="http://schemas.openxmlformats.org/drawingml/2006/diagram" xmlns:c="http://schemas.openxmlformats.org/drawingml/2006/chart" xmlns:mv="urn:schemas-microsoft-com:mac:vml" xmlns:mc="http://schemas.openxmlformats.org/markup-compatibility/2006" xmlns="" r:id="rId38" roundtripDataSignature="AMtx7mjFLyGGbKtZ6MKWK8o6r1g77If8Vw=="/>
     </p:ext>
   </p:extLst>
 </p:presentation>
@@ -2087,7 +2090,13 @@
   <p:cSld>
     <p:spTree>
       <p:nvGrpSpPr>
-        <p:cNvPr id="1" name="Shape 190"/>
+        <p:cNvPr id="1" name="Shape 184">
+          <a:extLst>
+            <a:ext uri="{FF2B5EF4-FFF2-40B4-BE49-F238E27FC236}">
+              <a16:creationId xmlns:a16="http://schemas.microsoft.com/office/drawing/2014/main" id="{538FC70F-713A-88E7-5065-A012C5238A8D}"/>
+            </a:ext>
+          </a:extLst>
+        </p:cNvPr>
         <p:cNvGrpSpPr/>
         <p:nvPr/>
       </p:nvGrpSpPr>
@@ -2101,7 +2110,13 @@
       </p:grpSpPr>
       <p:sp>
         <p:nvSpPr>
-          <p:cNvPr id="191" name="Google Shape;191;g2f19d644e1e_1_96:notes"/>
+          <p:cNvPr id="185" name="Google Shape;185;g2f19d644e1e_1_90:notes">
+            <a:extLst>
+              <a:ext uri="{FF2B5EF4-FFF2-40B4-BE49-F238E27FC236}">
+                <a16:creationId xmlns:a16="http://schemas.microsoft.com/office/drawing/2014/main" id="{2C6472A0-6274-8743-504A-65C695E953D8}"/>
+              </a:ext>
+            </a:extLst>
+          </p:cNvPr>
           <p:cNvSpPr txBox="1">
             <a:spLocks noGrp="1"/>
           </p:cNvSpPr>
@@ -2139,111 +2154,13 @@
       </p:sp>
       <p:sp>
         <p:nvSpPr>
-          <p:cNvPr id="192" name="Google Shape;192;g2f19d644e1e_1_96:notes"/>
-          <p:cNvSpPr>
-            <a:spLocks noGrp="1" noRot="1" noChangeAspect="1"/>
-          </p:cNvSpPr>
-          <p:nvPr>
-            <p:ph type="sldImg" idx="2"/>
-          </p:nvPr>
-        </p:nvSpPr>
-        <p:spPr>
-          <a:xfrm>
-            <a:off x="1143225" y="685800"/>
-            <a:ext cx="4572225" cy="3429000"/>
-          </a:xfrm>
-          <a:custGeom>
-            <a:avLst/>
-            <a:gdLst/>
-            <a:ahLst/>
-            <a:cxnLst/>
-            <a:rect l="l" t="t" r="r" b="b"/>
-            <a:pathLst>
-              <a:path w="120000" h="120000" extrusionOk="0">
-                <a:moveTo>
-                  <a:pt x="0" y="0"/>
-                </a:moveTo>
-                <a:lnTo>
-                  <a:pt x="120000" y="0"/>
-                </a:lnTo>
-                <a:lnTo>
-                  <a:pt x="120000" y="120000"/>
-                </a:lnTo>
-                <a:lnTo>
-                  <a:pt x="0" y="120000"/>
-                </a:lnTo>
-                <a:close/>
-              </a:path>
-            </a:pathLst>
-          </a:custGeom>
-        </p:spPr>
-      </p:sp>
-    </p:spTree>
-  </p:cSld>
-  <p:clrMapOvr>
-    <a:masterClrMapping/>
-  </p:clrMapOvr>
-</p:notes>
-</file>
-
-<file path=ppt/notesSlides/notesSlide18.xml><?xml version="1.0" encoding="utf-8"?>
-<p:notes xmlns:a="http://schemas.openxmlformats.org/drawingml/2006/main" xmlns:r="http://schemas.openxmlformats.org/officeDocument/2006/relationships" xmlns:p="http://schemas.openxmlformats.org/presentationml/2006/main" showMasterSp="0" showMasterPhAnim="0">
-  <p:cSld>
-    <p:spTree>
-      <p:nvGrpSpPr>
-        <p:cNvPr id="1" name="Shape 217"/>
-        <p:cNvGrpSpPr/>
-        <p:nvPr/>
-      </p:nvGrpSpPr>
-      <p:grpSpPr>
-        <a:xfrm>
-          <a:off x="0" y="0"/>
-          <a:ext cx="0" cy="0"/>
-          <a:chOff x="0" y="0"/>
-          <a:chExt cx="0" cy="0"/>
-        </a:xfrm>
-      </p:grpSpPr>
-      <p:sp>
-        <p:nvSpPr>
-          <p:cNvPr id="218" name="Google Shape;218;g2f19d644e1e_1_120:notes"/>
-          <p:cNvSpPr txBox="1">
-            <a:spLocks noGrp="1"/>
-          </p:cNvSpPr>
-          <p:nvPr>
-            <p:ph type="body" idx="1"/>
-          </p:nvPr>
-        </p:nvSpPr>
-        <p:spPr>
-          <a:xfrm>
-            <a:off x="685800" y="4343400"/>
-            <a:ext cx="5486400" cy="4114800"/>
-          </a:xfrm>
-          <a:prstGeom prst="rect">
-            <a:avLst/>
-          </a:prstGeom>
-        </p:spPr>
-        <p:txBody>
-          <a:bodyPr spcFirstLastPara="1" wrap="square" lIns="91425" tIns="91425" rIns="91425" bIns="91425" anchor="t" anchorCtr="0">
-            <a:noAutofit/>
-          </a:bodyPr>
-          <a:lstStyle/>
-          <a:p>
-            <a:pPr marL="0" lvl="0" indent="0" algn="l" rtl="0">
-              <a:spcBef>
-                <a:spcPts val="0"/>
-              </a:spcBef>
-              <a:spcAft>
-                <a:spcPts val="0"/>
-              </a:spcAft>
-              <a:buNone/>
-            </a:pPr>
-            <a:endParaRPr/>
-          </a:p>
-        </p:txBody>
-      </p:sp>
-      <p:sp>
-        <p:nvSpPr>
-          <p:cNvPr id="219" name="Google Shape;219;g2f19d644e1e_1_120:notes"/>
+          <p:cNvPr id="186" name="Google Shape;186;g2f19d644e1e_1_90:notes">
+            <a:extLst>
+              <a:ext uri="{FF2B5EF4-FFF2-40B4-BE49-F238E27FC236}">
+                <a16:creationId xmlns:a16="http://schemas.microsoft.com/office/drawing/2014/main" id="{BFF51063-C744-D9FA-C21B-8C236B0E9DF8}"/>
+              </a:ext>
+            </a:extLst>
+          </p:cNvPr>
           <p:cNvSpPr>
             <a:spLocks noGrp="1" noRot="1" noChangeAspect="1"/>
           </p:cNvSpPr>
@@ -2283,6 +2200,11 @@
         </p:spPr>
       </p:sp>
     </p:spTree>
+    <p:extLst>
+      <p:ext uri="{BB962C8B-B14F-4D97-AF65-F5344CB8AC3E}">
+        <p14:creationId xmlns:p14="http://schemas.microsoft.com/office/powerpoint/2010/main" val="1054386876"/>
+      </p:ext>
+    </p:extLst>
   </p:cSld>
   <p:clrMapOvr>
     <a:masterClrMapping/>
@@ -2290,12 +2212,18 @@
 </p:notes>
 </file>
 
-<file path=ppt/notesSlides/notesSlide19.xml><?xml version="1.0" encoding="utf-8"?>
+<file path=ppt/notesSlides/notesSlide18.xml><?xml version="1.0" encoding="utf-8"?>
 <p:notes xmlns:a="http://schemas.openxmlformats.org/drawingml/2006/main" xmlns:r="http://schemas.openxmlformats.org/officeDocument/2006/relationships" xmlns:p="http://schemas.openxmlformats.org/presentationml/2006/main" showMasterSp="0" showMasterPhAnim="0">
   <p:cSld>
     <p:spTree>
       <p:nvGrpSpPr>
-        <p:cNvPr id="1" name="Shape 224"/>
+        <p:cNvPr id="1" name="Shape 184">
+          <a:extLst>
+            <a:ext uri="{FF2B5EF4-FFF2-40B4-BE49-F238E27FC236}">
+              <a16:creationId xmlns:a16="http://schemas.microsoft.com/office/drawing/2014/main" id="{E0AA8347-332A-298A-C584-8535D29914FF}"/>
+            </a:ext>
+          </a:extLst>
+        </p:cNvPr>
         <p:cNvGrpSpPr/>
         <p:nvPr/>
       </p:nvGrpSpPr>
@@ -2309,7 +2237,13 @@
       </p:grpSpPr>
       <p:sp>
         <p:nvSpPr>
-          <p:cNvPr id="225" name="Google Shape;225;g2f19d644e1e_1_126:notes"/>
+          <p:cNvPr id="185" name="Google Shape;185;g2f19d644e1e_1_90:notes">
+            <a:extLst>
+              <a:ext uri="{FF2B5EF4-FFF2-40B4-BE49-F238E27FC236}">
+                <a16:creationId xmlns:a16="http://schemas.microsoft.com/office/drawing/2014/main" id="{58AB3E9E-7EC9-7291-EEBE-044F34EEC1C7}"/>
+              </a:ext>
+            </a:extLst>
+          </p:cNvPr>
           <p:cNvSpPr txBox="1">
             <a:spLocks noGrp="1"/>
           </p:cNvSpPr>
@@ -2347,7 +2281,13 @@
       </p:sp>
       <p:sp>
         <p:nvSpPr>
-          <p:cNvPr id="226" name="Google Shape;226;g2f19d644e1e_1_126:notes"/>
+          <p:cNvPr id="186" name="Google Shape;186;g2f19d644e1e_1_90:notes">
+            <a:extLst>
+              <a:ext uri="{FF2B5EF4-FFF2-40B4-BE49-F238E27FC236}">
+                <a16:creationId xmlns:a16="http://schemas.microsoft.com/office/drawing/2014/main" id="{8910E96B-0BD4-204E-FC56-79D4C96ED066}"/>
+              </a:ext>
+            </a:extLst>
+          </p:cNvPr>
           <p:cNvSpPr>
             <a:spLocks noGrp="1" noRot="1" noChangeAspect="1"/>
           </p:cNvSpPr>
@@ -2387,6 +2327,138 @@
         </p:spPr>
       </p:sp>
     </p:spTree>
+    <p:extLst>
+      <p:ext uri="{BB962C8B-B14F-4D97-AF65-F5344CB8AC3E}">
+        <p14:creationId xmlns:p14="http://schemas.microsoft.com/office/powerpoint/2010/main" val="3254954573"/>
+      </p:ext>
+    </p:extLst>
+  </p:cSld>
+  <p:clrMapOvr>
+    <a:masterClrMapping/>
+  </p:clrMapOvr>
+</p:notes>
+</file>
+
+<file path=ppt/notesSlides/notesSlide19.xml><?xml version="1.0" encoding="utf-8"?>
+<p:notes xmlns:a="http://schemas.openxmlformats.org/drawingml/2006/main" xmlns:r="http://schemas.openxmlformats.org/officeDocument/2006/relationships" xmlns:p="http://schemas.openxmlformats.org/presentationml/2006/main" showMasterSp="0" showMasterPhAnim="0">
+  <p:cSld>
+    <p:spTree>
+      <p:nvGrpSpPr>
+        <p:cNvPr id="1" name="Shape 184">
+          <a:extLst>
+            <a:ext uri="{FF2B5EF4-FFF2-40B4-BE49-F238E27FC236}">
+              <a16:creationId xmlns:a16="http://schemas.microsoft.com/office/drawing/2014/main" id="{75E045F2-A9F4-AEE8-7828-19BB03739A99}"/>
+            </a:ext>
+          </a:extLst>
+        </p:cNvPr>
+        <p:cNvGrpSpPr/>
+        <p:nvPr/>
+      </p:nvGrpSpPr>
+      <p:grpSpPr>
+        <a:xfrm>
+          <a:off x="0" y="0"/>
+          <a:ext cx="0" cy="0"/>
+          <a:chOff x="0" y="0"/>
+          <a:chExt cx="0" cy="0"/>
+        </a:xfrm>
+      </p:grpSpPr>
+      <p:sp>
+        <p:nvSpPr>
+          <p:cNvPr id="185" name="Google Shape;185;g2f19d644e1e_1_90:notes">
+            <a:extLst>
+              <a:ext uri="{FF2B5EF4-FFF2-40B4-BE49-F238E27FC236}">
+                <a16:creationId xmlns:a16="http://schemas.microsoft.com/office/drawing/2014/main" id="{6EF6C27B-E787-6A26-FB8F-D87505A48F6B}"/>
+              </a:ext>
+            </a:extLst>
+          </p:cNvPr>
+          <p:cNvSpPr txBox="1">
+            <a:spLocks noGrp="1"/>
+          </p:cNvSpPr>
+          <p:nvPr>
+            <p:ph type="body" idx="1"/>
+          </p:nvPr>
+        </p:nvSpPr>
+        <p:spPr>
+          <a:xfrm>
+            <a:off x="685800" y="4343400"/>
+            <a:ext cx="5486400" cy="4114800"/>
+          </a:xfrm>
+          <a:prstGeom prst="rect">
+            <a:avLst/>
+          </a:prstGeom>
+        </p:spPr>
+        <p:txBody>
+          <a:bodyPr spcFirstLastPara="1" wrap="square" lIns="91425" tIns="91425" rIns="91425" bIns="91425" anchor="t" anchorCtr="0">
+            <a:noAutofit/>
+          </a:bodyPr>
+          <a:lstStyle/>
+          <a:p>
+            <a:pPr marL="0" lvl="0" indent="0" algn="l" rtl="0">
+              <a:spcBef>
+                <a:spcPts val="0"/>
+              </a:spcBef>
+              <a:spcAft>
+                <a:spcPts val="0"/>
+              </a:spcAft>
+              <a:buNone/>
+            </a:pPr>
+            <a:endParaRPr/>
+          </a:p>
+        </p:txBody>
+      </p:sp>
+      <p:sp>
+        <p:nvSpPr>
+          <p:cNvPr id="186" name="Google Shape;186;g2f19d644e1e_1_90:notes">
+            <a:extLst>
+              <a:ext uri="{FF2B5EF4-FFF2-40B4-BE49-F238E27FC236}">
+                <a16:creationId xmlns:a16="http://schemas.microsoft.com/office/drawing/2014/main" id="{A0661EA6-909F-B66F-DA49-251D2FFF4DD8}"/>
+              </a:ext>
+            </a:extLst>
+          </p:cNvPr>
+          <p:cNvSpPr>
+            <a:spLocks noGrp="1" noRot="1" noChangeAspect="1"/>
+          </p:cNvSpPr>
+          <p:nvPr>
+            <p:ph type="sldImg" idx="2"/>
+          </p:nvPr>
+        </p:nvSpPr>
+        <p:spPr>
+          <a:xfrm>
+            <a:off x="381000" y="685800"/>
+            <a:ext cx="6096000" cy="3429000"/>
+          </a:xfrm>
+          <a:custGeom>
+            <a:avLst/>
+            <a:gdLst/>
+            <a:ahLst/>
+            <a:cxnLst/>
+            <a:rect l="l" t="t" r="r" b="b"/>
+            <a:pathLst>
+              <a:path w="120000" h="120000" extrusionOk="0">
+                <a:moveTo>
+                  <a:pt x="0" y="0"/>
+                </a:moveTo>
+                <a:lnTo>
+                  <a:pt x="120000" y="0"/>
+                </a:lnTo>
+                <a:lnTo>
+                  <a:pt x="120000" y="120000"/>
+                </a:lnTo>
+                <a:lnTo>
+                  <a:pt x="0" y="120000"/>
+                </a:lnTo>
+                <a:close/>
+              </a:path>
+            </a:pathLst>
+          </a:custGeom>
+        </p:spPr>
+      </p:sp>
+    </p:spTree>
+    <p:extLst>
+      <p:ext uri="{BB962C8B-B14F-4D97-AF65-F5344CB8AC3E}">
+        <p14:creationId xmlns:p14="http://schemas.microsoft.com/office/powerpoint/2010/main" val="2196073712"/>
+      </p:ext>
+    </p:extLst>
   </p:cSld>
   <p:clrMapOvr>
     <a:masterClrMapping/>
@@ -2521,6 +2593,318 @@
   <p:cSld>
     <p:spTree>
       <p:nvGrpSpPr>
+        <p:cNvPr id="1" name="Shape 190"/>
+        <p:cNvGrpSpPr/>
+        <p:nvPr/>
+      </p:nvGrpSpPr>
+      <p:grpSpPr>
+        <a:xfrm>
+          <a:off x="0" y="0"/>
+          <a:ext cx="0" cy="0"/>
+          <a:chOff x="0" y="0"/>
+          <a:chExt cx="0" cy="0"/>
+        </a:xfrm>
+      </p:grpSpPr>
+      <p:sp>
+        <p:nvSpPr>
+          <p:cNvPr id="191" name="Google Shape;191;g2f19d644e1e_1_96:notes"/>
+          <p:cNvSpPr txBox="1">
+            <a:spLocks noGrp="1"/>
+          </p:cNvSpPr>
+          <p:nvPr>
+            <p:ph type="body" idx="1"/>
+          </p:nvPr>
+        </p:nvSpPr>
+        <p:spPr>
+          <a:xfrm>
+            <a:off x="685800" y="4343400"/>
+            <a:ext cx="5486400" cy="4114800"/>
+          </a:xfrm>
+          <a:prstGeom prst="rect">
+            <a:avLst/>
+          </a:prstGeom>
+        </p:spPr>
+        <p:txBody>
+          <a:bodyPr spcFirstLastPara="1" wrap="square" lIns="91425" tIns="91425" rIns="91425" bIns="91425" anchor="t" anchorCtr="0">
+            <a:noAutofit/>
+          </a:bodyPr>
+          <a:lstStyle/>
+          <a:p>
+            <a:pPr marL="0" lvl="0" indent="0" algn="l" rtl="0">
+              <a:spcBef>
+                <a:spcPts val="0"/>
+              </a:spcBef>
+              <a:spcAft>
+                <a:spcPts val="0"/>
+              </a:spcAft>
+              <a:buNone/>
+            </a:pPr>
+            <a:endParaRPr/>
+          </a:p>
+        </p:txBody>
+      </p:sp>
+      <p:sp>
+        <p:nvSpPr>
+          <p:cNvPr id="192" name="Google Shape;192;g2f19d644e1e_1_96:notes"/>
+          <p:cNvSpPr>
+            <a:spLocks noGrp="1" noRot="1" noChangeAspect="1"/>
+          </p:cNvSpPr>
+          <p:nvPr>
+            <p:ph type="sldImg" idx="2"/>
+          </p:nvPr>
+        </p:nvSpPr>
+        <p:spPr>
+          <a:xfrm>
+            <a:off x="1143225" y="685800"/>
+            <a:ext cx="4572225" cy="3429000"/>
+          </a:xfrm>
+          <a:custGeom>
+            <a:avLst/>
+            <a:gdLst/>
+            <a:ahLst/>
+            <a:cxnLst/>
+            <a:rect l="l" t="t" r="r" b="b"/>
+            <a:pathLst>
+              <a:path w="120000" h="120000" extrusionOk="0">
+                <a:moveTo>
+                  <a:pt x="0" y="0"/>
+                </a:moveTo>
+                <a:lnTo>
+                  <a:pt x="120000" y="0"/>
+                </a:lnTo>
+                <a:lnTo>
+                  <a:pt x="120000" y="120000"/>
+                </a:lnTo>
+                <a:lnTo>
+                  <a:pt x="0" y="120000"/>
+                </a:lnTo>
+                <a:close/>
+              </a:path>
+            </a:pathLst>
+          </a:custGeom>
+        </p:spPr>
+      </p:sp>
+    </p:spTree>
+  </p:cSld>
+  <p:clrMapOvr>
+    <a:masterClrMapping/>
+  </p:clrMapOvr>
+</p:notes>
+</file>
+
+<file path=ppt/notesSlides/notesSlide21.xml><?xml version="1.0" encoding="utf-8"?>
+<p:notes xmlns:a="http://schemas.openxmlformats.org/drawingml/2006/main" xmlns:r="http://schemas.openxmlformats.org/officeDocument/2006/relationships" xmlns:p="http://schemas.openxmlformats.org/presentationml/2006/main" showMasterSp="0" showMasterPhAnim="0">
+  <p:cSld>
+    <p:spTree>
+      <p:nvGrpSpPr>
+        <p:cNvPr id="1" name="Shape 217"/>
+        <p:cNvGrpSpPr/>
+        <p:nvPr/>
+      </p:nvGrpSpPr>
+      <p:grpSpPr>
+        <a:xfrm>
+          <a:off x="0" y="0"/>
+          <a:ext cx="0" cy="0"/>
+          <a:chOff x="0" y="0"/>
+          <a:chExt cx="0" cy="0"/>
+        </a:xfrm>
+      </p:grpSpPr>
+      <p:sp>
+        <p:nvSpPr>
+          <p:cNvPr id="218" name="Google Shape;218;g2f19d644e1e_1_120:notes"/>
+          <p:cNvSpPr txBox="1">
+            <a:spLocks noGrp="1"/>
+          </p:cNvSpPr>
+          <p:nvPr>
+            <p:ph type="body" idx="1"/>
+          </p:nvPr>
+        </p:nvSpPr>
+        <p:spPr>
+          <a:xfrm>
+            <a:off x="685800" y="4343400"/>
+            <a:ext cx="5486400" cy="4114800"/>
+          </a:xfrm>
+          <a:prstGeom prst="rect">
+            <a:avLst/>
+          </a:prstGeom>
+        </p:spPr>
+        <p:txBody>
+          <a:bodyPr spcFirstLastPara="1" wrap="square" lIns="91425" tIns="91425" rIns="91425" bIns="91425" anchor="t" anchorCtr="0">
+            <a:noAutofit/>
+          </a:bodyPr>
+          <a:lstStyle/>
+          <a:p>
+            <a:pPr marL="0" lvl="0" indent="0" algn="l" rtl="0">
+              <a:spcBef>
+                <a:spcPts val="0"/>
+              </a:spcBef>
+              <a:spcAft>
+                <a:spcPts val="0"/>
+              </a:spcAft>
+              <a:buNone/>
+            </a:pPr>
+            <a:endParaRPr/>
+          </a:p>
+        </p:txBody>
+      </p:sp>
+      <p:sp>
+        <p:nvSpPr>
+          <p:cNvPr id="219" name="Google Shape;219;g2f19d644e1e_1_120:notes"/>
+          <p:cNvSpPr>
+            <a:spLocks noGrp="1" noRot="1" noChangeAspect="1"/>
+          </p:cNvSpPr>
+          <p:nvPr>
+            <p:ph type="sldImg" idx="2"/>
+          </p:nvPr>
+        </p:nvSpPr>
+        <p:spPr>
+          <a:xfrm>
+            <a:off x="381000" y="685800"/>
+            <a:ext cx="6096000" cy="3429000"/>
+          </a:xfrm>
+          <a:custGeom>
+            <a:avLst/>
+            <a:gdLst/>
+            <a:ahLst/>
+            <a:cxnLst/>
+            <a:rect l="l" t="t" r="r" b="b"/>
+            <a:pathLst>
+              <a:path w="120000" h="120000" extrusionOk="0">
+                <a:moveTo>
+                  <a:pt x="0" y="0"/>
+                </a:moveTo>
+                <a:lnTo>
+                  <a:pt x="120000" y="0"/>
+                </a:lnTo>
+                <a:lnTo>
+                  <a:pt x="120000" y="120000"/>
+                </a:lnTo>
+                <a:lnTo>
+                  <a:pt x="0" y="120000"/>
+                </a:lnTo>
+                <a:close/>
+              </a:path>
+            </a:pathLst>
+          </a:custGeom>
+        </p:spPr>
+      </p:sp>
+    </p:spTree>
+  </p:cSld>
+  <p:clrMapOvr>
+    <a:masterClrMapping/>
+  </p:clrMapOvr>
+</p:notes>
+</file>
+
+<file path=ppt/notesSlides/notesSlide22.xml><?xml version="1.0" encoding="utf-8"?>
+<p:notes xmlns:a="http://schemas.openxmlformats.org/drawingml/2006/main" xmlns:r="http://schemas.openxmlformats.org/officeDocument/2006/relationships" xmlns:p="http://schemas.openxmlformats.org/presentationml/2006/main" showMasterSp="0" showMasterPhAnim="0">
+  <p:cSld>
+    <p:spTree>
+      <p:nvGrpSpPr>
+        <p:cNvPr id="1" name="Shape 224"/>
+        <p:cNvGrpSpPr/>
+        <p:nvPr/>
+      </p:nvGrpSpPr>
+      <p:grpSpPr>
+        <a:xfrm>
+          <a:off x="0" y="0"/>
+          <a:ext cx="0" cy="0"/>
+          <a:chOff x="0" y="0"/>
+          <a:chExt cx="0" cy="0"/>
+        </a:xfrm>
+      </p:grpSpPr>
+      <p:sp>
+        <p:nvSpPr>
+          <p:cNvPr id="225" name="Google Shape;225;g2f19d644e1e_1_126:notes"/>
+          <p:cNvSpPr txBox="1">
+            <a:spLocks noGrp="1"/>
+          </p:cNvSpPr>
+          <p:nvPr>
+            <p:ph type="body" idx="1"/>
+          </p:nvPr>
+        </p:nvSpPr>
+        <p:spPr>
+          <a:xfrm>
+            <a:off x="685800" y="4343400"/>
+            <a:ext cx="5486400" cy="4114800"/>
+          </a:xfrm>
+          <a:prstGeom prst="rect">
+            <a:avLst/>
+          </a:prstGeom>
+        </p:spPr>
+        <p:txBody>
+          <a:bodyPr spcFirstLastPara="1" wrap="square" lIns="91425" tIns="91425" rIns="91425" bIns="91425" anchor="t" anchorCtr="0">
+            <a:noAutofit/>
+          </a:bodyPr>
+          <a:lstStyle/>
+          <a:p>
+            <a:pPr marL="0" lvl="0" indent="0" algn="l" rtl="0">
+              <a:spcBef>
+                <a:spcPts val="0"/>
+              </a:spcBef>
+              <a:spcAft>
+                <a:spcPts val="0"/>
+              </a:spcAft>
+              <a:buNone/>
+            </a:pPr>
+            <a:endParaRPr/>
+          </a:p>
+        </p:txBody>
+      </p:sp>
+      <p:sp>
+        <p:nvSpPr>
+          <p:cNvPr id="226" name="Google Shape;226;g2f19d644e1e_1_126:notes"/>
+          <p:cNvSpPr>
+            <a:spLocks noGrp="1" noRot="1" noChangeAspect="1"/>
+          </p:cNvSpPr>
+          <p:nvPr>
+            <p:ph type="sldImg" idx="2"/>
+          </p:nvPr>
+        </p:nvSpPr>
+        <p:spPr>
+          <a:xfrm>
+            <a:off x="381000" y="685800"/>
+            <a:ext cx="6096000" cy="3429000"/>
+          </a:xfrm>
+          <a:custGeom>
+            <a:avLst/>
+            <a:gdLst/>
+            <a:ahLst/>
+            <a:cxnLst/>
+            <a:rect l="l" t="t" r="r" b="b"/>
+            <a:pathLst>
+              <a:path w="120000" h="120000" extrusionOk="0">
+                <a:moveTo>
+                  <a:pt x="0" y="0"/>
+                </a:moveTo>
+                <a:lnTo>
+                  <a:pt x="120000" y="0"/>
+                </a:lnTo>
+                <a:lnTo>
+                  <a:pt x="120000" y="120000"/>
+                </a:lnTo>
+                <a:lnTo>
+                  <a:pt x="0" y="120000"/>
+                </a:lnTo>
+                <a:close/>
+              </a:path>
+            </a:pathLst>
+          </a:custGeom>
+        </p:spPr>
+      </p:sp>
+    </p:spTree>
+  </p:cSld>
+  <p:clrMapOvr>
+    <a:masterClrMapping/>
+  </p:clrMapOvr>
+</p:notes>
+</file>
+
+<file path=ppt/notesSlides/notesSlide23.xml><?xml version="1.0" encoding="utf-8"?>
+<p:notes xmlns:a="http://schemas.openxmlformats.org/drawingml/2006/main" xmlns:r="http://schemas.openxmlformats.org/officeDocument/2006/relationships" xmlns:p="http://schemas.openxmlformats.org/presentationml/2006/main" showMasterSp="0" showMasterPhAnim="0">
+  <p:cSld>
+    <p:spTree>
+      <p:nvGrpSpPr>
         <p:cNvPr id="1" name="Shape 237"/>
         <p:cNvGrpSpPr/>
         <p:nvPr/>
@@ -2620,7 +3004,7 @@
 </p:notes>
 </file>
 
-<file path=ppt/notesSlides/notesSlide21.xml><?xml version="1.0" encoding="utf-8"?>
+<file path=ppt/notesSlides/notesSlide24.xml><?xml version="1.0" encoding="utf-8"?>
 <p:notes xmlns:a="http://schemas.openxmlformats.org/drawingml/2006/main" xmlns:r="http://schemas.openxmlformats.org/officeDocument/2006/relationships" xmlns:p="http://schemas.openxmlformats.org/presentationml/2006/main" showMasterSp="0" showMasterPhAnim="0">
   <p:cSld>
     <p:spTree>
@@ -2724,7 +3108,7 @@
 </p:notes>
 </file>
 
-<file path=ppt/notesSlides/notesSlide22.xml><?xml version="1.0" encoding="utf-8"?>
+<file path=ppt/notesSlides/notesSlide25.xml><?xml version="1.0" encoding="utf-8"?>
 <p:notes xmlns:a="http://schemas.openxmlformats.org/drawingml/2006/main" xmlns:r="http://schemas.openxmlformats.org/officeDocument/2006/relationships" xmlns:p="http://schemas.openxmlformats.org/presentationml/2006/main" showMasterSp="0" showMasterPhAnim="0">
   <p:cSld>
     <p:spTree>
@@ -2828,7 +3212,7 @@
 </p:notes>
 </file>
 
-<file path=ppt/notesSlides/notesSlide23.xml><?xml version="1.0" encoding="utf-8"?>
+<file path=ppt/notesSlides/notesSlide26.xml><?xml version="1.0" encoding="utf-8"?>
 <p:notes xmlns:a="http://schemas.openxmlformats.org/drawingml/2006/main" xmlns:r="http://schemas.openxmlformats.org/officeDocument/2006/relationships" xmlns:p="http://schemas.openxmlformats.org/presentationml/2006/main" showMasterSp="0" showMasterPhAnim="0">
   <p:cSld>
     <p:spTree>
@@ -2955,7 +3339,7 @@
 </p:notes>
 </file>
 
-<file path=ppt/notesSlides/notesSlide24.xml><?xml version="1.0" encoding="utf-8"?>
+<file path=ppt/notesSlides/notesSlide27.xml><?xml version="1.0" encoding="utf-8"?>
 <p:notes xmlns:a="http://schemas.openxmlformats.org/drawingml/2006/main" xmlns:r="http://schemas.openxmlformats.org/officeDocument/2006/relationships" xmlns:p="http://schemas.openxmlformats.org/presentationml/2006/main" showMasterSp="0" showMasterPhAnim="0">
   <p:cSld>
     <p:spTree>
@@ -3059,7 +3443,7 @@
 </p:notes>
 </file>
 
-<file path=ppt/notesSlides/notesSlide25.xml><?xml version="1.0" encoding="utf-8"?>
+<file path=ppt/notesSlides/notesSlide28.xml><?xml version="1.0" encoding="utf-8"?>
 <p:notes xmlns:a="http://schemas.openxmlformats.org/drawingml/2006/main" xmlns:r="http://schemas.openxmlformats.org/officeDocument/2006/relationships" xmlns:p="http://schemas.openxmlformats.org/presentationml/2006/main" showMasterSp="0" showMasterPhAnim="0">
   <p:cSld>
     <p:spTree>
@@ -3163,7 +3547,7 @@
 </p:notes>
 </file>
 
-<file path=ppt/notesSlides/notesSlide26.xml><?xml version="1.0" encoding="utf-8"?>
+<file path=ppt/notesSlides/notesSlide29.xml><?xml version="1.0" encoding="utf-8"?>
 <p:notes xmlns:a="http://schemas.openxmlformats.org/drawingml/2006/main" xmlns:r="http://schemas.openxmlformats.org/officeDocument/2006/relationships" xmlns:p="http://schemas.openxmlformats.org/presentationml/2006/main" showMasterSp="0" showMasterPhAnim="0">
   <p:cSld>
     <p:spTree>
@@ -3221,110 +3605,6 @@
       <p:sp>
         <p:nvSpPr>
           <p:cNvPr id="285" name="Google Shape;285;g2f19d644e1e_1_178:notes"/>
-          <p:cNvSpPr>
-            <a:spLocks noGrp="1" noRot="1" noChangeAspect="1"/>
-          </p:cNvSpPr>
-          <p:nvPr>
-            <p:ph type="sldImg" idx="2"/>
-          </p:nvPr>
-        </p:nvSpPr>
-        <p:spPr>
-          <a:xfrm>
-            <a:off x="381000" y="685800"/>
-            <a:ext cx="6096000" cy="3429000"/>
-          </a:xfrm>
-          <a:custGeom>
-            <a:avLst/>
-            <a:gdLst/>
-            <a:ahLst/>
-            <a:cxnLst/>
-            <a:rect l="l" t="t" r="r" b="b"/>
-            <a:pathLst>
-              <a:path w="120000" h="120000" extrusionOk="0">
-                <a:moveTo>
-                  <a:pt x="0" y="0"/>
-                </a:moveTo>
-                <a:lnTo>
-                  <a:pt x="120000" y="0"/>
-                </a:lnTo>
-                <a:lnTo>
-                  <a:pt x="120000" y="120000"/>
-                </a:lnTo>
-                <a:lnTo>
-                  <a:pt x="0" y="120000"/>
-                </a:lnTo>
-                <a:close/>
-              </a:path>
-            </a:pathLst>
-          </a:custGeom>
-        </p:spPr>
-      </p:sp>
-    </p:spTree>
-  </p:cSld>
-  <p:clrMapOvr>
-    <a:masterClrMapping/>
-  </p:clrMapOvr>
-</p:notes>
-</file>
-
-<file path=ppt/notesSlides/notesSlide27.xml><?xml version="1.0" encoding="utf-8"?>
-<p:notes xmlns:a="http://schemas.openxmlformats.org/drawingml/2006/main" xmlns:r="http://schemas.openxmlformats.org/officeDocument/2006/relationships" xmlns:p="http://schemas.openxmlformats.org/presentationml/2006/main" showMasterSp="0" showMasterPhAnim="0">
-  <p:cSld>
-    <p:spTree>
-      <p:nvGrpSpPr>
-        <p:cNvPr id="1" name="Shape 290"/>
-        <p:cNvGrpSpPr/>
-        <p:nvPr/>
-      </p:nvGrpSpPr>
-      <p:grpSpPr>
-        <a:xfrm>
-          <a:off x="0" y="0"/>
-          <a:ext cx="0" cy="0"/>
-          <a:chOff x="0" y="0"/>
-          <a:chExt cx="0" cy="0"/>
-        </a:xfrm>
-      </p:grpSpPr>
-      <p:sp>
-        <p:nvSpPr>
-          <p:cNvPr id="291" name="Google Shape;291;g2f19d644e1e_1_184:notes"/>
-          <p:cNvSpPr txBox="1">
-            <a:spLocks noGrp="1"/>
-          </p:cNvSpPr>
-          <p:nvPr>
-            <p:ph type="body" idx="1"/>
-          </p:nvPr>
-        </p:nvSpPr>
-        <p:spPr>
-          <a:xfrm>
-            <a:off x="685800" y="4343400"/>
-            <a:ext cx="5486400" cy="4114800"/>
-          </a:xfrm>
-          <a:prstGeom prst="rect">
-            <a:avLst/>
-          </a:prstGeom>
-        </p:spPr>
-        <p:txBody>
-          <a:bodyPr spcFirstLastPara="1" wrap="square" lIns="91425" tIns="91425" rIns="91425" bIns="91425" anchor="t" anchorCtr="0">
-            <a:noAutofit/>
-          </a:bodyPr>
-          <a:lstStyle/>
-          <a:p>
-            <a:pPr marL="0" lvl="0" indent="0" algn="l" rtl="0">
-              <a:spcBef>
-                <a:spcPts val="0"/>
-              </a:spcBef>
-              <a:spcAft>
-                <a:spcPts val="0"/>
-              </a:spcAft>
-              <a:buNone/>
-            </a:pPr>
-            <a:endParaRPr/>
-          </a:p>
-        </p:txBody>
-      </p:sp>
-      <p:sp>
-        <p:nvSpPr>
-          <p:cNvPr id="292" name="Google Shape;292;g2f19d644e1e_1_184:notes"/>
           <p:cNvSpPr>
             <a:spLocks noGrp="1" noRot="1" noChangeAspect="1"/>
           </p:cNvSpPr>
@@ -3491,6 +3771,110 @@
         <p14:creationId xmlns:p14="http://schemas.microsoft.com/office/powerpoint/2010/main" val="3507482679"/>
       </p:ext>
     </p:extLst>
+  </p:cSld>
+  <p:clrMapOvr>
+    <a:masterClrMapping/>
+  </p:clrMapOvr>
+</p:notes>
+</file>
+
+<file path=ppt/notesSlides/notesSlide30.xml><?xml version="1.0" encoding="utf-8"?>
+<p:notes xmlns:a="http://schemas.openxmlformats.org/drawingml/2006/main" xmlns:r="http://schemas.openxmlformats.org/officeDocument/2006/relationships" xmlns:p="http://schemas.openxmlformats.org/presentationml/2006/main" showMasterSp="0" showMasterPhAnim="0">
+  <p:cSld>
+    <p:spTree>
+      <p:nvGrpSpPr>
+        <p:cNvPr id="1" name="Shape 290"/>
+        <p:cNvGrpSpPr/>
+        <p:nvPr/>
+      </p:nvGrpSpPr>
+      <p:grpSpPr>
+        <a:xfrm>
+          <a:off x="0" y="0"/>
+          <a:ext cx="0" cy="0"/>
+          <a:chOff x="0" y="0"/>
+          <a:chExt cx="0" cy="0"/>
+        </a:xfrm>
+      </p:grpSpPr>
+      <p:sp>
+        <p:nvSpPr>
+          <p:cNvPr id="291" name="Google Shape;291;g2f19d644e1e_1_184:notes"/>
+          <p:cNvSpPr txBox="1">
+            <a:spLocks noGrp="1"/>
+          </p:cNvSpPr>
+          <p:nvPr>
+            <p:ph type="body" idx="1"/>
+          </p:nvPr>
+        </p:nvSpPr>
+        <p:spPr>
+          <a:xfrm>
+            <a:off x="685800" y="4343400"/>
+            <a:ext cx="5486400" cy="4114800"/>
+          </a:xfrm>
+          <a:prstGeom prst="rect">
+            <a:avLst/>
+          </a:prstGeom>
+        </p:spPr>
+        <p:txBody>
+          <a:bodyPr spcFirstLastPara="1" wrap="square" lIns="91425" tIns="91425" rIns="91425" bIns="91425" anchor="t" anchorCtr="0">
+            <a:noAutofit/>
+          </a:bodyPr>
+          <a:lstStyle/>
+          <a:p>
+            <a:pPr marL="0" lvl="0" indent="0" algn="l" rtl="0">
+              <a:spcBef>
+                <a:spcPts val="0"/>
+              </a:spcBef>
+              <a:spcAft>
+                <a:spcPts val="0"/>
+              </a:spcAft>
+              <a:buNone/>
+            </a:pPr>
+            <a:endParaRPr/>
+          </a:p>
+        </p:txBody>
+      </p:sp>
+      <p:sp>
+        <p:nvSpPr>
+          <p:cNvPr id="292" name="Google Shape;292;g2f19d644e1e_1_184:notes"/>
+          <p:cNvSpPr>
+            <a:spLocks noGrp="1" noRot="1" noChangeAspect="1"/>
+          </p:cNvSpPr>
+          <p:nvPr>
+            <p:ph type="sldImg" idx="2"/>
+          </p:nvPr>
+        </p:nvSpPr>
+        <p:spPr>
+          <a:xfrm>
+            <a:off x="381000" y="685800"/>
+            <a:ext cx="6096000" cy="3429000"/>
+          </a:xfrm>
+          <a:custGeom>
+            <a:avLst/>
+            <a:gdLst/>
+            <a:ahLst/>
+            <a:cxnLst/>
+            <a:rect l="l" t="t" r="r" b="b"/>
+            <a:pathLst>
+              <a:path w="120000" h="120000" extrusionOk="0">
+                <a:moveTo>
+                  <a:pt x="0" y="0"/>
+                </a:moveTo>
+                <a:lnTo>
+                  <a:pt x="120000" y="0"/>
+                </a:lnTo>
+                <a:lnTo>
+                  <a:pt x="120000" y="120000"/>
+                </a:lnTo>
+                <a:lnTo>
+                  <a:pt x="0" y="120000"/>
+                </a:lnTo>
+                <a:close/>
+              </a:path>
+            </a:pathLst>
+          </a:custGeom>
+        </p:spPr>
+      </p:sp>
+    </p:spTree>
   </p:cSld>
   <p:clrMapOvr>
     <a:masterClrMapping/>
@@ -16580,7 +16964,7 @@
               <a:buNone/>
             </a:pPr>
             <a:r>
-              <a:rPr lang="en" sz="2100">
+              <a:rPr lang="en" sz="2100" dirty="0">
                 <a:solidFill>
                   <a:srgbClr val="FF0000"/>
                 </a:solidFill>
@@ -16591,7 +16975,7 @@
               </a:rPr>
               <a:t> ver github autoencoder</a:t>
             </a:r>
-            <a:endParaRPr sz="2100">
+            <a:endParaRPr sz="2100" dirty="0">
               <a:solidFill>
                 <a:srgbClr val="FF0000"/>
               </a:solidFill>
@@ -16612,6 +16996,2719 @@
 </file>
 
 <file path=ppt/slides/slide17.xml><?xml version="1.0" encoding="utf-8"?>
+<p:sld xmlns:a="http://schemas.openxmlformats.org/drawingml/2006/main" xmlns:r="http://schemas.openxmlformats.org/officeDocument/2006/relationships" xmlns:p="http://schemas.openxmlformats.org/presentationml/2006/main">
+  <p:cSld>
+    <p:spTree>
+      <p:nvGrpSpPr>
+        <p:cNvPr id="1" name="Shape 187">
+          <a:extLst>
+            <a:ext uri="{FF2B5EF4-FFF2-40B4-BE49-F238E27FC236}">
+              <a16:creationId xmlns:a16="http://schemas.microsoft.com/office/drawing/2014/main" id="{854E0B96-BAAA-9C8B-425E-DD27843149DD}"/>
+            </a:ext>
+          </a:extLst>
+        </p:cNvPr>
+        <p:cNvGrpSpPr/>
+        <p:nvPr/>
+      </p:nvGrpSpPr>
+      <p:grpSpPr>
+        <a:xfrm>
+          <a:off x="0" y="0"/>
+          <a:ext cx="0" cy="0"/>
+          <a:chOff x="0" y="0"/>
+          <a:chExt cx="0" cy="0"/>
+        </a:xfrm>
+      </p:grpSpPr>
+      <p:sp>
+        <p:nvSpPr>
+          <p:cNvPr id="188" name="Google Shape;188;g2f19d644e1e_1_90">
+            <a:extLst>
+              <a:ext uri="{FF2B5EF4-FFF2-40B4-BE49-F238E27FC236}">
+                <a16:creationId xmlns:a16="http://schemas.microsoft.com/office/drawing/2014/main" id="{6C18E871-786D-B36B-D070-C9CEA13EC787}"/>
+              </a:ext>
+            </a:extLst>
+          </p:cNvPr>
+          <p:cNvSpPr txBox="1"/>
+          <p:nvPr/>
+        </p:nvSpPr>
+        <p:spPr>
+          <a:xfrm>
+            <a:off x="-129402" y="0"/>
+            <a:ext cx="9383400" cy="814500"/>
+          </a:xfrm>
+          <a:prstGeom prst="rect">
+            <a:avLst/>
+          </a:prstGeom>
+          <a:noFill/>
+          <a:ln>
+            <a:noFill/>
+          </a:ln>
+        </p:spPr>
+        <p:txBody>
+          <a:bodyPr spcFirstLastPara="1" wrap="square" lIns="68575" tIns="34275" rIns="68575" bIns="34275" anchor="t" anchorCtr="0">
+            <a:noAutofit/>
+          </a:bodyPr>
+          <a:lstStyle/>
+          <a:p>
+            <a:pPr marL="0" marR="0" lvl="0" indent="0" algn="ctr" rtl="0">
+              <a:lnSpc>
+                <a:spcPct val="120000"/>
+              </a:lnSpc>
+              <a:spcBef>
+                <a:spcPts val="0"/>
+              </a:spcBef>
+              <a:spcAft>
+                <a:spcPts val="0"/>
+              </a:spcAft>
+              <a:buClr>
+                <a:schemeClr val="dk1"/>
+              </a:buClr>
+              <a:buSzPts val="3000"/>
+              <a:buFont typeface="Arial"/>
+              <a:buNone/>
+            </a:pPr>
+            <a:r>
+              <a:rPr lang="en" sz="2400">
+                <a:solidFill>
+                  <a:schemeClr val="dk2"/>
+                </a:solidFill>
+                <a:latin typeface="Twentieth Century"/>
+                <a:ea typeface="Twentieth Century"/>
+                <a:cs typeface="Twentieth Century"/>
+                <a:sym typeface="Twentieth Century"/>
+              </a:rPr>
+              <a:t>Autoencoders</a:t>
+            </a:r>
+            <a:endParaRPr sz="2400">
+              <a:solidFill>
+                <a:schemeClr val="dk2"/>
+              </a:solidFill>
+              <a:latin typeface="Twentieth Century"/>
+              <a:ea typeface="Twentieth Century"/>
+              <a:cs typeface="Twentieth Century"/>
+              <a:sym typeface="Twentieth Century"/>
+            </a:endParaRPr>
+          </a:p>
+        </p:txBody>
+      </p:sp>
+      <p:sp>
+        <p:nvSpPr>
+          <p:cNvPr id="6" name="Google Shape;189;g2f19d644e1e_1_90">
+            <a:extLst>
+              <a:ext uri="{FF2B5EF4-FFF2-40B4-BE49-F238E27FC236}">
+                <a16:creationId xmlns:a16="http://schemas.microsoft.com/office/drawing/2014/main" id="{19A1861C-CD1E-F9FC-BD14-3DCE37591AA8}"/>
+              </a:ext>
+            </a:extLst>
+          </p:cNvPr>
+          <p:cNvSpPr txBox="1"/>
+          <p:nvPr/>
+        </p:nvSpPr>
+        <p:spPr>
+          <a:xfrm>
+            <a:off x="1148853" y="1314320"/>
+            <a:ext cx="1044332" cy="317166"/>
+          </a:xfrm>
+          <a:prstGeom prst="rect">
+            <a:avLst/>
+          </a:prstGeom>
+          <a:noFill/>
+          <a:ln>
+            <a:noFill/>
+          </a:ln>
+        </p:spPr>
+        <p:txBody>
+          <a:bodyPr spcFirstLastPara="1" wrap="square" lIns="68575" tIns="34275" rIns="68575" bIns="34275" anchor="t" anchorCtr="0">
+            <a:noAutofit/>
+          </a:bodyPr>
+          <a:lstStyle/>
+          <a:p>
+            <a:pPr marL="0" marR="0" lvl="0" indent="0" algn="l" rtl="0">
+              <a:lnSpc>
+                <a:spcPct val="90000"/>
+              </a:lnSpc>
+              <a:spcBef>
+                <a:spcPts val="0"/>
+              </a:spcBef>
+              <a:spcAft>
+                <a:spcPts val="0"/>
+              </a:spcAft>
+              <a:buClr>
+                <a:srgbClr val="FF0000"/>
+              </a:buClr>
+              <a:buSzPts val="2100"/>
+              <a:buFont typeface="Arial"/>
+              <a:buNone/>
+            </a:pPr>
+            <a:r>
+              <a:rPr lang="es-ES" sz="2100" dirty="0">
+                <a:solidFill>
+                  <a:srgbClr val="FF0000"/>
+                </a:solidFill>
+                <a:latin typeface="Twentieth Century"/>
+                <a:ea typeface="Twentieth Century"/>
+                <a:cs typeface="Twentieth Century"/>
+                <a:sym typeface="Twentieth Century"/>
+              </a:rPr>
+              <a:t>K</a:t>
+            </a:r>
+            <a:r>
+              <a:rPr lang="en" sz="2100" dirty="0">
+                <a:solidFill>
+                  <a:srgbClr val="FF0000"/>
+                </a:solidFill>
+                <a:latin typeface="Twentieth Century"/>
+                <a:ea typeface="Twentieth Century"/>
+                <a:cs typeface="Twentieth Century"/>
+                <a:sym typeface="Twentieth Century"/>
+              </a:rPr>
+              <a:t>l=0</a:t>
+            </a:r>
+            <a:endParaRPr sz="2100" dirty="0">
+              <a:solidFill>
+                <a:srgbClr val="FF0000"/>
+              </a:solidFill>
+              <a:latin typeface="Twentieth Century"/>
+              <a:ea typeface="Twentieth Century"/>
+              <a:cs typeface="Twentieth Century"/>
+              <a:sym typeface="Twentieth Century"/>
+            </a:endParaRPr>
+          </a:p>
+        </p:txBody>
+      </p:sp>
+      <p:pic>
+        <p:nvPicPr>
+          <p:cNvPr id="8" name="Imagen 7">
+            <a:extLst>
+              <a:ext uri="{FF2B5EF4-FFF2-40B4-BE49-F238E27FC236}">
+                <a16:creationId xmlns:a16="http://schemas.microsoft.com/office/drawing/2014/main" id="{23337770-E30F-A72E-6F53-1C496080E7E5}"/>
+              </a:ext>
+            </a:extLst>
+          </p:cNvPr>
+          <p:cNvPicPr>
+            <a:picLocks noChangeAspect="1"/>
+          </p:cNvPicPr>
+          <p:nvPr/>
+        </p:nvPicPr>
+        <p:blipFill>
+          <a:blip r:embed="rId3"/>
+          <a:stretch>
+            <a:fillRect/>
+          </a:stretch>
+        </p:blipFill>
+        <p:spPr>
+          <a:xfrm>
+            <a:off x="3193205" y="1926692"/>
+            <a:ext cx="2880000" cy="2649600"/>
+          </a:xfrm>
+          <a:prstGeom prst="rect">
+            <a:avLst/>
+          </a:prstGeom>
+        </p:spPr>
+      </p:pic>
+      <p:pic>
+        <p:nvPicPr>
+          <p:cNvPr id="10" name="Imagen 9">
+            <a:extLst>
+              <a:ext uri="{FF2B5EF4-FFF2-40B4-BE49-F238E27FC236}">
+                <a16:creationId xmlns:a16="http://schemas.microsoft.com/office/drawing/2014/main" id="{6362ACDD-A284-08D5-5D33-8B49629A67A4}"/>
+              </a:ext>
+            </a:extLst>
+          </p:cNvPr>
+          <p:cNvPicPr>
+            <a:picLocks noChangeAspect="1"/>
+          </p:cNvPicPr>
+          <p:nvPr/>
+        </p:nvPicPr>
+        <p:blipFill>
+          <a:blip r:embed="rId4"/>
+          <a:stretch>
+            <a:fillRect/>
+          </a:stretch>
+        </p:blipFill>
+        <p:spPr>
+          <a:xfrm>
+            <a:off x="92199" y="1926691"/>
+            <a:ext cx="2880000" cy="2624154"/>
+          </a:xfrm>
+          <a:prstGeom prst="rect">
+            <a:avLst/>
+          </a:prstGeom>
+        </p:spPr>
+      </p:pic>
+      <p:pic>
+        <p:nvPicPr>
+          <p:cNvPr id="12" name="Imagen 11">
+            <a:extLst>
+              <a:ext uri="{FF2B5EF4-FFF2-40B4-BE49-F238E27FC236}">
+                <a16:creationId xmlns:a16="http://schemas.microsoft.com/office/drawing/2014/main" id="{9EAFBA3A-FAA1-2705-1BE6-952330CA59F8}"/>
+              </a:ext>
+            </a:extLst>
+          </p:cNvPr>
+          <p:cNvPicPr>
+            <a:picLocks noChangeAspect="1"/>
+          </p:cNvPicPr>
+          <p:nvPr/>
+        </p:nvPicPr>
+        <p:blipFill>
+          <a:blip r:embed="rId5"/>
+          <a:stretch>
+            <a:fillRect/>
+          </a:stretch>
+        </p:blipFill>
+        <p:spPr>
+          <a:xfrm>
+            <a:off x="6097825" y="1915559"/>
+            <a:ext cx="2880000" cy="2649600"/>
+          </a:xfrm>
+          <a:prstGeom prst="rect">
+            <a:avLst/>
+          </a:prstGeom>
+        </p:spPr>
+      </p:pic>
+      <p:sp>
+        <p:nvSpPr>
+          <p:cNvPr id="13" name="Google Shape;189;g2f19d644e1e_1_90">
+            <a:extLst>
+              <a:ext uri="{FF2B5EF4-FFF2-40B4-BE49-F238E27FC236}">
+                <a16:creationId xmlns:a16="http://schemas.microsoft.com/office/drawing/2014/main" id="{B3BF4D1C-C310-7879-287A-7B7A6B50BFBF}"/>
+              </a:ext>
+            </a:extLst>
+          </p:cNvPr>
+          <p:cNvSpPr txBox="1"/>
+          <p:nvPr/>
+        </p:nvSpPr>
+        <p:spPr>
+          <a:xfrm>
+            <a:off x="4319461" y="1314320"/>
+            <a:ext cx="1044332" cy="317166"/>
+          </a:xfrm>
+          <a:prstGeom prst="rect">
+            <a:avLst/>
+          </a:prstGeom>
+          <a:noFill/>
+          <a:ln>
+            <a:noFill/>
+          </a:ln>
+        </p:spPr>
+        <p:txBody>
+          <a:bodyPr spcFirstLastPara="1" wrap="square" lIns="68575" tIns="34275" rIns="68575" bIns="34275" anchor="t" anchorCtr="0">
+            <a:noAutofit/>
+          </a:bodyPr>
+          <a:lstStyle/>
+          <a:p>
+            <a:pPr marL="0" marR="0" lvl="0" indent="0" algn="l" rtl="0">
+              <a:lnSpc>
+                <a:spcPct val="90000"/>
+              </a:lnSpc>
+              <a:spcBef>
+                <a:spcPts val="0"/>
+              </a:spcBef>
+              <a:spcAft>
+                <a:spcPts val="0"/>
+              </a:spcAft>
+              <a:buClr>
+                <a:srgbClr val="FF0000"/>
+              </a:buClr>
+              <a:buSzPts val="2100"/>
+              <a:buFont typeface="Arial"/>
+              <a:buNone/>
+            </a:pPr>
+            <a:r>
+              <a:rPr lang="es-ES" sz="2100" dirty="0">
+                <a:solidFill>
+                  <a:srgbClr val="FF0000"/>
+                </a:solidFill>
+                <a:latin typeface="Twentieth Century"/>
+                <a:ea typeface="Twentieth Century"/>
+                <a:cs typeface="Twentieth Century"/>
+                <a:sym typeface="Twentieth Century"/>
+              </a:rPr>
+              <a:t>K</a:t>
+            </a:r>
+            <a:r>
+              <a:rPr lang="en" sz="2100" dirty="0">
+                <a:solidFill>
+                  <a:srgbClr val="FF0000"/>
+                </a:solidFill>
+                <a:latin typeface="Twentieth Century"/>
+                <a:ea typeface="Twentieth Century"/>
+                <a:cs typeface="Twentieth Century"/>
+                <a:sym typeface="Twentieth Century"/>
+              </a:rPr>
+              <a:t>l=0.25</a:t>
+            </a:r>
+            <a:endParaRPr sz="2100" dirty="0">
+              <a:solidFill>
+                <a:srgbClr val="FF0000"/>
+              </a:solidFill>
+              <a:latin typeface="Twentieth Century"/>
+              <a:ea typeface="Twentieth Century"/>
+              <a:cs typeface="Twentieth Century"/>
+              <a:sym typeface="Twentieth Century"/>
+            </a:endParaRPr>
+          </a:p>
+        </p:txBody>
+      </p:sp>
+      <p:sp>
+        <p:nvSpPr>
+          <p:cNvPr id="14" name="Google Shape;189;g2f19d644e1e_1_90">
+            <a:extLst>
+              <a:ext uri="{FF2B5EF4-FFF2-40B4-BE49-F238E27FC236}">
+                <a16:creationId xmlns:a16="http://schemas.microsoft.com/office/drawing/2014/main" id="{C2CF6083-D58F-AA54-214B-2B53926AE02C}"/>
+              </a:ext>
+            </a:extLst>
+          </p:cNvPr>
+          <p:cNvSpPr txBox="1"/>
+          <p:nvPr/>
+        </p:nvSpPr>
+        <p:spPr>
+          <a:xfrm>
+            <a:off x="7015659" y="1314320"/>
+            <a:ext cx="1044332" cy="317166"/>
+          </a:xfrm>
+          <a:prstGeom prst="rect">
+            <a:avLst/>
+          </a:prstGeom>
+          <a:noFill/>
+          <a:ln>
+            <a:noFill/>
+          </a:ln>
+        </p:spPr>
+        <p:txBody>
+          <a:bodyPr spcFirstLastPara="1" wrap="square" lIns="68575" tIns="34275" rIns="68575" bIns="34275" anchor="t" anchorCtr="0">
+            <a:noAutofit/>
+          </a:bodyPr>
+          <a:lstStyle/>
+          <a:p>
+            <a:pPr marL="0" marR="0" lvl="0" indent="0" algn="l" rtl="0">
+              <a:lnSpc>
+                <a:spcPct val="90000"/>
+              </a:lnSpc>
+              <a:spcBef>
+                <a:spcPts val="0"/>
+              </a:spcBef>
+              <a:spcAft>
+                <a:spcPts val="0"/>
+              </a:spcAft>
+              <a:buClr>
+                <a:srgbClr val="FF0000"/>
+              </a:buClr>
+              <a:buSzPts val="2100"/>
+              <a:buFont typeface="Arial"/>
+              <a:buNone/>
+            </a:pPr>
+            <a:r>
+              <a:rPr lang="es-ES" sz="2100" dirty="0">
+                <a:solidFill>
+                  <a:srgbClr val="FF0000"/>
+                </a:solidFill>
+                <a:latin typeface="Twentieth Century"/>
+                <a:ea typeface="Twentieth Century"/>
+                <a:cs typeface="Twentieth Century"/>
+                <a:sym typeface="Twentieth Century"/>
+              </a:rPr>
+              <a:t>K</a:t>
+            </a:r>
+            <a:r>
+              <a:rPr lang="en" sz="2100" dirty="0">
+                <a:solidFill>
+                  <a:srgbClr val="FF0000"/>
+                </a:solidFill>
+                <a:latin typeface="Twentieth Century"/>
+                <a:ea typeface="Twentieth Century"/>
+                <a:cs typeface="Twentieth Century"/>
+                <a:sym typeface="Twentieth Century"/>
+              </a:rPr>
+              <a:t>l=0.75</a:t>
+            </a:r>
+            <a:endParaRPr sz="2100" dirty="0">
+              <a:solidFill>
+                <a:srgbClr val="FF0000"/>
+              </a:solidFill>
+              <a:latin typeface="Twentieth Century"/>
+              <a:ea typeface="Twentieth Century"/>
+              <a:cs typeface="Twentieth Century"/>
+              <a:sym typeface="Twentieth Century"/>
+            </a:endParaRPr>
+          </a:p>
+        </p:txBody>
+      </p:sp>
+      <p:sp>
+        <p:nvSpPr>
+          <p:cNvPr id="15" name="Google Shape;189;g2f19d644e1e_1_90">
+            <a:extLst>
+              <a:ext uri="{FF2B5EF4-FFF2-40B4-BE49-F238E27FC236}">
+                <a16:creationId xmlns:a16="http://schemas.microsoft.com/office/drawing/2014/main" id="{590DA479-56F1-E6F3-42AA-DE5EA4F3E0A4}"/>
+              </a:ext>
+            </a:extLst>
+          </p:cNvPr>
+          <p:cNvSpPr txBox="1"/>
+          <p:nvPr/>
+        </p:nvSpPr>
+        <p:spPr>
+          <a:xfrm>
+            <a:off x="2880704" y="814500"/>
+            <a:ext cx="3671350" cy="317166"/>
+          </a:xfrm>
+          <a:prstGeom prst="rect">
+            <a:avLst/>
+          </a:prstGeom>
+          <a:noFill/>
+          <a:ln>
+            <a:noFill/>
+          </a:ln>
+        </p:spPr>
+        <p:txBody>
+          <a:bodyPr spcFirstLastPara="1" wrap="square" lIns="68575" tIns="34275" rIns="68575" bIns="34275" anchor="t" anchorCtr="0">
+            <a:noAutofit/>
+          </a:bodyPr>
+          <a:lstStyle/>
+          <a:p>
+            <a:pPr marL="0" marR="0" lvl="0" indent="0" algn="l" rtl="0">
+              <a:lnSpc>
+                <a:spcPct val="90000"/>
+              </a:lnSpc>
+              <a:spcBef>
+                <a:spcPts val="0"/>
+              </a:spcBef>
+              <a:spcAft>
+                <a:spcPts val="0"/>
+              </a:spcAft>
+              <a:buClr>
+                <a:srgbClr val="FF0000"/>
+              </a:buClr>
+              <a:buSzPts val="2100"/>
+              <a:buFont typeface="Arial"/>
+              <a:buNone/>
+            </a:pPr>
+            <a:r>
+              <a:rPr lang="es-AR" sz="2100" dirty="0">
+                <a:solidFill>
+                  <a:srgbClr val="FF0000"/>
+                </a:solidFill>
+                <a:latin typeface="Twentieth Century"/>
+                <a:ea typeface="Twentieth Century"/>
+                <a:cs typeface="Twentieth Century"/>
+                <a:sym typeface="Twentieth Century"/>
+              </a:rPr>
+              <a:t>VAE </a:t>
+            </a:r>
+            <a:r>
+              <a:rPr lang="es-AR" sz="2100" dirty="0" err="1">
+                <a:solidFill>
+                  <a:srgbClr val="FF0000"/>
+                </a:solidFill>
+                <a:latin typeface="Twentieth Century"/>
+                <a:ea typeface="Twentieth Century"/>
+                <a:cs typeface="Twentieth Century"/>
+                <a:sym typeface="Twentieth Century"/>
+              </a:rPr>
+              <a:t>autoencoder</a:t>
+            </a:r>
+            <a:r>
+              <a:rPr lang="es-AR" sz="2100" dirty="0">
+                <a:solidFill>
+                  <a:srgbClr val="FF0000"/>
+                </a:solidFill>
+                <a:latin typeface="Twentieth Century"/>
+                <a:ea typeface="Twentieth Century"/>
+                <a:cs typeface="Twentieth Century"/>
+                <a:sym typeface="Twentieth Century"/>
+              </a:rPr>
+              <a:t> convolucional</a:t>
+            </a:r>
+            <a:endParaRPr sz="2100" dirty="0">
+              <a:solidFill>
+                <a:srgbClr val="FF0000"/>
+              </a:solidFill>
+              <a:latin typeface="Twentieth Century"/>
+              <a:ea typeface="Twentieth Century"/>
+              <a:cs typeface="Twentieth Century"/>
+              <a:sym typeface="Twentieth Century"/>
+            </a:endParaRPr>
+          </a:p>
+        </p:txBody>
+      </p:sp>
+    </p:spTree>
+    <p:extLst>
+      <p:ext uri="{BB962C8B-B14F-4D97-AF65-F5344CB8AC3E}">
+        <p14:creationId xmlns:p14="http://schemas.microsoft.com/office/powerpoint/2010/main" val="289375536"/>
+      </p:ext>
+    </p:extLst>
+  </p:cSld>
+  <p:clrMapOvr>
+    <a:masterClrMapping/>
+  </p:clrMapOvr>
+</p:sld>
+</file>
+
+<file path=ppt/slides/slide18.xml><?xml version="1.0" encoding="utf-8"?>
+<p:sld xmlns:a="http://schemas.openxmlformats.org/drawingml/2006/main" xmlns:r="http://schemas.openxmlformats.org/officeDocument/2006/relationships" xmlns:p="http://schemas.openxmlformats.org/presentationml/2006/main">
+  <p:cSld>
+    <p:spTree>
+      <p:nvGrpSpPr>
+        <p:cNvPr id="1" name="Shape 187">
+          <a:extLst>
+            <a:ext uri="{FF2B5EF4-FFF2-40B4-BE49-F238E27FC236}">
+              <a16:creationId xmlns:a16="http://schemas.microsoft.com/office/drawing/2014/main" id="{D29405F6-7F81-E61D-806A-10C7D85E7FC2}"/>
+            </a:ext>
+          </a:extLst>
+        </p:cNvPr>
+        <p:cNvGrpSpPr/>
+        <p:nvPr/>
+      </p:nvGrpSpPr>
+      <p:grpSpPr>
+        <a:xfrm>
+          <a:off x="0" y="0"/>
+          <a:ext cx="0" cy="0"/>
+          <a:chOff x="0" y="0"/>
+          <a:chExt cx="0" cy="0"/>
+        </a:xfrm>
+      </p:grpSpPr>
+      <p:sp>
+        <p:nvSpPr>
+          <p:cNvPr id="188" name="Google Shape;188;g2f19d644e1e_1_90">
+            <a:extLst>
+              <a:ext uri="{FF2B5EF4-FFF2-40B4-BE49-F238E27FC236}">
+                <a16:creationId xmlns:a16="http://schemas.microsoft.com/office/drawing/2014/main" id="{B3615DAB-FC99-EF45-D3B3-785FFD7D348B}"/>
+              </a:ext>
+            </a:extLst>
+          </p:cNvPr>
+          <p:cNvSpPr txBox="1"/>
+          <p:nvPr/>
+        </p:nvSpPr>
+        <p:spPr>
+          <a:xfrm>
+            <a:off x="-129402" y="0"/>
+            <a:ext cx="9383400" cy="814500"/>
+          </a:xfrm>
+          <a:prstGeom prst="rect">
+            <a:avLst/>
+          </a:prstGeom>
+          <a:noFill/>
+          <a:ln>
+            <a:noFill/>
+          </a:ln>
+        </p:spPr>
+        <p:txBody>
+          <a:bodyPr spcFirstLastPara="1" wrap="square" lIns="68575" tIns="34275" rIns="68575" bIns="34275" anchor="t" anchorCtr="0">
+            <a:noAutofit/>
+          </a:bodyPr>
+          <a:lstStyle/>
+          <a:p>
+            <a:pPr marL="0" marR="0" lvl="0" indent="0" algn="ctr" rtl="0">
+              <a:lnSpc>
+                <a:spcPct val="120000"/>
+              </a:lnSpc>
+              <a:spcBef>
+                <a:spcPts val="0"/>
+              </a:spcBef>
+              <a:spcAft>
+                <a:spcPts val="0"/>
+              </a:spcAft>
+              <a:buClr>
+                <a:schemeClr val="dk1"/>
+              </a:buClr>
+              <a:buSzPts val="3000"/>
+              <a:buFont typeface="Arial"/>
+              <a:buNone/>
+            </a:pPr>
+            <a:r>
+              <a:rPr lang="en" sz="2400">
+                <a:solidFill>
+                  <a:schemeClr val="dk2"/>
+                </a:solidFill>
+                <a:latin typeface="Twentieth Century"/>
+                <a:ea typeface="Twentieth Century"/>
+                <a:cs typeface="Twentieth Century"/>
+                <a:sym typeface="Twentieth Century"/>
+              </a:rPr>
+              <a:t>Autoencoders</a:t>
+            </a:r>
+            <a:endParaRPr sz="2400">
+              <a:solidFill>
+                <a:schemeClr val="dk2"/>
+              </a:solidFill>
+              <a:latin typeface="Twentieth Century"/>
+              <a:ea typeface="Twentieth Century"/>
+              <a:cs typeface="Twentieth Century"/>
+              <a:sym typeface="Twentieth Century"/>
+            </a:endParaRPr>
+          </a:p>
+        </p:txBody>
+      </p:sp>
+      <p:pic>
+        <p:nvPicPr>
+          <p:cNvPr id="3" name="Imagen 2">
+            <a:extLst>
+              <a:ext uri="{FF2B5EF4-FFF2-40B4-BE49-F238E27FC236}">
+                <a16:creationId xmlns:a16="http://schemas.microsoft.com/office/drawing/2014/main" id="{4BB7FF96-0A4A-881B-92F2-2CDAE022ADEB}"/>
+              </a:ext>
+            </a:extLst>
+          </p:cNvPr>
+          <p:cNvPicPr>
+            <a:picLocks noChangeAspect="1"/>
+          </p:cNvPicPr>
+          <p:nvPr/>
+        </p:nvPicPr>
+        <p:blipFill>
+          <a:blip r:embed="rId3"/>
+          <a:stretch>
+            <a:fillRect/>
+          </a:stretch>
+        </p:blipFill>
+        <p:spPr>
+          <a:xfrm>
+            <a:off x="6002298" y="2077947"/>
+            <a:ext cx="2880000" cy="2519999"/>
+          </a:xfrm>
+          <a:prstGeom prst="rect">
+            <a:avLst/>
+          </a:prstGeom>
+        </p:spPr>
+      </p:pic>
+      <p:sp>
+        <p:nvSpPr>
+          <p:cNvPr id="4" name="Google Shape;189;g2f19d644e1e_1_90">
+            <a:extLst>
+              <a:ext uri="{FF2B5EF4-FFF2-40B4-BE49-F238E27FC236}">
+                <a16:creationId xmlns:a16="http://schemas.microsoft.com/office/drawing/2014/main" id="{5B839E1E-554B-65AC-A7C3-85FFDAB7A83F}"/>
+              </a:ext>
+            </a:extLst>
+          </p:cNvPr>
+          <p:cNvSpPr txBox="1"/>
+          <p:nvPr/>
+        </p:nvSpPr>
+        <p:spPr>
+          <a:xfrm>
+            <a:off x="3711382" y="919166"/>
+            <a:ext cx="1598952" cy="317166"/>
+          </a:xfrm>
+          <a:prstGeom prst="rect">
+            <a:avLst/>
+          </a:prstGeom>
+          <a:noFill/>
+          <a:ln>
+            <a:noFill/>
+          </a:ln>
+        </p:spPr>
+        <p:txBody>
+          <a:bodyPr spcFirstLastPara="1" wrap="square" lIns="68575" tIns="34275" rIns="68575" bIns="34275" anchor="t" anchorCtr="0">
+            <a:noAutofit/>
+          </a:bodyPr>
+          <a:lstStyle/>
+          <a:p>
+            <a:pPr marL="0" marR="0" lvl="0" indent="0" algn="l" rtl="0">
+              <a:lnSpc>
+                <a:spcPct val="90000"/>
+              </a:lnSpc>
+              <a:spcBef>
+                <a:spcPts val="0"/>
+              </a:spcBef>
+              <a:spcAft>
+                <a:spcPts val="0"/>
+              </a:spcAft>
+              <a:buClr>
+                <a:srgbClr val="FF0000"/>
+              </a:buClr>
+              <a:buSzPts val="2100"/>
+              <a:buFont typeface="Arial"/>
+              <a:buNone/>
+            </a:pPr>
+            <a:r>
+              <a:rPr lang="es-AR" sz="2100" dirty="0" err="1">
+                <a:solidFill>
+                  <a:srgbClr val="FF0000"/>
+                </a:solidFill>
+                <a:latin typeface="Twentieth Century"/>
+                <a:ea typeface="Twentieth Century"/>
+                <a:cs typeface="Twentieth Century"/>
+                <a:sym typeface="Twentieth Century"/>
+              </a:rPr>
+              <a:t>sparse</a:t>
+            </a:r>
+            <a:r>
+              <a:rPr lang="es-AR" sz="2100" dirty="0">
+                <a:solidFill>
+                  <a:srgbClr val="FF0000"/>
+                </a:solidFill>
+                <a:latin typeface="Twentieth Century"/>
+                <a:ea typeface="Twentieth Century"/>
+                <a:cs typeface="Twentieth Century"/>
+                <a:sym typeface="Twentieth Century"/>
+              </a:rPr>
+              <a:t> MLP</a:t>
+            </a:r>
+          </a:p>
+          <a:p>
+            <a:pPr marL="0" marR="0" lvl="0" indent="0" algn="l" rtl="0">
+              <a:lnSpc>
+                <a:spcPct val="90000"/>
+              </a:lnSpc>
+              <a:spcBef>
+                <a:spcPts val="0"/>
+              </a:spcBef>
+              <a:spcAft>
+                <a:spcPts val="0"/>
+              </a:spcAft>
+              <a:buClr>
+                <a:srgbClr val="FF0000"/>
+              </a:buClr>
+              <a:buSzPts val="2100"/>
+              <a:buFont typeface="Arial"/>
+              <a:buNone/>
+            </a:pPr>
+            <a:r>
+              <a:rPr lang="es-AR" sz="2100" dirty="0" err="1">
+                <a:solidFill>
+                  <a:srgbClr val="FF0000"/>
+                </a:solidFill>
+                <a:latin typeface="Twentieth Century"/>
+                <a:ea typeface="Twentieth Century"/>
+                <a:cs typeface="Twentieth Century"/>
+                <a:sym typeface="Twentieth Century"/>
+              </a:rPr>
+              <a:t>Zdim</a:t>
+            </a:r>
+            <a:r>
+              <a:rPr lang="es-AR" sz="2100" dirty="0">
+                <a:solidFill>
+                  <a:srgbClr val="FF0000"/>
+                </a:solidFill>
+                <a:latin typeface="Twentieth Century"/>
+                <a:ea typeface="Twentieth Century"/>
+                <a:cs typeface="Twentieth Century"/>
+                <a:sym typeface="Twentieth Century"/>
+              </a:rPr>
+              <a:t>: 32</a:t>
+            </a:r>
+          </a:p>
+          <a:p>
+            <a:pPr marL="0" marR="0" lvl="0" indent="0" algn="l" rtl="0">
+              <a:lnSpc>
+                <a:spcPct val="90000"/>
+              </a:lnSpc>
+              <a:spcBef>
+                <a:spcPts val="0"/>
+              </a:spcBef>
+              <a:spcAft>
+                <a:spcPts val="0"/>
+              </a:spcAft>
+              <a:buClr>
+                <a:srgbClr val="FF0000"/>
+              </a:buClr>
+              <a:buSzPts val="2100"/>
+              <a:buFont typeface="Arial"/>
+              <a:buNone/>
+            </a:pPr>
+            <a:r>
+              <a:rPr lang="es-AR" sz="2100" dirty="0">
+                <a:solidFill>
+                  <a:srgbClr val="FF0000"/>
+                </a:solidFill>
+                <a:latin typeface="Twentieth Century"/>
+                <a:ea typeface="Twentieth Century"/>
+                <a:cs typeface="Twentieth Century"/>
+                <a:sym typeface="Twentieth Century"/>
+              </a:rPr>
+              <a:t>L1: 5e-4</a:t>
+            </a:r>
+            <a:endParaRPr sz="2100" dirty="0">
+              <a:solidFill>
+                <a:srgbClr val="FF0000"/>
+              </a:solidFill>
+              <a:latin typeface="Twentieth Century"/>
+              <a:ea typeface="Twentieth Century"/>
+              <a:cs typeface="Twentieth Century"/>
+              <a:sym typeface="Twentieth Century"/>
+            </a:endParaRPr>
+          </a:p>
+        </p:txBody>
+      </p:sp>
+      <p:pic>
+        <p:nvPicPr>
+          <p:cNvPr id="6" name="Imagen 5">
+            <a:extLst>
+              <a:ext uri="{FF2B5EF4-FFF2-40B4-BE49-F238E27FC236}">
+                <a16:creationId xmlns:a16="http://schemas.microsoft.com/office/drawing/2014/main" id="{736236D8-E150-6244-93D2-BC1EEA48D45F}"/>
+              </a:ext>
+            </a:extLst>
+          </p:cNvPr>
+          <p:cNvPicPr>
+            <a:picLocks noChangeAspect="1"/>
+          </p:cNvPicPr>
+          <p:nvPr/>
+        </p:nvPicPr>
+        <p:blipFill>
+          <a:blip r:embed="rId4"/>
+          <a:stretch>
+            <a:fillRect/>
+          </a:stretch>
+        </p:blipFill>
+        <p:spPr>
+          <a:xfrm>
+            <a:off x="3122298" y="2112833"/>
+            <a:ext cx="2880000" cy="2520000"/>
+          </a:xfrm>
+          <a:prstGeom prst="rect">
+            <a:avLst/>
+          </a:prstGeom>
+        </p:spPr>
+      </p:pic>
+      <p:sp>
+        <p:nvSpPr>
+          <p:cNvPr id="7" name="Google Shape;189;g2f19d644e1e_1_90">
+            <a:extLst>
+              <a:ext uri="{FF2B5EF4-FFF2-40B4-BE49-F238E27FC236}">
+                <a16:creationId xmlns:a16="http://schemas.microsoft.com/office/drawing/2014/main" id="{BEE56B23-341F-DBD7-E8DA-372DDE715C9E}"/>
+              </a:ext>
+            </a:extLst>
+          </p:cNvPr>
+          <p:cNvSpPr txBox="1"/>
+          <p:nvPr/>
+        </p:nvSpPr>
+        <p:spPr>
+          <a:xfrm>
+            <a:off x="6850727" y="996318"/>
+            <a:ext cx="1598952" cy="317166"/>
+          </a:xfrm>
+          <a:prstGeom prst="rect">
+            <a:avLst/>
+          </a:prstGeom>
+          <a:noFill/>
+          <a:ln>
+            <a:noFill/>
+          </a:ln>
+        </p:spPr>
+        <p:txBody>
+          <a:bodyPr spcFirstLastPara="1" wrap="square" lIns="68575" tIns="34275" rIns="68575" bIns="34275" anchor="t" anchorCtr="0">
+            <a:noAutofit/>
+          </a:bodyPr>
+          <a:lstStyle/>
+          <a:p>
+            <a:pPr marL="0" marR="0" lvl="0" indent="0" algn="l" rtl="0">
+              <a:lnSpc>
+                <a:spcPct val="90000"/>
+              </a:lnSpc>
+              <a:spcBef>
+                <a:spcPts val="0"/>
+              </a:spcBef>
+              <a:spcAft>
+                <a:spcPts val="0"/>
+              </a:spcAft>
+              <a:buClr>
+                <a:srgbClr val="FF0000"/>
+              </a:buClr>
+              <a:buSzPts val="2100"/>
+              <a:buFont typeface="Arial"/>
+              <a:buNone/>
+            </a:pPr>
+            <a:r>
+              <a:rPr lang="es-AR" sz="2100" dirty="0">
+                <a:solidFill>
+                  <a:srgbClr val="FF0000"/>
+                </a:solidFill>
+                <a:latin typeface="Twentieth Century"/>
+                <a:ea typeface="Twentieth Century"/>
+                <a:cs typeface="Twentieth Century"/>
+                <a:sym typeface="Twentieth Century"/>
+              </a:rPr>
+              <a:t>VAE MLP</a:t>
+            </a:r>
+          </a:p>
+          <a:p>
+            <a:pPr marL="0" marR="0" lvl="0" indent="0" algn="l" rtl="0">
+              <a:lnSpc>
+                <a:spcPct val="90000"/>
+              </a:lnSpc>
+              <a:spcBef>
+                <a:spcPts val="0"/>
+              </a:spcBef>
+              <a:spcAft>
+                <a:spcPts val="0"/>
+              </a:spcAft>
+              <a:buClr>
+                <a:srgbClr val="FF0000"/>
+              </a:buClr>
+              <a:buSzPts val="2100"/>
+              <a:buFont typeface="Arial"/>
+              <a:buNone/>
+            </a:pPr>
+            <a:r>
+              <a:rPr lang="es-AR" sz="2100" dirty="0" err="1">
+                <a:solidFill>
+                  <a:srgbClr val="FF0000"/>
+                </a:solidFill>
+                <a:latin typeface="Twentieth Century"/>
+                <a:ea typeface="Twentieth Century"/>
+                <a:cs typeface="Twentieth Century"/>
+                <a:sym typeface="Twentieth Century"/>
+              </a:rPr>
+              <a:t>Zdim</a:t>
+            </a:r>
+            <a:r>
+              <a:rPr lang="es-AR" sz="2100" dirty="0">
+                <a:solidFill>
+                  <a:srgbClr val="FF0000"/>
+                </a:solidFill>
+                <a:latin typeface="Twentieth Century"/>
+                <a:ea typeface="Twentieth Century"/>
+                <a:cs typeface="Twentieth Century"/>
+                <a:sym typeface="Twentieth Century"/>
+              </a:rPr>
+              <a:t>: 32</a:t>
+            </a:r>
+          </a:p>
+          <a:p>
+            <a:pPr marL="0" marR="0" lvl="0" indent="0" algn="l" rtl="0">
+              <a:lnSpc>
+                <a:spcPct val="90000"/>
+              </a:lnSpc>
+              <a:spcBef>
+                <a:spcPts val="0"/>
+              </a:spcBef>
+              <a:spcAft>
+                <a:spcPts val="0"/>
+              </a:spcAft>
+              <a:buClr>
+                <a:srgbClr val="FF0000"/>
+              </a:buClr>
+              <a:buSzPts val="2100"/>
+              <a:buFont typeface="Arial"/>
+              <a:buNone/>
+            </a:pPr>
+            <a:r>
+              <a:rPr lang="es-AR" sz="2100" dirty="0">
+                <a:solidFill>
+                  <a:srgbClr val="FF0000"/>
+                </a:solidFill>
+                <a:latin typeface="Twentieth Century"/>
+                <a:ea typeface="Twentieth Century"/>
+                <a:cs typeface="Twentieth Century"/>
+                <a:sym typeface="Twentieth Century"/>
+              </a:rPr>
+              <a:t>Kl: 1e-4</a:t>
+            </a:r>
+            <a:endParaRPr sz="2100" dirty="0">
+              <a:solidFill>
+                <a:srgbClr val="FF0000"/>
+              </a:solidFill>
+              <a:latin typeface="Twentieth Century"/>
+              <a:ea typeface="Twentieth Century"/>
+              <a:cs typeface="Twentieth Century"/>
+              <a:sym typeface="Twentieth Century"/>
+            </a:endParaRPr>
+          </a:p>
+        </p:txBody>
+      </p:sp>
+      <p:pic>
+        <p:nvPicPr>
+          <p:cNvPr id="9" name="Imagen 8">
+            <a:extLst>
+              <a:ext uri="{FF2B5EF4-FFF2-40B4-BE49-F238E27FC236}">
+                <a16:creationId xmlns:a16="http://schemas.microsoft.com/office/drawing/2014/main" id="{01DD52B7-6D92-C044-AFBB-50DB34546169}"/>
+              </a:ext>
+            </a:extLst>
+          </p:cNvPr>
+          <p:cNvPicPr>
+            <a:picLocks noChangeAspect="1"/>
+          </p:cNvPicPr>
+          <p:nvPr/>
+        </p:nvPicPr>
+        <p:blipFill>
+          <a:blip r:embed="rId5"/>
+          <a:stretch>
+            <a:fillRect/>
+          </a:stretch>
+        </p:blipFill>
+        <p:spPr>
+          <a:xfrm>
+            <a:off x="147816" y="2112833"/>
+            <a:ext cx="2880000" cy="2520000"/>
+          </a:xfrm>
+          <a:prstGeom prst="rect">
+            <a:avLst/>
+          </a:prstGeom>
+        </p:spPr>
+      </p:pic>
+      <p:sp>
+        <p:nvSpPr>
+          <p:cNvPr id="10" name="Google Shape;189;g2f19d644e1e_1_90">
+            <a:extLst>
+              <a:ext uri="{FF2B5EF4-FFF2-40B4-BE49-F238E27FC236}">
+                <a16:creationId xmlns:a16="http://schemas.microsoft.com/office/drawing/2014/main" id="{5C64B54E-77D2-53F4-ED48-4839DF7770D9}"/>
+              </a:ext>
+            </a:extLst>
+          </p:cNvPr>
+          <p:cNvSpPr txBox="1"/>
+          <p:nvPr/>
+        </p:nvSpPr>
+        <p:spPr>
+          <a:xfrm>
+            <a:off x="694321" y="970474"/>
+            <a:ext cx="1598952" cy="317166"/>
+          </a:xfrm>
+          <a:prstGeom prst="rect">
+            <a:avLst/>
+          </a:prstGeom>
+          <a:noFill/>
+          <a:ln>
+            <a:noFill/>
+          </a:ln>
+        </p:spPr>
+        <p:txBody>
+          <a:bodyPr spcFirstLastPara="1" wrap="square" lIns="68575" tIns="34275" rIns="68575" bIns="34275" anchor="t" anchorCtr="0">
+            <a:noAutofit/>
+          </a:bodyPr>
+          <a:lstStyle/>
+          <a:p>
+            <a:pPr marL="0" marR="0" lvl="0" indent="0" algn="l" rtl="0">
+              <a:lnSpc>
+                <a:spcPct val="90000"/>
+              </a:lnSpc>
+              <a:spcBef>
+                <a:spcPts val="0"/>
+              </a:spcBef>
+              <a:spcAft>
+                <a:spcPts val="0"/>
+              </a:spcAft>
+              <a:buClr>
+                <a:srgbClr val="FF0000"/>
+              </a:buClr>
+              <a:buSzPts val="2100"/>
+              <a:buFont typeface="Arial"/>
+              <a:buNone/>
+            </a:pPr>
+            <a:r>
+              <a:rPr lang="es-AR" sz="2100" dirty="0">
+                <a:solidFill>
+                  <a:srgbClr val="FF0000"/>
+                </a:solidFill>
+                <a:latin typeface="Twentieth Century"/>
+                <a:ea typeface="Twentieth Century"/>
+                <a:cs typeface="Twentieth Century"/>
+                <a:sym typeface="Twentieth Century"/>
+              </a:rPr>
+              <a:t>MLP</a:t>
+            </a:r>
+          </a:p>
+          <a:p>
+            <a:pPr marL="0" marR="0" lvl="0" indent="0" algn="l" rtl="0">
+              <a:lnSpc>
+                <a:spcPct val="90000"/>
+              </a:lnSpc>
+              <a:spcBef>
+                <a:spcPts val="0"/>
+              </a:spcBef>
+              <a:spcAft>
+                <a:spcPts val="0"/>
+              </a:spcAft>
+              <a:buClr>
+                <a:srgbClr val="FF0000"/>
+              </a:buClr>
+              <a:buSzPts val="2100"/>
+              <a:buFont typeface="Arial"/>
+              <a:buNone/>
+            </a:pPr>
+            <a:r>
+              <a:rPr lang="es-AR" sz="2100" dirty="0" err="1">
+                <a:solidFill>
+                  <a:srgbClr val="FF0000"/>
+                </a:solidFill>
+                <a:latin typeface="Twentieth Century"/>
+                <a:ea typeface="Twentieth Century"/>
+                <a:cs typeface="Twentieth Century"/>
+                <a:sym typeface="Twentieth Century"/>
+              </a:rPr>
+              <a:t>Zdim</a:t>
+            </a:r>
+            <a:r>
+              <a:rPr lang="es-AR" sz="2100" dirty="0">
+                <a:solidFill>
+                  <a:srgbClr val="FF0000"/>
+                </a:solidFill>
+                <a:latin typeface="Twentieth Century"/>
+                <a:ea typeface="Twentieth Century"/>
+                <a:cs typeface="Twentieth Century"/>
+                <a:sym typeface="Twentieth Century"/>
+              </a:rPr>
+              <a:t>: 32</a:t>
+            </a:r>
+          </a:p>
+        </p:txBody>
+      </p:sp>
+      <p:sp>
+        <p:nvSpPr>
+          <p:cNvPr id="11" name="Google Shape;189;g2f19d644e1e_1_90">
+            <a:extLst>
+              <a:ext uri="{FF2B5EF4-FFF2-40B4-BE49-F238E27FC236}">
+                <a16:creationId xmlns:a16="http://schemas.microsoft.com/office/drawing/2014/main" id="{245BCB9B-BC5E-A8D9-B15C-291C94FEC326}"/>
+              </a:ext>
+            </a:extLst>
+          </p:cNvPr>
+          <p:cNvSpPr txBox="1"/>
+          <p:nvPr/>
+        </p:nvSpPr>
+        <p:spPr>
+          <a:xfrm>
+            <a:off x="788340" y="4691096"/>
+            <a:ext cx="1598952" cy="317166"/>
+          </a:xfrm>
+          <a:prstGeom prst="rect">
+            <a:avLst/>
+          </a:prstGeom>
+          <a:noFill/>
+          <a:ln>
+            <a:noFill/>
+          </a:ln>
+        </p:spPr>
+        <p:txBody>
+          <a:bodyPr spcFirstLastPara="1" wrap="square" lIns="68575" tIns="34275" rIns="68575" bIns="34275" anchor="t" anchorCtr="0">
+            <a:noAutofit/>
+          </a:bodyPr>
+          <a:lstStyle/>
+          <a:p>
+            <a:pPr marL="0" marR="0" lvl="0" indent="0" algn="l" rtl="0">
+              <a:lnSpc>
+                <a:spcPct val="90000"/>
+              </a:lnSpc>
+              <a:spcBef>
+                <a:spcPts val="0"/>
+              </a:spcBef>
+              <a:spcAft>
+                <a:spcPts val="0"/>
+              </a:spcAft>
+              <a:buClr>
+                <a:srgbClr val="FF0000"/>
+              </a:buClr>
+              <a:buSzPts val="2100"/>
+              <a:buFont typeface="Arial"/>
+              <a:buNone/>
+            </a:pPr>
+            <a:r>
+              <a:rPr lang="es-AR" sz="2100" dirty="0">
+                <a:solidFill>
+                  <a:srgbClr val="FF0000"/>
+                </a:solidFill>
+                <a:latin typeface="Twentieth Century"/>
+                <a:ea typeface="Twentieth Century"/>
+                <a:cs typeface="Twentieth Century"/>
+                <a:sym typeface="Twentieth Century"/>
+              </a:rPr>
+              <a:t>MSE: 0.0431</a:t>
+            </a:r>
+          </a:p>
+        </p:txBody>
+      </p:sp>
+      <p:sp>
+        <p:nvSpPr>
+          <p:cNvPr id="12" name="Google Shape;189;g2f19d644e1e_1_90">
+            <a:extLst>
+              <a:ext uri="{FF2B5EF4-FFF2-40B4-BE49-F238E27FC236}">
+                <a16:creationId xmlns:a16="http://schemas.microsoft.com/office/drawing/2014/main" id="{B9315433-840C-5FED-1729-50367699B95C}"/>
+              </a:ext>
+            </a:extLst>
+          </p:cNvPr>
+          <p:cNvSpPr txBox="1"/>
+          <p:nvPr/>
+        </p:nvSpPr>
+        <p:spPr>
+          <a:xfrm>
+            <a:off x="3772524" y="4656130"/>
+            <a:ext cx="1598952" cy="317166"/>
+          </a:xfrm>
+          <a:prstGeom prst="rect">
+            <a:avLst/>
+          </a:prstGeom>
+          <a:noFill/>
+          <a:ln>
+            <a:noFill/>
+          </a:ln>
+        </p:spPr>
+        <p:txBody>
+          <a:bodyPr spcFirstLastPara="1" wrap="square" lIns="68575" tIns="34275" rIns="68575" bIns="34275" anchor="t" anchorCtr="0">
+            <a:noAutofit/>
+          </a:bodyPr>
+          <a:lstStyle/>
+          <a:p>
+            <a:pPr marL="0" marR="0" lvl="0" indent="0" algn="l" rtl="0">
+              <a:lnSpc>
+                <a:spcPct val="90000"/>
+              </a:lnSpc>
+              <a:spcBef>
+                <a:spcPts val="0"/>
+              </a:spcBef>
+              <a:spcAft>
+                <a:spcPts val="0"/>
+              </a:spcAft>
+              <a:buClr>
+                <a:srgbClr val="FF0000"/>
+              </a:buClr>
+              <a:buSzPts val="2100"/>
+              <a:buFont typeface="Arial"/>
+              <a:buNone/>
+            </a:pPr>
+            <a:r>
+              <a:rPr lang="es-AR" sz="2100" dirty="0">
+                <a:solidFill>
+                  <a:srgbClr val="FF0000"/>
+                </a:solidFill>
+                <a:latin typeface="Twentieth Century"/>
+                <a:ea typeface="Twentieth Century"/>
+                <a:cs typeface="Twentieth Century"/>
+                <a:sym typeface="Twentieth Century"/>
+              </a:rPr>
+              <a:t>MSE: 0.0457</a:t>
+            </a:r>
+          </a:p>
+        </p:txBody>
+      </p:sp>
+      <p:sp>
+        <p:nvSpPr>
+          <p:cNvPr id="13" name="Google Shape;189;g2f19d644e1e_1_90">
+            <a:extLst>
+              <a:ext uri="{FF2B5EF4-FFF2-40B4-BE49-F238E27FC236}">
+                <a16:creationId xmlns:a16="http://schemas.microsoft.com/office/drawing/2014/main" id="{3AECCDD5-CA7D-1C2A-6F6E-498E4B0AFE57}"/>
+              </a:ext>
+            </a:extLst>
+          </p:cNvPr>
+          <p:cNvSpPr txBox="1"/>
+          <p:nvPr/>
+        </p:nvSpPr>
+        <p:spPr>
+          <a:xfrm>
+            <a:off x="6588054" y="4597946"/>
+            <a:ext cx="1598952" cy="317166"/>
+          </a:xfrm>
+          <a:prstGeom prst="rect">
+            <a:avLst/>
+          </a:prstGeom>
+          <a:noFill/>
+          <a:ln>
+            <a:noFill/>
+          </a:ln>
+        </p:spPr>
+        <p:txBody>
+          <a:bodyPr spcFirstLastPara="1" wrap="square" lIns="68575" tIns="34275" rIns="68575" bIns="34275" anchor="t" anchorCtr="0">
+            <a:noAutofit/>
+          </a:bodyPr>
+          <a:lstStyle/>
+          <a:p>
+            <a:pPr marL="0" marR="0" lvl="0" indent="0" algn="l" rtl="0">
+              <a:lnSpc>
+                <a:spcPct val="90000"/>
+              </a:lnSpc>
+              <a:spcBef>
+                <a:spcPts val="0"/>
+              </a:spcBef>
+              <a:spcAft>
+                <a:spcPts val="0"/>
+              </a:spcAft>
+              <a:buClr>
+                <a:srgbClr val="FF0000"/>
+              </a:buClr>
+              <a:buSzPts val="2100"/>
+              <a:buFont typeface="Arial"/>
+              <a:buNone/>
+            </a:pPr>
+            <a:r>
+              <a:rPr lang="es-AR" sz="2100" dirty="0">
+                <a:solidFill>
+                  <a:srgbClr val="FF0000"/>
+                </a:solidFill>
+                <a:latin typeface="Twentieth Century"/>
+                <a:ea typeface="Twentieth Century"/>
+                <a:cs typeface="Twentieth Century"/>
+                <a:sym typeface="Twentieth Century"/>
+              </a:rPr>
+              <a:t>MSE: 0.0440</a:t>
+            </a:r>
+          </a:p>
+        </p:txBody>
+      </p:sp>
+    </p:spTree>
+    <p:extLst>
+      <p:ext uri="{BB962C8B-B14F-4D97-AF65-F5344CB8AC3E}">
+        <p14:creationId xmlns:p14="http://schemas.microsoft.com/office/powerpoint/2010/main" val="3636683501"/>
+      </p:ext>
+    </p:extLst>
+  </p:cSld>
+  <p:clrMapOvr>
+    <a:masterClrMapping/>
+  </p:clrMapOvr>
+</p:sld>
+</file>
+
+<file path=ppt/slides/slide19.xml><?xml version="1.0" encoding="utf-8"?>
+<p:sld xmlns:a="http://schemas.openxmlformats.org/drawingml/2006/main" xmlns:r="http://schemas.openxmlformats.org/officeDocument/2006/relationships" xmlns:p="http://schemas.openxmlformats.org/presentationml/2006/main">
+  <p:cSld>
+    <p:spTree>
+      <p:nvGrpSpPr>
+        <p:cNvPr id="1" name="Shape 187">
+          <a:extLst>
+            <a:ext uri="{FF2B5EF4-FFF2-40B4-BE49-F238E27FC236}">
+              <a16:creationId xmlns:a16="http://schemas.microsoft.com/office/drawing/2014/main" id="{3EADC6E9-5E89-A1DB-7334-3B54724C7008}"/>
+            </a:ext>
+          </a:extLst>
+        </p:cNvPr>
+        <p:cNvGrpSpPr/>
+        <p:nvPr/>
+      </p:nvGrpSpPr>
+      <p:grpSpPr>
+        <a:xfrm>
+          <a:off x="0" y="0"/>
+          <a:ext cx="0" cy="0"/>
+          <a:chOff x="0" y="0"/>
+          <a:chExt cx="0" cy="0"/>
+        </a:xfrm>
+      </p:grpSpPr>
+      <p:sp>
+        <p:nvSpPr>
+          <p:cNvPr id="188" name="Google Shape;188;g2f19d644e1e_1_90">
+            <a:extLst>
+              <a:ext uri="{FF2B5EF4-FFF2-40B4-BE49-F238E27FC236}">
+                <a16:creationId xmlns:a16="http://schemas.microsoft.com/office/drawing/2014/main" id="{43D4DF03-0E23-2525-8250-9AE1FF4979A7}"/>
+              </a:ext>
+            </a:extLst>
+          </p:cNvPr>
+          <p:cNvSpPr txBox="1"/>
+          <p:nvPr/>
+        </p:nvSpPr>
+        <p:spPr>
+          <a:xfrm>
+            <a:off x="-129402" y="0"/>
+            <a:ext cx="9383400" cy="814500"/>
+          </a:xfrm>
+          <a:prstGeom prst="rect">
+            <a:avLst/>
+          </a:prstGeom>
+          <a:noFill/>
+          <a:ln>
+            <a:noFill/>
+          </a:ln>
+        </p:spPr>
+        <p:txBody>
+          <a:bodyPr spcFirstLastPara="1" wrap="square" lIns="68575" tIns="34275" rIns="68575" bIns="34275" anchor="t" anchorCtr="0">
+            <a:noAutofit/>
+          </a:bodyPr>
+          <a:lstStyle/>
+          <a:p>
+            <a:pPr marL="0" marR="0" lvl="0" indent="0" algn="ctr" rtl="0">
+              <a:lnSpc>
+                <a:spcPct val="120000"/>
+              </a:lnSpc>
+              <a:spcBef>
+                <a:spcPts val="0"/>
+              </a:spcBef>
+              <a:spcAft>
+                <a:spcPts val="0"/>
+              </a:spcAft>
+              <a:buClr>
+                <a:schemeClr val="dk1"/>
+              </a:buClr>
+              <a:buSzPts val="3000"/>
+              <a:buFont typeface="Arial"/>
+              <a:buNone/>
+            </a:pPr>
+            <a:r>
+              <a:rPr lang="en" sz="2400">
+                <a:solidFill>
+                  <a:schemeClr val="dk2"/>
+                </a:solidFill>
+                <a:latin typeface="Twentieth Century"/>
+                <a:ea typeface="Twentieth Century"/>
+                <a:cs typeface="Twentieth Century"/>
+                <a:sym typeface="Twentieth Century"/>
+              </a:rPr>
+              <a:t>Autoencoders</a:t>
+            </a:r>
+            <a:endParaRPr sz="2400">
+              <a:solidFill>
+                <a:schemeClr val="dk2"/>
+              </a:solidFill>
+              <a:latin typeface="Twentieth Century"/>
+              <a:ea typeface="Twentieth Century"/>
+              <a:cs typeface="Twentieth Century"/>
+              <a:sym typeface="Twentieth Century"/>
+            </a:endParaRPr>
+          </a:p>
+        </p:txBody>
+      </p:sp>
+      <p:sp>
+        <p:nvSpPr>
+          <p:cNvPr id="4" name="Google Shape;189;g2f19d644e1e_1_90">
+            <a:extLst>
+              <a:ext uri="{FF2B5EF4-FFF2-40B4-BE49-F238E27FC236}">
+                <a16:creationId xmlns:a16="http://schemas.microsoft.com/office/drawing/2014/main" id="{C0AD1CD5-313C-8345-35E1-EE490B62DE69}"/>
+              </a:ext>
+            </a:extLst>
+          </p:cNvPr>
+          <p:cNvSpPr txBox="1"/>
+          <p:nvPr/>
+        </p:nvSpPr>
+        <p:spPr>
+          <a:xfrm>
+            <a:off x="3711382" y="919166"/>
+            <a:ext cx="1598952" cy="317166"/>
+          </a:xfrm>
+          <a:prstGeom prst="rect">
+            <a:avLst/>
+          </a:prstGeom>
+          <a:noFill/>
+          <a:ln>
+            <a:noFill/>
+          </a:ln>
+        </p:spPr>
+        <p:txBody>
+          <a:bodyPr spcFirstLastPara="1" wrap="square" lIns="68575" tIns="34275" rIns="68575" bIns="34275" anchor="t" anchorCtr="0">
+            <a:noAutofit/>
+          </a:bodyPr>
+          <a:lstStyle/>
+          <a:p>
+            <a:pPr marL="0" marR="0" lvl="0" indent="0" algn="l" rtl="0">
+              <a:lnSpc>
+                <a:spcPct val="90000"/>
+              </a:lnSpc>
+              <a:spcBef>
+                <a:spcPts val="0"/>
+              </a:spcBef>
+              <a:spcAft>
+                <a:spcPts val="0"/>
+              </a:spcAft>
+              <a:buClr>
+                <a:srgbClr val="FF0000"/>
+              </a:buClr>
+              <a:buSzPts val="2100"/>
+              <a:buFont typeface="Arial"/>
+              <a:buNone/>
+            </a:pPr>
+            <a:r>
+              <a:rPr lang="es-AR" sz="2100" dirty="0" err="1">
+                <a:solidFill>
+                  <a:srgbClr val="FF0000"/>
+                </a:solidFill>
+                <a:latin typeface="Twentieth Century"/>
+                <a:ea typeface="Twentieth Century"/>
+                <a:cs typeface="Twentieth Century"/>
+                <a:sym typeface="Twentieth Century"/>
+              </a:rPr>
+              <a:t>sparse</a:t>
+            </a:r>
+            <a:r>
+              <a:rPr lang="es-AR" sz="2100" dirty="0">
+                <a:solidFill>
+                  <a:srgbClr val="FF0000"/>
+                </a:solidFill>
+                <a:latin typeface="Twentieth Century"/>
+                <a:ea typeface="Twentieth Century"/>
+                <a:cs typeface="Twentieth Century"/>
+                <a:sym typeface="Twentieth Century"/>
+              </a:rPr>
+              <a:t> MLP</a:t>
+            </a:r>
+          </a:p>
+          <a:p>
+            <a:pPr marL="0" marR="0" lvl="0" indent="0" algn="l" rtl="0">
+              <a:lnSpc>
+                <a:spcPct val="90000"/>
+              </a:lnSpc>
+              <a:spcBef>
+                <a:spcPts val="0"/>
+              </a:spcBef>
+              <a:spcAft>
+                <a:spcPts val="0"/>
+              </a:spcAft>
+              <a:buClr>
+                <a:srgbClr val="FF0000"/>
+              </a:buClr>
+              <a:buSzPts val="2100"/>
+              <a:buFont typeface="Arial"/>
+              <a:buNone/>
+            </a:pPr>
+            <a:r>
+              <a:rPr lang="es-AR" sz="2100" dirty="0" err="1">
+                <a:solidFill>
+                  <a:srgbClr val="FF0000"/>
+                </a:solidFill>
+                <a:latin typeface="Twentieth Century"/>
+                <a:ea typeface="Twentieth Century"/>
+                <a:cs typeface="Twentieth Century"/>
+                <a:sym typeface="Twentieth Century"/>
+              </a:rPr>
+              <a:t>Zdim</a:t>
+            </a:r>
+            <a:r>
+              <a:rPr lang="es-AR" sz="2100" dirty="0">
+                <a:solidFill>
+                  <a:srgbClr val="FF0000"/>
+                </a:solidFill>
+                <a:latin typeface="Twentieth Century"/>
+                <a:ea typeface="Twentieth Century"/>
+                <a:cs typeface="Twentieth Century"/>
+                <a:sym typeface="Twentieth Century"/>
+              </a:rPr>
+              <a:t>: 32</a:t>
+            </a:r>
+          </a:p>
+          <a:p>
+            <a:pPr marL="0" marR="0" lvl="0" indent="0" algn="l" rtl="0">
+              <a:lnSpc>
+                <a:spcPct val="90000"/>
+              </a:lnSpc>
+              <a:spcBef>
+                <a:spcPts val="0"/>
+              </a:spcBef>
+              <a:spcAft>
+                <a:spcPts val="0"/>
+              </a:spcAft>
+              <a:buClr>
+                <a:srgbClr val="FF0000"/>
+              </a:buClr>
+              <a:buSzPts val="2100"/>
+              <a:buFont typeface="Arial"/>
+              <a:buNone/>
+            </a:pPr>
+            <a:r>
+              <a:rPr lang="es-AR" sz="2100" dirty="0">
+                <a:solidFill>
+                  <a:srgbClr val="FF0000"/>
+                </a:solidFill>
+                <a:latin typeface="Twentieth Century"/>
+                <a:ea typeface="Twentieth Century"/>
+                <a:cs typeface="Twentieth Century"/>
+                <a:sym typeface="Twentieth Century"/>
+              </a:rPr>
+              <a:t>L1: 5e-4</a:t>
+            </a:r>
+            <a:endParaRPr sz="2100" dirty="0">
+              <a:solidFill>
+                <a:srgbClr val="FF0000"/>
+              </a:solidFill>
+              <a:latin typeface="Twentieth Century"/>
+              <a:ea typeface="Twentieth Century"/>
+              <a:cs typeface="Twentieth Century"/>
+              <a:sym typeface="Twentieth Century"/>
+            </a:endParaRPr>
+          </a:p>
+        </p:txBody>
+      </p:sp>
+      <p:sp>
+        <p:nvSpPr>
+          <p:cNvPr id="7" name="Google Shape;189;g2f19d644e1e_1_90">
+            <a:extLst>
+              <a:ext uri="{FF2B5EF4-FFF2-40B4-BE49-F238E27FC236}">
+                <a16:creationId xmlns:a16="http://schemas.microsoft.com/office/drawing/2014/main" id="{157AADA2-0864-34B0-682A-FC33B129A56A}"/>
+              </a:ext>
+            </a:extLst>
+          </p:cNvPr>
+          <p:cNvSpPr txBox="1"/>
+          <p:nvPr/>
+        </p:nvSpPr>
+        <p:spPr>
+          <a:xfrm>
+            <a:off x="6850727" y="996318"/>
+            <a:ext cx="1598952" cy="317166"/>
+          </a:xfrm>
+          <a:prstGeom prst="rect">
+            <a:avLst/>
+          </a:prstGeom>
+          <a:noFill/>
+          <a:ln>
+            <a:noFill/>
+          </a:ln>
+        </p:spPr>
+        <p:txBody>
+          <a:bodyPr spcFirstLastPara="1" wrap="square" lIns="68575" tIns="34275" rIns="68575" bIns="34275" anchor="t" anchorCtr="0">
+            <a:noAutofit/>
+          </a:bodyPr>
+          <a:lstStyle/>
+          <a:p>
+            <a:pPr marL="0" marR="0" lvl="0" indent="0" algn="l" rtl="0">
+              <a:lnSpc>
+                <a:spcPct val="90000"/>
+              </a:lnSpc>
+              <a:spcBef>
+                <a:spcPts val="0"/>
+              </a:spcBef>
+              <a:spcAft>
+                <a:spcPts val="0"/>
+              </a:spcAft>
+              <a:buClr>
+                <a:srgbClr val="FF0000"/>
+              </a:buClr>
+              <a:buSzPts val="2100"/>
+              <a:buFont typeface="Arial"/>
+              <a:buNone/>
+            </a:pPr>
+            <a:r>
+              <a:rPr lang="es-AR" sz="2100" dirty="0">
+                <a:solidFill>
+                  <a:srgbClr val="FF0000"/>
+                </a:solidFill>
+                <a:latin typeface="Twentieth Century"/>
+                <a:ea typeface="Twentieth Century"/>
+                <a:cs typeface="Twentieth Century"/>
+                <a:sym typeface="Twentieth Century"/>
+              </a:rPr>
+              <a:t>VAE MLP</a:t>
+            </a:r>
+          </a:p>
+          <a:p>
+            <a:pPr marL="0" marR="0" lvl="0" indent="0" algn="l" rtl="0">
+              <a:lnSpc>
+                <a:spcPct val="90000"/>
+              </a:lnSpc>
+              <a:spcBef>
+                <a:spcPts val="0"/>
+              </a:spcBef>
+              <a:spcAft>
+                <a:spcPts val="0"/>
+              </a:spcAft>
+              <a:buClr>
+                <a:srgbClr val="FF0000"/>
+              </a:buClr>
+              <a:buSzPts val="2100"/>
+              <a:buFont typeface="Arial"/>
+              <a:buNone/>
+            </a:pPr>
+            <a:r>
+              <a:rPr lang="es-AR" sz="2100" dirty="0" err="1">
+                <a:solidFill>
+                  <a:srgbClr val="FF0000"/>
+                </a:solidFill>
+                <a:latin typeface="Twentieth Century"/>
+                <a:ea typeface="Twentieth Century"/>
+                <a:cs typeface="Twentieth Century"/>
+                <a:sym typeface="Twentieth Century"/>
+              </a:rPr>
+              <a:t>Zdim</a:t>
+            </a:r>
+            <a:r>
+              <a:rPr lang="es-AR" sz="2100" dirty="0">
+                <a:solidFill>
+                  <a:srgbClr val="FF0000"/>
+                </a:solidFill>
+                <a:latin typeface="Twentieth Century"/>
+                <a:ea typeface="Twentieth Century"/>
+                <a:cs typeface="Twentieth Century"/>
+                <a:sym typeface="Twentieth Century"/>
+              </a:rPr>
+              <a:t>: 32</a:t>
+            </a:r>
+          </a:p>
+          <a:p>
+            <a:pPr marL="0" marR="0" lvl="0" indent="0" algn="l" rtl="0">
+              <a:lnSpc>
+                <a:spcPct val="90000"/>
+              </a:lnSpc>
+              <a:spcBef>
+                <a:spcPts val="0"/>
+              </a:spcBef>
+              <a:spcAft>
+                <a:spcPts val="0"/>
+              </a:spcAft>
+              <a:buClr>
+                <a:srgbClr val="FF0000"/>
+              </a:buClr>
+              <a:buSzPts val="2100"/>
+              <a:buFont typeface="Arial"/>
+              <a:buNone/>
+            </a:pPr>
+            <a:r>
+              <a:rPr lang="es-AR" sz="2100" dirty="0">
+                <a:solidFill>
+                  <a:srgbClr val="FF0000"/>
+                </a:solidFill>
+                <a:latin typeface="Twentieth Century"/>
+                <a:ea typeface="Twentieth Century"/>
+                <a:cs typeface="Twentieth Century"/>
+                <a:sym typeface="Twentieth Century"/>
+              </a:rPr>
+              <a:t>Kl: 1e-4</a:t>
+            </a:r>
+            <a:endParaRPr sz="2100" dirty="0">
+              <a:solidFill>
+                <a:srgbClr val="FF0000"/>
+              </a:solidFill>
+              <a:latin typeface="Twentieth Century"/>
+              <a:ea typeface="Twentieth Century"/>
+              <a:cs typeface="Twentieth Century"/>
+              <a:sym typeface="Twentieth Century"/>
+            </a:endParaRPr>
+          </a:p>
+        </p:txBody>
+      </p:sp>
+      <p:sp>
+        <p:nvSpPr>
+          <p:cNvPr id="10" name="Google Shape;189;g2f19d644e1e_1_90">
+            <a:extLst>
+              <a:ext uri="{FF2B5EF4-FFF2-40B4-BE49-F238E27FC236}">
+                <a16:creationId xmlns:a16="http://schemas.microsoft.com/office/drawing/2014/main" id="{38743EAC-28CD-9FA0-BECC-C083B56EC437}"/>
+              </a:ext>
+            </a:extLst>
+          </p:cNvPr>
+          <p:cNvSpPr txBox="1"/>
+          <p:nvPr/>
+        </p:nvSpPr>
+        <p:spPr>
+          <a:xfrm>
+            <a:off x="694321" y="970474"/>
+            <a:ext cx="1598952" cy="317166"/>
+          </a:xfrm>
+          <a:prstGeom prst="rect">
+            <a:avLst/>
+          </a:prstGeom>
+          <a:noFill/>
+          <a:ln>
+            <a:noFill/>
+          </a:ln>
+        </p:spPr>
+        <p:txBody>
+          <a:bodyPr spcFirstLastPara="1" wrap="square" lIns="68575" tIns="34275" rIns="68575" bIns="34275" anchor="t" anchorCtr="0">
+            <a:noAutofit/>
+          </a:bodyPr>
+          <a:lstStyle/>
+          <a:p>
+            <a:pPr marL="0" marR="0" lvl="0" indent="0" algn="l" rtl="0">
+              <a:lnSpc>
+                <a:spcPct val="90000"/>
+              </a:lnSpc>
+              <a:spcBef>
+                <a:spcPts val="0"/>
+              </a:spcBef>
+              <a:spcAft>
+                <a:spcPts val="0"/>
+              </a:spcAft>
+              <a:buClr>
+                <a:srgbClr val="FF0000"/>
+              </a:buClr>
+              <a:buSzPts val="2100"/>
+              <a:buFont typeface="Arial"/>
+              <a:buNone/>
+            </a:pPr>
+            <a:r>
+              <a:rPr lang="es-AR" sz="2100" dirty="0">
+                <a:solidFill>
+                  <a:srgbClr val="FF0000"/>
+                </a:solidFill>
+                <a:latin typeface="Twentieth Century"/>
+                <a:ea typeface="Twentieth Century"/>
+                <a:cs typeface="Twentieth Century"/>
+                <a:sym typeface="Twentieth Century"/>
+              </a:rPr>
+              <a:t>MLP</a:t>
+            </a:r>
+          </a:p>
+          <a:p>
+            <a:pPr marL="0" marR="0" lvl="0" indent="0" algn="l" rtl="0">
+              <a:lnSpc>
+                <a:spcPct val="90000"/>
+              </a:lnSpc>
+              <a:spcBef>
+                <a:spcPts val="0"/>
+              </a:spcBef>
+              <a:spcAft>
+                <a:spcPts val="0"/>
+              </a:spcAft>
+              <a:buClr>
+                <a:srgbClr val="FF0000"/>
+              </a:buClr>
+              <a:buSzPts val="2100"/>
+              <a:buFont typeface="Arial"/>
+              <a:buNone/>
+            </a:pPr>
+            <a:r>
+              <a:rPr lang="es-AR" sz="2100" dirty="0" err="1">
+                <a:solidFill>
+                  <a:srgbClr val="FF0000"/>
+                </a:solidFill>
+                <a:latin typeface="Twentieth Century"/>
+                <a:ea typeface="Twentieth Century"/>
+                <a:cs typeface="Twentieth Century"/>
+                <a:sym typeface="Twentieth Century"/>
+              </a:rPr>
+              <a:t>Zdim</a:t>
+            </a:r>
+            <a:r>
+              <a:rPr lang="es-AR" sz="2100" dirty="0">
+                <a:solidFill>
+                  <a:srgbClr val="FF0000"/>
+                </a:solidFill>
+                <a:latin typeface="Twentieth Century"/>
+                <a:ea typeface="Twentieth Century"/>
+                <a:cs typeface="Twentieth Century"/>
+                <a:sym typeface="Twentieth Century"/>
+              </a:rPr>
+              <a:t>: 32</a:t>
+            </a:r>
+          </a:p>
+        </p:txBody>
+      </p:sp>
+      <p:sp>
+        <p:nvSpPr>
+          <p:cNvPr id="11" name="Google Shape;189;g2f19d644e1e_1_90">
+            <a:extLst>
+              <a:ext uri="{FF2B5EF4-FFF2-40B4-BE49-F238E27FC236}">
+                <a16:creationId xmlns:a16="http://schemas.microsoft.com/office/drawing/2014/main" id="{720055BD-D7D0-FC30-865A-55AA61DE09DC}"/>
+              </a:ext>
+            </a:extLst>
+          </p:cNvPr>
+          <p:cNvSpPr txBox="1"/>
+          <p:nvPr/>
+        </p:nvSpPr>
+        <p:spPr>
+          <a:xfrm>
+            <a:off x="788340" y="4691096"/>
+            <a:ext cx="1598952" cy="317166"/>
+          </a:xfrm>
+          <a:prstGeom prst="rect">
+            <a:avLst/>
+          </a:prstGeom>
+          <a:noFill/>
+          <a:ln>
+            <a:noFill/>
+          </a:ln>
+        </p:spPr>
+        <p:txBody>
+          <a:bodyPr spcFirstLastPara="1" wrap="square" lIns="68575" tIns="34275" rIns="68575" bIns="34275" anchor="t" anchorCtr="0">
+            <a:noAutofit/>
+          </a:bodyPr>
+          <a:lstStyle/>
+          <a:p>
+            <a:pPr marL="0" marR="0" lvl="0" indent="0" algn="l" rtl="0">
+              <a:lnSpc>
+                <a:spcPct val="90000"/>
+              </a:lnSpc>
+              <a:spcBef>
+                <a:spcPts val="0"/>
+              </a:spcBef>
+              <a:spcAft>
+                <a:spcPts val="0"/>
+              </a:spcAft>
+              <a:buClr>
+                <a:srgbClr val="FF0000"/>
+              </a:buClr>
+              <a:buSzPts val="2100"/>
+              <a:buFont typeface="Arial"/>
+              <a:buNone/>
+            </a:pPr>
+            <a:r>
+              <a:rPr lang="es-AR" sz="2100" dirty="0">
+                <a:solidFill>
+                  <a:srgbClr val="FF0000"/>
+                </a:solidFill>
+                <a:latin typeface="Twentieth Century"/>
+                <a:ea typeface="Twentieth Century"/>
+                <a:cs typeface="Twentieth Century"/>
+                <a:sym typeface="Twentieth Century"/>
+              </a:rPr>
+              <a:t>MSE: 0.0431</a:t>
+            </a:r>
+          </a:p>
+        </p:txBody>
+      </p:sp>
+      <p:sp>
+        <p:nvSpPr>
+          <p:cNvPr id="12" name="Google Shape;189;g2f19d644e1e_1_90">
+            <a:extLst>
+              <a:ext uri="{FF2B5EF4-FFF2-40B4-BE49-F238E27FC236}">
+                <a16:creationId xmlns:a16="http://schemas.microsoft.com/office/drawing/2014/main" id="{E6D49E6B-AA33-2ECE-16AF-4FEA9DD67BB2}"/>
+              </a:ext>
+            </a:extLst>
+          </p:cNvPr>
+          <p:cNvSpPr txBox="1"/>
+          <p:nvPr/>
+        </p:nvSpPr>
+        <p:spPr>
+          <a:xfrm>
+            <a:off x="3772524" y="4656130"/>
+            <a:ext cx="1598952" cy="317166"/>
+          </a:xfrm>
+          <a:prstGeom prst="rect">
+            <a:avLst/>
+          </a:prstGeom>
+          <a:noFill/>
+          <a:ln>
+            <a:noFill/>
+          </a:ln>
+        </p:spPr>
+        <p:txBody>
+          <a:bodyPr spcFirstLastPara="1" wrap="square" lIns="68575" tIns="34275" rIns="68575" bIns="34275" anchor="t" anchorCtr="0">
+            <a:noAutofit/>
+          </a:bodyPr>
+          <a:lstStyle/>
+          <a:p>
+            <a:pPr marL="0" marR="0" lvl="0" indent="0" algn="l" rtl="0">
+              <a:lnSpc>
+                <a:spcPct val="90000"/>
+              </a:lnSpc>
+              <a:spcBef>
+                <a:spcPts val="0"/>
+              </a:spcBef>
+              <a:spcAft>
+                <a:spcPts val="0"/>
+              </a:spcAft>
+              <a:buClr>
+                <a:srgbClr val="FF0000"/>
+              </a:buClr>
+              <a:buSzPts val="2100"/>
+              <a:buFont typeface="Arial"/>
+              <a:buNone/>
+            </a:pPr>
+            <a:r>
+              <a:rPr lang="es-AR" sz="2100" dirty="0">
+                <a:solidFill>
+                  <a:srgbClr val="FF0000"/>
+                </a:solidFill>
+                <a:latin typeface="Twentieth Century"/>
+                <a:ea typeface="Twentieth Century"/>
+                <a:cs typeface="Twentieth Century"/>
+                <a:sym typeface="Twentieth Century"/>
+              </a:rPr>
+              <a:t>MSE: 0.0457</a:t>
+            </a:r>
+          </a:p>
+        </p:txBody>
+      </p:sp>
+      <p:sp>
+        <p:nvSpPr>
+          <p:cNvPr id="13" name="Google Shape;189;g2f19d644e1e_1_90">
+            <a:extLst>
+              <a:ext uri="{FF2B5EF4-FFF2-40B4-BE49-F238E27FC236}">
+                <a16:creationId xmlns:a16="http://schemas.microsoft.com/office/drawing/2014/main" id="{44954AE5-4D2C-BC9E-5B16-45CEAD3F25CD}"/>
+              </a:ext>
+            </a:extLst>
+          </p:cNvPr>
+          <p:cNvSpPr txBox="1"/>
+          <p:nvPr/>
+        </p:nvSpPr>
+        <p:spPr>
+          <a:xfrm>
+            <a:off x="6588054" y="4597946"/>
+            <a:ext cx="1598952" cy="317166"/>
+          </a:xfrm>
+          <a:prstGeom prst="rect">
+            <a:avLst/>
+          </a:prstGeom>
+          <a:noFill/>
+          <a:ln>
+            <a:noFill/>
+          </a:ln>
+        </p:spPr>
+        <p:txBody>
+          <a:bodyPr spcFirstLastPara="1" wrap="square" lIns="68575" tIns="34275" rIns="68575" bIns="34275" anchor="t" anchorCtr="0">
+            <a:noAutofit/>
+          </a:bodyPr>
+          <a:lstStyle/>
+          <a:p>
+            <a:pPr marL="0" marR="0" lvl="0" indent="0" algn="l" rtl="0">
+              <a:lnSpc>
+                <a:spcPct val="90000"/>
+              </a:lnSpc>
+              <a:spcBef>
+                <a:spcPts val="0"/>
+              </a:spcBef>
+              <a:spcAft>
+                <a:spcPts val="0"/>
+              </a:spcAft>
+              <a:buClr>
+                <a:srgbClr val="FF0000"/>
+              </a:buClr>
+              <a:buSzPts val="2100"/>
+              <a:buFont typeface="Arial"/>
+              <a:buNone/>
+            </a:pPr>
+            <a:r>
+              <a:rPr lang="es-AR" sz="2100" dirty="0">
+                <a:solidFill>
+                  <a:srgbClr val="FF0000"/>
+                </a:solidFill>
+                <a:latin typeface="Twentieth Century"/>
+                <a:ea typeface="Twentieth Century"/>
+                <a:cs typeface="Twentieth Century"/>
+                <a:sym typeface="Twentieth Century"/>
+              </a:rPr>
+              <a:t>MSE: 0.0440</a:t>
+            </a:r>
+          </a:p>
+        </p:txBody>
+      </p:sp>
+      <p:pic>
+        <p:nvPicPr>
+          <p:cNvPr id="5" name="Imagen 4">
+            <a:extLst>
+              <a:ext uri="{FF2B5EF4-FFF2-40B4-BE49-F238E27FC236}">
+                <a16:creationId xmlns:a16="http://schemas.microsoft.com/office/drawing/2014/main" id="{6D46FC77-5229-22CA-AB3E-65B9588CE8DB}"/>
+              </a:ext>
+            </a:extLst>
+          </p:cNvPr>
+          <p:cNvPicPr>
+            <a:picLocks noChangeAspect="1"/>
+          </p:cNvPicPr>
+          <p:nvPr/>
+        </p:nvPicPr>
+        <p:blipFill>
+          <a:blip r:embed="rId3"/>
+          <a:stretch>
+            <a:fillRect/>
+          </a:stretch>
+        </p:blipFill>
+        <p:spPr>
+          <a:xfrm>
+            <a:off x="53797" y="2269368"/>
+            <a:ext cx="2880000" cy="1440000"/>
+          </a:xfrm>
+          <a:prstGeom prst="rect">
+            <a:avLst/>
+          </a:prstGeom>
+        </p:spPr>
+      </p:pic>
+      <p:pic>
+        <p:nvPicPr>
+          <p:cNvPr id="14" name="Imagen 13">
+            <a:extLst>
+              <a:ext uri="{FF2B5EF4-FFF2-40B4-BE49-F238E27FC236}">
+                <a16:creationId xmlns:a16="http://schemas.microsoft.com/office/drawing/2014/main" id="{E15E41EE-6008-E7F4-8976-B6C2188F6885}"/>
+              </a:ext>
+            </a:extLst>
+          </p:cNvPr>
+          <p:cNvPicPr>
+            <a:picLocks noChangeAspect="1"/>
+          </p:cNvPicPr>
+          <p:nvPr/>
+        </p:nvPicPr>
+        <p:blipFill>
+          <a:blip r:embed="rId4"/>
+          <a:stretch>
+            <a:fillRect/>
+          </a:stretch>
+        </p:blipFill>
+        <p:spPr>
+          <a:xfrm>
+            <a:off x="3122298" y="2269368"/>
+            <a:ext cx="2880000" cy="1440000"/>
+          </a:xfrm>
+          <a:prstGeom prst="rect">
+            <a:avLst/>
+          </a:prstGeom>
+        </p:spPr>
+      </p:pic>
+      <p:pic>
+        <p:nvPicPr>
+          <p:cNvPr id="16" name="Imagen 15">
+            <a:extLst>
+              <a:ext uri="{FF2B5EF4-FFF2-40B4-BE49-F238E27FC236}">
+                <a16:creationId xmlns:a16="http://schemas.microsoft.com/office/drawing/2014/main" id="{00191610-9F0D-9904-AF50-B51EF8BB15EC}"/>
+              </a:ext>
+            </a:extLst>
+          </p:cNvPr>
+          <p:cNvPicPr>
+            <a:picLocks noChangeAspect="1"/>
+          </p:cNvPicPr>
+          <p:nvPr/>
+        </p:nvPicPr>
+        <p:blipFill>
+          <a:blip r:embed="rId5"/>
+          <a:stretch>
+            <a:fillRect/>
+          </a:stretch>
+        </p:blipFill>
+        <p:spPr>
+          <a:xfrm>
+            <a:off x="6118917" y="2269368"/>
+            <a:ext cx="2880000" cy="1440000"/>
+          </a:xfrm>
+          <a:prstGeom prst="rect">
+            <a:avLst/>
+          </a:prstGeom>
+        </p:spPr>
+      </p:pic>
+    </p:spTree>
+    <p:extLst>
+      <p:ext uri="{BB962C8B-B14F-4D97-AF65-F5344CB8AC3E}">
+        <p14:creationId xmlns:p14="http://schemas.microsoft.com/office/powerpoint/2010/main" val="3925028538"/>
+      </p:ext>
+    </p:extLst>
+  </p:cSld>
+  <p:clrMapOvr>
+    <a:masterClrMapping/>
+  </p:clrMapOvr>
+</p:sld>
+</file>
+
+<file path=ppt/slides/slide2.xml><?xml version="1.0" encoding="utf-8"?>
+<p:sld xmlns:a="http://schemas.openxmlformats.org/drawingml/2006/main" xmlns:r="http://schemas.openxmlformats.org/officeDocument/2006/relationships" xmlns:p="http://schemas.openxmlformats.org/presentationml/2006/main">
+  <p:cSld>
+    <p:spTree>
+      <p:nvGrpSpPr>
+        <p:cNvPr id="1" name="Shape 80"/>
+        <p:cNvGrpSpPr/>
+        <p:nvPr/>
+      </p:nvGrpSpPr>
+      <p:grpSpPr>
+        <a:xfrm>
+          <a:off x="0" y="0"/>
+          <a:ext cx="0" cy="0"/>
+          <a:chOff x="0" y="0"/>
+          <a:chExt cx="0" cy="0"/>
+        </a:xfrm>
+      </p:grpSpPr>
+      <p:sp>
+        <p:nvSpPr>
+          <p:cNvPr id="81" name="Google Shape;81;p2"/>
+          <p:cNvSpPr txBox="1">
+            <a:spLocks noGrp="1"/>
+          </p:cNvSpPr>
+          <p:nvPr>
+            <p:ph type="title"/>
+          </p:nvPr>
+        </p:nvSpPr>
+        <p:spPr>
+          <a:xfrm>
+            <a:off x="460950" y="303000"/>
+            <a:ext cx="8222100" cy="937500"/>
+          </a:xfrm>
+          <a:prstGeom prst="rect">
+            <a:avLst/>
+          </a:prstGeom>
+          <a:noFill/>
+          <a:ln>
+            <a:noFill/>
+          </a:ln>
+        </p:spPr>
+        <p:txBody>
+          <a:bodyPr spcFirstLastPara="1" wrap="square" lIns="91425" tIns="91425" rIns="91425" bIns="91425" anchor="b" anchorCtr="0">
+            <a:noAutofit/>
+          </a:bodyPr>
+          <a:lstStyle/>
+          <a:p>
+            <a:pPr marL="0" lvl="0" indent="0" algn="ctr" rtl="0">
+              <a:lnSpc>
+                <a:spcPct val="120000"/>
+              </a:lnSpc>
+              <a:spcBef>
+                <a:spcPts val="800"/>
+              </a:spcBef>
+              <a:spcAft>
+                <a:spcPts val="0"/>
+              </a:spcAft>
+              <a:buClr>
+                <a:schemeClr val="dk1"/>
+              </a:buClr>
+              <a:buSzPts val="2600"/>
+              <a:buFont typeface="Arial"/>
+              <a:buNone/>
+            </a:pPr>
+            <a:r>
+              <a:rPr lang="en" sz="2100" dirty="0"/>
+              <a:t>REPRESENTATION LEARNING </a:t>
+            </a:r>
+            <a:br>
+              <a:rPr lang="en" sz="2100" dirty="0"/>
+            </a:br>
+            <a:r>
+              <a:rPr lang="en" sz="2100" dirty="0"/>
+              <a:t>AUTOENCODER / EMBEDDINGS</a:t>
+            </a:r>
+            <a:endParaRPr sz="2818" dirty="0">
+              <a:latin typeface="Arial"/>
+              <a:ea typeface="Arial"/>
+              <a:cs typeface="Arial"/>
+              <a:sym typeface="Arial"/>
+            </a:endParaRPr>
+          </a:p>
+        </p:txBody>
+      </p:sp>
+      <p:sp>
+        <p:nvSpPr>
+          <p:cNvPr id="82" name="Google Shape;82;p2"/>
+          <p:cNvSpPr txBox="1">
+            <a:spLocks noGrp="1"/>
+          </p:cNvSpPr>
+          <p:nvPr>
+            <p:ph type="body" idx="1"/>
+          </p:nvPr>
+        </p:nvSpPr>
+        <p:spPr>
+          <a:xfrm>
+            <a:off x="403148" y="2776300"/>
+            <a:ext cx="3598950" cy="2152875"/>
+          </a:xfrm>
+          <a:prstGeom prst="rect">
+            <a:avLst/>
+          </a:prstGeom>
+          <a:noFill/>
+          <a:ln>
+            <a:noFill/>
+          </a:ln>
+        </p:spPr>
+        <p:txBody>
+          <a:bodyPr spcFirstLastPara="1" wrap="square" lIns="91425" tIns="91425" rIns="91425" bIns="91425" anchor="t" anchorCtr="0">
+            <a:noAutofit/>
+          </a:bodyPr>
+          <a:lstStyle/>
+          <a:p>
+            <a:pPr marL="0" lvl="0" indent="0" algn="l" rtl="0">
+              <a:lnSpc>
+                <a:spcPct val="95000"/>
+              </a:lnSpc>
+              <a:spcBef>
+                <a:spcPts val="0"/>
+              </a:spcBef>
+              <a:spcAft>
+                <a:spcPts val="0"/>
+              </a:spcAft>
+              <a:buSzPts val="1018"/>
+              <a:buNone/>
+            </a:pPr>
+            <a:r>
+              <a:rPr lang="en" dirty="0">
+                <a:solidFill>
+                  <a:schemeClr val="dk2"/>
+                </a:solidFill>
+              </a:rPr>
+              <a:t>. Autoencoders</a:t>
+            </a:r>
+          </a:p>
+          <a:p>
+            <a:pPr marL="0" lvl="0" indent="0" algn="l" rtl="0">
+              <a:lnSpc>
+                <a:spcPct val="95000"/>
+              </a:lnSpc>
+              <a:spcBef>
+                <a:spcPts val="0"/>
+              </a:spcBef>
+              <a:spcAft>
+                <a:spcPts val="0"/>
+              </a:spcAft>
+              <a:buSzPts val="1018"/>
+              <a:buNone/>
+            </a:pPr>
+            <a:endParaRPr lang="en" dirty="0">
+              <a:solidFill>
+                <a:schemeClr val="dk2"/>
+              </a:solidFill>
+            </a:endParaRPr>
+          </a:p>
+          <a:p>
+            <a:pPr marL="0" lvl="0" indent="0" algn="l" rtl="0">
+              <a:lnSpc>
+                <a:spcPct val="95000"/>
+              </a:lnSpc>
+              <a:spcBef>
+                <a:spcPts val="0"/>
+              </a:spcBef>
+              <a:spcAft>
+                <a:spcPts val="0"/>
+              </a:spcAft>
+              <a:buSzPts val="1018"/>
+              <a:buNone/>
+            </a:pPr>
+            <a:r>
+              <a:rPr lang="es-AR" dirty="0">
+                <a:solidFill>
+                  <a:schemeClr val="dk2"/>
+                </a:solidFill>
+              </a:rPr>
+              <a:t>U</a:t>
+            </a:r>
+            <a:r>
+              <a:rPr lang="en" dirty="0">
+                <a:solidFill>
+                  <a:schemeClr val="dk2"/>
+                </a:solidFill>
+              </a:rPr>
+              <a:t>ndercomplete vs regularized AE</a:t>
+            </a:r>
+          </a:p>
+          <a:p>
+            <a:pPr marL="0" lvl="0" indent="0" algn="l" rtl="0">
+              <a:lnSpc>
+                <a:spcPct val="95000"/>
+              </a:lnSpc>
+              <a:spcBef>
+                <a:spcPts val="0"/>
+              </a:spcBef>
+              <a:spcAft>
+                <a:spcPts val="0"/>
+              </a:spcAft>
+              <a:buSzPts val="1018"/>
+              <a:buNone/>
+            </a:pPr>
+            <a:endParaRPr lang="en" dirty="0">
+              <a:solidFill>
+                <a:schemeClr val="dk2"/>
+              </a:solidFill>
+            </a:endParaRPr>
+          </a:p>
+          <a:p>
+            <a:pPr marL="0" lvl="0" indent="0" algn="l" rtl="0">
+              <a:lnSpc>
+                <a:spcPct val="95000"/>
+              </a:lnSpc>
+              <a:spcBef>
+                <a:spcPts val="0"/>
+              </a:spcBef>
+              <a:spcAft>
+                <a:spcPts val="0"/>
+              </a:spcAft>
+              <a:buSzPts val="1018"/>
+              <a:buNone/>
+            </a:pPr>
+            <a:r>
+              <a:rPr lang="en" dirty="0">
+                <a:solidFill>
+                  <a:schemeClr val="dk2"/>
+                </a:solidFill>
+              </a:rPr>
+              <a:t>Manifold learning</a:t>
+            </a:r>
+          </a:p>
+          <a:p>
+            <a:pPr marL="0" lvl="0" indent="0" algn="l" rtl="0">
+              <a:lnSpc>
+                <a:spcPct val="95000"/>
+              </a:lnSpc>
+              <a:spcBef>
+                <a:spcPts val="0"/>
+              </a:spcBef>
+              <a:spcAft>
+                <a:spcPts val="0"/>
+              </a:spcAft>
+              <a:buSzPts val="1018"/>
+              <a:buNone/>
+            </a:pPr>
+            <a:endParaRPr lang="en" dirty="0">
+              <a:solidFill>
+                <a:schemeClr val="dk2"/>
+              </a:solidFill>
+            </a:endParaRPr>
+          </a:p>
+          <a:p>
+            <a:pPr marL="0" lvl="0" indent="0" algn="l" rtl="0">
+              <a:lnSpc>
+                <a:spcPct val="95000"/>
+              </a:lnSpc>
+              <a:spcBef>
+                <a:spcPts val="0"/>
+              </a:spcBef>
+              <a:spcAft>
+                <a:spcPts val="0"/>
+              </a:spcAft>
+              <a:buSzPts val="1018"/>
+              <a:buNone/>
+            </a:pPr>
+            <a:r>
+              <a:rPr lang="en" dirty="0">
+                <a:solidFill>
+                  <a:schemeClr val="dk2"/>
+                </a:solidFill>
+              </a:rPr>
+              <a:t>Varational AE</a:t>
+            </a:r>
+          </a:p>
+          <a:p>
+            <a:pPr marL="0" lvl="0" indent="0" algn="l" rtl="0">
+              <a:lnSpc>
+                <a:spcPct val="95000"/>
+              </a:lnSpc>
+              <a:spcBef>
+                <a:spcPts val="0"/>
+              </a:spcBef>
+              <a:spcAft>
+                <a:spcPts val="0"/>
+              </a:spcAft>
+              <a:buSzPts val="1018"/>
+              <a:buNone/>
+            </a:pPr>
+            <a:endParaRPr lang="en" dirty="0">
+              <a:solidFill>
+                <a:schemeClr val="dk2"/>
+              </a:solidFill>
+            </a:endParaRPr>
+          </a:p>
+          <a:p>
+            <a:pPr marL="0" lvl="0" indent="0" algn="l" rtl="0">
+              <a:lnSpc>
+                <a:spcPct val="95000"/>
+              </a:lnSpc>
+              <a:spcBef>
+                <a:spcPts val="1200"/>
+              </a:spcBef>
+              <a:spcAft>
+                <a:spcPts val="0"/>
+              </a:spcAft>
+              <a:buSzPts val="1018"/>
+              <a:buNone/>
+            </a:pPr>
+            <a:endParaRPr dirty="0">
+              <a:solidFill>
+                <a:schemeClr val="dk2"/>
+              </a:solidFill>
+            </a:endParaRPr>
+          </a:p>
+        </p:txBody>
+      </p:sp>
+      <p:pic>
+        <p:nvPicPr>
+          <p:cNvPr id="83" name="Google Shape;83;p2"/>
+          <p:cNvPicPr preferRelativeResize="0"/>
+          <p:nvPr/>
+        </p:nvPicPr>
+        <p:blipFill rotWithShape="1">
+          <a:blip r:embed="rId3">
+            <a:alphaModFix/>
+          </a:blip>
+          <a:srcRect/>
+          <a:stretch/>
+        </p:blipFill>
+        <p:spPr>
+          <a:xfrm>
+            <a:off x="8130475" y="4138900"/>
+            <a:ext cx="790275" cy="790275"/>
+          </a:xfrm>
+          <a:prstGeom prst="rect">
+            <a:avLst/>
+          </a:prstGeom>
+          <a:noFill/>
+          <a:ln>
+            <a:noFill/>
+          </a:ln>
+        </p:spPr>
+      </p:pic>
+      <p:sp>
+        <p:nvSpPr>
+          <p:cNvPr id="84" name="Google Shape;84;p2"/>
+          <p:cNvSpPr txBox="1">
+            <a:spLocks noGrp="1"/>
+          </p:cNvSpPr>
+          <p:nvPr>
+            <p:ph type="body" idx="1"/>
+          </p:nvPr>
+        </p:nvSpPr>
+        <p:spPr>
+          <a:xfrm>
+            <a:off x="4572000" y="2712242"/>
+            <a:ext cx="4302000" cy="2348067"/>
+          </a:xfrm>
+          <a:prstGeom prst="rect">
+            <a:avLst/>
+          </a:prstGeom>
+          <a:noFill/>
+          <a:ln>
+            <a:noFill/>
+          </a:ln>
+        </p:spPr>
+        <p:txBody>
+          <a:bodyPr spcFirstLastPara="1" wrap="square" lIns="91425" tIns="91425" rIns="91425" bIns="91425" anchor="t" anchorCtr="0">
+            <a:normAutofit/>
+          </a:bodyPr>
+          <a:lstStyle/>
+          <a:p>
+            <a:pPr marL="0" lvl="0" indent="0" algn="l" rtl="0">
+              <a:lnSpc>
+                <a:spcPct val="115000"/>
+              </a:lnSpc>
+              <a:spcBef>
+                <a:spcPts val="0"/>
+              </a:spcBef>
+              <a:spcAft>
+                <a:spcPts val="0"/>
+              </a:spcAft>
+              <a:buSzPts val="1800"/>
+              <a:buNone/>
+            </a:pPr>
+            <a:r>
+              <a:rPr lang="en" dirty="0">
+                <a:solidFill>
+                  <a:schemeClr val="dk2"/>
+                </a:solidFill>
+              </a:rPr>
+              <a:t>. Embeddings</a:t>
+            </a:r>
+          </a:p>
+          <a:p>
+            <a:pPr marL="0" lvl="0" indent="0" algn="l" rtl="0">
+              <a:lnSpc>
+                <a:spcPct val="115000"/>
+              </a:lnSpc>
+              <a:spcBef>
+                <a:spcPts val="0"/>
+              </a:spcBef>
+              <a:spcAft>
+                <a:spcPts val="0"/>
+              </a:spcAft>
+              <a:buSzPts val="1800"/>
+              <a:buNone/>
+            </a:pPr>
+            <a:endParaRPr lang="en" dirty="0">
+              <a:solidFill>
+                <a:schemeClr val="dk2"/>
+              </a:solidFill>
+            </a:endParaRPr>
+          </a:p>
+          <a:p>
+            <a:pPr marL="0" lvl="0" indent="0" algn="l" rtl="0">
+              <a:lnSpc>
+                <a:spcPct val="115000"/>
+              </a:lnSpc>
+              <a:spcBef>
+                <a:spcPts val="0"/>
+              </a:spcBef>
+              <a:spcAft>
+                <a:spcPts val="0"/>
+              </a:spcAft>
+              <a:buSzPts val="1800"/>
+              <a:buNone/>
+            </a:pPr>
+            <a:r>
+              <a:rPr lang="es-ES" dirty="0" err="1">
+                <a:solidFill>
+                  <a:schemeClr val="dk2"/>
+                </a:solidFill>
+              </a:rPr>
+              <a:t>Embeddings</a:t>
+            </a:r>
+            <a:r>
+              <a:rPr lang="es-ES" dirty="0">
+                <a:solidFill>
+                  <a:schemeClr val="dk2"/>
+                </a:solidFill>
+              </a:rPr>
+              <a:t> vs </a:t>
+            </a:r>
+            <a:r>
+              <a:rPr lang="es-ES" dirty="0" err="1">
+                <a:solidFill>
+                  <a:schemeClr val="dk2"/>
+                </a:solidFill>
+              </a:rPr>
+              <a:t>one-hot.encoding</a:t>
+            </a:r>
+            <a:endParaRPr lang="es-ES" dirty="0">
+              <a:solidFill>
+                <a:schemeClr val="dk2"/>
+              </a:solidFill>
+            </a:endParaRPr>
+          </a:p>
+          <a:p>
+            <a:pPr marL="0" lvl="0" indent="0" algn="l" rtl="0">
+              <a:lnSpc>
+                <a:spcPct val="115000"/>
+              </a:lnSpc>
+              <a:spcBef>
+                <a:spcPts val="0"/>
+              </a:spcBef>
+              <a:spcAft>
+                <a:spcPts val="0"/>
+              </a:spcAft>
+              <a:buSzPts val="1800"/>
+              <a:buNone/>
+            </a:pPr>
+            <a:endParaRPr lang="es-ES" dirty="0">
+              <a:solidFill>
+                <a:schemeClr val="dk2"/>
+              </a:solidFill>
+            </a:endParaRPr>
+          </a:p>
+          <a:p>
+            <a:pPr marL="0" lvl="0" indent="0" algn="l" rtl="0">
+              <a:lnSpc>
+                <a:spcPct val="115000"/>
+              </a:lnSpc>
+              <a:spcBef>
+                <a:spcPts val="0"/>
+              </a:spcBef>
+              <a:spcAft>
+                <a:spcPts val="0"/>
+              </a:spcAft>
+              <a:buSzPts val="1800"/>
+              <a:buNone/>
+            </a:pPr>
+            <a:r>
+              <a:rPr lang="es-ES" dirty="0">
+                <a:solidFill>
+                  <a:schemeClr val="dk2"/>
+                </a:solidFill>
+              </a:rPr>
+              <a:t>F</a:t>
+            </a:r>
+            <a:r>
+              <a:rPr lang="en" dirty="0">
+                <a:solidFill>
+                  <a:schemeClr val="dk2"/>
+                </a:solidFill>
+              </a:rPr>
+              <a:t>alse task training</a:t>
+            </a:r>
+            <a:endParaRPr dirty="0">
+              <a:solidFill>
+                <a:schemeClr val="dk2"/>
+              </a:solidFill>
+            </a:endParaRPr>
+          </a:p>
+        </p:txBody>
+      </p:sp>
+      <p:sp>
+        <p:nvSpPr>
+          <p:cNvPr id="3" name="CuadroTexto 2">
+            <a:extLst>
+              <a:ext uri="{FF2B5EF4-FFF2-40B4-BE49-F238E27FC236}">
+                <a16:creationId xmlns:a16="http://schemas.microsoft.com/office/drawing/2014/main" id="{584D6A6C-4882-7422-E750-B3F7E8634DD0}"/>
+              </a:ext>
+            </a:extLst>
+          </p:cNvPr>
+          <p:cNvSpPr txBox="1"/>
+          <p:nvPr/>
+        </p:nvSpPr>
+        <p:spPr>
+          <a:xfrm>
+            <a:off x="2732887" y="1983377"/>
+            <a:ext cx="3104147" cy="383823"/>
+          </a:xfrm>
+          <a:prstGeom prst="rect">
+            <a:avLst/>
+          </a:prstGeom>
+          <a:noFill/>
+        </p:spPr>
+        <p:txBody>
+          <a:bodyPr wrap="square">
+            <a:spAutoFit/>
+          </a:bodyPr>
+          <a:lstStyle/>
+          <a:p>
+            <a:pPr marL="0" lvl="0" indent="0" algn="l" rtl="0">
+              <a:lnSpc>
+                <a:spcPct val="115000"/>
+              </a:lnSpc>
+              <a:spcBef>
+                <a:spcPts val="0"/>
+              </a:spcBef>
+              <a:spcAft>
+                <a:spcPts val="0"/>
+              </a:spcAft>
+              <a:buSzPts val="1800"/>
+              <a:buNone/>
+            </a:pPr>
+            <a:r>
+              <a:rPr lang="en" sz="1800" dirty="0">
+                <a:solidFill>
+                  <a:schemeClr val="dk2"/>
+                </a:solidFill>
+              </a:rPr>
+              <a:t>Representation learning </a:t>
+            </a:r>
+          </a:p>
+        </p:txBody>
+      </p:sp>
+    </p:spTree>
+  </p:cSld>
+  <p:clrMapOvr>
+    <a:masterClrMapping/>
+  </p:clrMapOvr>
+</p:sld>
+</file>
+
+<file path=ppt/slides/slide20.xml><?xml version="1.0" encoding="utf-8"?>
 <p:sld xmlns:a="http://schemas.openxmlformats.org/drawingml/2006/main" xmlns:r="http://schemas.openxmlformats.org/officeDocument/2006/relationships" xmlns:p="http://schemas.openxmlformats.org/presentationml/2006/main">
   <p:cSld>
     <p:spTree>
@@ -16721,7 +19818,7 @@
 </p:sld>
 </file>
 
-<file path=ppt/slides/slide18.xml><?xml version="1.0" encoding="utf-8"?>
+<file path=ppt/slides/slide21.xml><?xml version="1.0" encoding="utf-8"?>
 <p:sld xmlns:a="http://schemas.openxmlformats.org/drawingml/2006/main" xmlns:r="http://schemas.openxmlformats.org/officeDocument/2006/relationships" xmlns:p="http://schemas.openxmlformats.org/presentationml/2006/main">
   <p:cSld>
     <p:spTree>
@@ -17276,7 +20373,7 @@
 </p:sld>
 </file>
 
-<file path=ppt/slides/slide19.xml><?xml version="1.0" encoding="utf-8"?>
+<file path=ppt/slides/slide22.xml><?xml version="1.0" encoding="utf-8"?>
 <p:sld xmlns:a="http://schemas.openxmlformats.org/drawingml/2006/main" xmlns:r="http://schemas.openxmlformats.org/officeDocument/2006/relationships" xmlns:p="http://schemas.openxmlformats.org/presentationml/2006/main">
   <p:cSld>
     <p:spTree>
@@ -18296,580 +21393,7 @@
 </p:sld>
 </file>
 
-<file path=ppt/slides/slide2.xml><?xml version="1.0" encoding="utf-8"?>
-<p:sld xmlns:a="http://schemas.openxmlformats.org/drawingml/2006/main" xmlns:r="http://schemas.openxmlformats.org/officeDocument/2006/relationships" xmlns:p="http://schemas.openxmlformats.org/presentationml/2006/main">
-  <p:cSld>
-    <p:spTree>
-      <p:nvGrpSpPr>
-        <p:cNvPr id="1" name="Shape 80"/>
-        <p:cNvGrpSpPr/>
-        <p:nvPr/>
-      </p:nvGrpSpPr>
-      <p:grpSpPr>
-        <a:xfrm>
-          <a:off x="0" y="0"/>
-          <a:ext cx="0" cy="0"/>
-          <a:chOff x="0" y="0"/>
-          <a:chExt cx="0" cy="0"/>
-        </a:xfrm>
-      </p:grpSpPr>
-      <p:sp>
-        <p:nvSpPr>
-          <p:cNvPr id="81" name="Google Shape;81;p2"/>
-          <p:cNvSpPr txBox="1">
-            <a:spLocks noGrp="1"/>
-          </p:cNvSpPr>
-          <p:nvPr>
-            <p:ph type="title"/>
-          </p:nvPr>
-        </p:nvSpPr>
-        <p:spPr>
-          <a:xfrm>
-            <a:off x="460950" y="303000"/>
-            <a:ext cx="8222100" cy="937500"/>
-          </a:xfrm>
-          <a:prstGeom prst="rect">
-            <a:avLst/>
-          </a:prstGeom>
-          <a:noFill/>
-          <a:ln>
-            <a:noFill/>
-          </a:ln>
-        </p:spPr>
-        <p:txBody>
-          <a:bodyPr spcFirstLastPara="1" wrap="square" lIns="91425" tIns="91425" rIns="91425" bIns="91425" anchor="b" anchorCtr="0">
-            <a:noAutofit/>
-          </a:bodyPr>
-          <a:lstStyle/>
-          <a:p>
-            <a:pPr marL="0" lvl="0" indent="0" algn="ctr" rtl="0">
-              <a:lnSpc>
-                <a:spcPct val="120000"/>
-              </a:lnSpc>
-              <a:spcBef>
-                <a:spcPts val="800"/>
-              </a:spcBef>
-              <a:spcAft>
-                <a:spcPts val="0"/>
-              </a:spcAft>
-              <a:buClr>
-                <a:schemeClr val="dk1"/>
-              </a:buClr>
-              <a:buSzPts val="2600"/>
-              <a:buFont typeface="Arial"/>
-              <a:buNone/>
-            </a:pPr>
-            <a:r>
-              <a:rPr lang="en" sz="2100" dirty="0"/>
-              <a:t>REPRESENTATION LEARNING </a:t>
-            </a:r>
-            <a:br>
-              <a:rPr lang="en" sz="2100" dirty="0"/>
-            </a:br>
-            <a:r>
-              <a:rPr lang="en" sz="2100" dirty="0"/>
-              <a:t>AUTOENCODER / EMBEDDINGS</a:t>
-            </a:r>
-            <a:endParaRPr sz="2818" dirty="0">
-              <a:latin typeface="Arial"/>
-              <a:ea typeface="Arial"/>
-              <a:cs typeface="Arial"/>
-              <a:sym typeface="Arial"/>
-            </a:endParaRPr>
-          </a:p>
-        </p:txBody>
-      </p:sp>
-      <p:sp>
-        <p:nvSpPr>
-          <p:cNvPr id="82" name="Google Shape;82;p2"/>
-          <p:cNvSpPr txBox="1">
-            <a:spLocks noGrp="1"/>
-          </p:cNvSpPr>
-          <p:nvPr>
-            <p:ph type="body" idx="1"/>
-          </p:nvPr>
-        </p:nvSpPr>
-        <p:spPr>
-          <a:xfrm>
-            <a:off x="403148" y="2776300"/>
-            <a:ext cx="3598950" cy="2152875"/>
-          </a:xfrm>
-          <a:prstGeom prst="rect">
-            <a:avLst/>
-          </a:prstGeom>
-          <a:noFill/>
-          <a:ln>
-            <a:noFill/>
-          </a:ln>
-        </p:spPr>
-        <p:txBody>
-          <a:bodyPr spcFirstLastPara="1" wrap="square" lIns="91425" tIns="91425" rIns="91425" bIns="91425" anchor="t" anchorCtr="0">
-            <a:noAutofit/>
-          </a:bodyPr>
-          <a:lstStyle/>
-          <a:p>
-            <a:pPr marL="0" lvl="0" indent="0" algn="l" rtl="0">
-              <a:lnSpc>
-                <a:spcPct val="95000"/>
-              </a:lnSpc>
-              <a:spcBef>
-                <a:spcPts val="0"/>
-              </a:spcBef>
-              <a:spcAft>
-                <a:spcPts val="0"/>
-              </a:spcAft>
-              <a:buSzPts val="1018"/>
-              <a:buNone/>
-            </a:pPr>
-            <a:r>
-              <a:rPr lang="en" dirty="0">
-                <a:solidFill>
-                  <a:schemeClr val="dk2"/>
-                </a:solidFill>
-              </a:rPr>
-              <a:t>. Autoencoders</a:t>
-            </a:r>
-          </a:p>
-          <a:p>
-            <a:pPr marL="0" lvl="0" indent="0" algn="l" rtl="0">
-              <a:lnSpc>
-                <a:spcPct val="95000"/>
-              </a:lnSpc>
-              <a:spcBef>
-                <a:spcPts val="0"/>
-              </a:spcBef>
-              <a:spcAft>
-                <a:spcPts val="0"/>
-              </a:spcAft>
-              <a:buSzPts val="1018"/>
-              <a:buNone/>
-            </a:pPr>
-            <a:endParaRPr lang="en" dirty="0">
-              <a:solidFill>
-                <a:schemeClr val="dk2"/>
-              </a:solidFill>
-            </a:endParaRPr>
-          </a:p>
-          <a:p>
-            <a:pPr marL="0" lvl="0" indent="0" algn="l" rtl="0">
-              <a:lnSpc>
-                <a:spcPct val="95000"/>
-              </a:lnSpc>
-              <a:spcBef>
-                <a:spcPts val="0"/>
-              </a:spcBef>
-              <a:spcAft>
-                <a:spcPts val="0"/>
-              </a:spcAft>
-              <a:buSzPts val="1018"/>
-              <a:buNone/>
-            </a:pPr>
-            <a:r>
-              <a:rPr lang="es-AR" dirty="0">
-                <a:solidFill>
-                  <a:schemeClr val="dk2"/>
-                </a:solidFill>
-              </a:rPr>
-              <a:t>U</a:t>
-            </a:r>
-            <a:r>
-              <a:rPr lang="en" dirty="0">
-                <a:solidFill>
-                  <a:schemeClr val="dk2"/>
-                </a:solidFill>
-              </a:rPr>
-              <a:t>ndercomplete vs regularized AE</a:t>
-            </a:r>
-          </a:p>
-          <a:p>
-            <a:pPr marL="0" lvl="0" indent="0" algn="l" rtl="0">
-              <a:lnSpc>
-                <a:spcPct val="95000"/>
-              </a:lnSpc>
-              <a:spcBef>
-                <a:spcPts val="0"/>
-              </a:spcBef>
-              <a:spcAft>
-                <a:spcPts val="0"/>
-              </a:spcAft>
-              <a:buSzPts val="1018"/>
-              <a:buNone/>
-            </a:pPr>
-            <a:endParaRPr lang="en" dirty="0">
-              <a:solidFill>
-                <a:schemeClr val="dk2"/>
-              </a:solidFill>
-            </a:endParaRPr>
-          </a:p>
-          <a:p>
-            <a:pPr marL="0" lvl="0" indent="0" algn="l" rtl="0">
-              <a:lnSpc>
-                <a:spcPct val="95000"/>
-              </a:lnSpc>
-              <a:spcBef>
-                <a:spcPts val="0"/>
-              </a:spcBef>
-              <a:spcAft>
-                <a:spcPts val="0"/>
-              </a:spcAft>
-              <a:buSzPts val="1018"/>
-              <a:buNone/>
-            </a:pPr>
-            <a:r>
-              <a:rPr lang="en" dirty="0">
-                <a:solidFill>
-                  <a:schemeClr val="dk2"/>
-                </a:solidFill>
-              </a:rPr>
-              <a:t>Manifold learning</a:t>
-            </a:r>
-          </a:p>
-          <a:p>
-            <a:pPr marL="0" lvl="0" indent="0" algn="l" rtl="0">
-              <a:lnSpc>
-                <a:spcPct val="95000"/>
-              </a:lnSpc>
-              <a:spcBef>
-                <a:spcPts val="0"/>
-              </a:spcBef>
-              <a:spcAft>
-                <a:spcPts val="0"/>
-              </a:spcAft>
-              <a:buSzPts val="1018"/>
-              <a:buNone/>
-            </a:pPr>
-            <a:endParaRPr lang="en" dirty="0">
-              <a:solidFill>
-                <a:schemeClr val="dk2"/>
-              </a:solidFill>
-            </a:endParaRPr>
-          </a:p>
-          <a:p>
-            <a:pPr marL="0" lvl="0" indent="0" algn="l" rtl="0">
-              <a:lnSpc>
-                <a:spcPct val="95000"/>
-              </a:lnSpc>
-              <a:spcBef>
-                <a:spcPts val="0"/>
-              </a:spcBef>
-              <a:spcAft>
-                <a:spcPts val="0"/>
-              </a:spcAft>
-              <a:buSzPts val="1018"/>
-              <a:buNone/>
-            </a:pPr>
-            <a:r>
-              <a:rPr lang="en" dirty="0">
-                <a:solidFill>
-                  <a:schemeClr val="dk2"/>
-                </a:solidFill>
-              </a:rPr>
-              <a:t>Varational AE</a:t>
-            </a:r>
-          </a:p>
-          <a:p>
-            <a:pPr marL="0" lvl="0" indent="0" algn="l" rtl="0">
-              <a:lnSpc>
-                <a:spcPct val="95000"/>
-              </a:lnSpc>
-              <a:spcBef>
-                <a:spcPts val="0"/>
-              </a:spcBef>
-              <a:spcAft>
-                <a:spcPts val="0"/>
-              </a:spcAft>
-              <a:buSzPts val="1018"/>
-              <a:buNone/>
-            </a:pPr>
-            <a:endParaRPr lang="en" dirty="0">
-              <a:solidFill>
-                <a:schemeClr val="dk2"/>
-              </a:solidFill>
-            </a:endParaRPr>
-          </a:p>
-          <a:p>
-            <a:pPr marL="0" lvl="0" indent="0" algn="l" rtl="0">
-              <a:lnSpc>
-                <a:spcPct val="95000"/>
-              </a:lnSpc>
-              <a:spcBef>
-                <a:spcPts val="1200"/>
-              </a:spcBef>
-              <a:spcAft>
-                <a:spcPts val="0"/>
-              </a:spcAft>
-              <a:buSzPts val="1018"/>
-              <a:buNone/>
-            </a:pPr>
-            <a:endParaRPr dirty="0">
-              <a:solidFill>
-                <a:schemeClr val="dk2"/>
-              </a:solidFill>
-            </a:endParaRPr>
-          </a:p>
-        </p:txBody>
-      </p:sp>
-      <p:pic>
-        <p:nvPicPr>
-          <p:cNvPr id="83" name="Google Shape;83;p2"/>
-          <p:cNvPicPr preferRelativeResize="0"/>
-          <p:nvPr/>
-        </p:nvPicPr>
-        <p:blipFill rotWithShape="1">
-          <a:blip r:embed="rId3">
-            <a:alphaModFix/>
-          </a:blip>
-          <a:srcRect/>
-          <a:stretch/>
-        </p:blipFill>
-        <p:spPr>
-          <a:xfrm>
-            <a:off x="8130475" y="4138900"/>
-            <a:ext cx="790275" cy="790275"/>
-          </a:xfrm>
-          <a:prstGeom prst="rect">
-            <a:avLst/>
-          </a:prstGeom>
-          <a:noFill/>
-          <a:ln>
-            <a:noFill/>
-          </a:ln>
-        </p:spPr>
-      </p:pic>
-      <p:sp>
-        <p:nvSpPr>
-          <p:cNvPr id="84" name="Google Shape;84;p2"/>
-          <p:cNvSpPr txBox="1">
-            <a:spLocks noGrp="1"/>
-          </p:cNvSpPr>
-          <p:nvPr>
-            <p:ph type="body" idx="1"/>
-          </p:nvPr>
-        </p:nvSpPr>
-        <p:spPr>
-          <a:xfrm>
-            <a:off x="4572000" y="2712242"/>
-            <a:ext cx="4302000" cy="2348067"/>
-          </a:xfrm>
-          <a:prstGeom prst="rect">
-            <a:avLst/>
-          </a:prstGeom>
-          <a:noFill/>
-          <a:ln>
-            <a:noFill/>
-          </a:ln>
-        </p:spPr>
-        <p:txBody>
-          <a:bodyPr spcFirstLastPara="1" wrap="square" lIns="91425" tIns="91425" rIns="91425" bIns="91425" anchor="t" anchorCtr="0">
-            <a:normAutofit/>
-          </a:bodyPr>
-          <a:lstStyle/>
-          <a:p>
-            <a:pPr marL="0" lvl="0" indent="0" algn="l" rtl="0">
-              <a:lnSpc>
-                <a:spcPct val="115000"/>
-              </a:lnSpc>
-              <a:spcBef>
-                <a:spcPts val="0"/>
-              </a:spcBef>
-              <a:spcAft>
-                <a:spcPts val="0"/>
-              </a:spcAft>
-              <a:buSzPts val="1800"/>
-              <a:buNone/>
-            </a:pPr>
-            <a:r>
-              <a:rPr lang="en" dirty="0">
-                <a:solidFill>
-                  <a:schemeClr val="dk2"/>
-                </a:solidFill>
-              </a:rPr>
-              <a:t>. Embeddings</a:t>
-            </a:r>
-          </a:p>
-          <a:p>
-            <a:pPr marL="0" lvl="0" indent="0" algn="l" rtl="0">
-              <a:lnSpc>
-                <a:spcPct val="115000"/>
-              </a:lnSpc>
-              <a:spcBef>
-                <a:spcPts val="0"/>
-              </a:spcBef>
-              <a:spcAft>
-                <a:spcPts val="0"/>
-              </a:spcAft>
-              <a:buSzPts val="1800"/>
-              <a:buNone/>
-            </a:pPr>
-            <a:endParaRPr lang="en" dirty="0">
-              <a:solidFill>
-                <a:schemeClr val="dk2"/>
-              </a:solidFill>
-            </a:endParaRPr>
-          </a:p>
-          <a:p>
-            <a:pPr marL="0" lvl="0" indent="0" algn="l" rtl="0">
-              <a:lnSpc>
-                <a:spcPct val="115000"/>
-              </a:lnSpc>
-              <a:spcBef>
-                <a:spcPts val="0"/>
-              </a:spcBef>
-              <a:spcAft>
-                <a:spcPts val="0"/>
-              </a:spcAft>
-              <a:buSzPts val="1800"/>
-              <a:buNone/>
-            </a:pPr>
-            <a:r>
-              <a:rPr lang="es-ES" dirty="0" err="1">
-                <a:solidFill>
-                  <a:schemeClr val="dk2"/>
-                </a:solidFill>
-              </a:rPr>
-              <a:t>Embeddings</a:t>
-            </a:r>
-            <a:r>
-              <a:rPr lang="es-ES" dirty="0">
-                <a:solidFill>
-                  <a:schemeClr val="dk2"/>
-                </a:solidFill>
-              </a:rPr>
-              <a:t> vs </a:t>
-            </a:r>
-            <a:r>
-              <a:rPr lang="es-ES" dirty="0" err="1">
-                <a:solidFill>
-                  <a:schemeClr val="dk2"/>
-                </a:solidFill>
-              </a:rPr>
-              <a:t>one-hot.encoding</a:t>
-            </a:r>
-            <a:endParaRPr lang="es-ES" dirty="0">
-              <a:solidFill>
-                <a:schemeClr val="dk2"/>
-              </a:solidFill>
-            </a:endParaRPr>
-          </a:p>
-          <a:p>
-            <a:pPr marL="0" lvl="0" indent="0" algn="l" rtl="0">
-              <a:lnSpc>
-                <a:spcPct val="115000"/>
-              </a:lnSpc>
-              <a:spcBef>
-                <a:spcPts val="0"/>
-              </a:spcBef>
-              <a:spcAft>
-                <a:spcPts val="0"/>
-              </a:spcAft>
-              <a:buSzPts val="1800"/>
-              <a:buNone/>
-            </a:pPr>
-            <a:endParaRPr lang="es-ES" dirty="0">
-              <a:solidFill>
-                <a:schemeClr val="dk2"/>
-              </a:solidFill>
-            </a:endParaRPr>
-          </a:p>
-          <a:p>
-            <a:pPr marL="0" lvl="0" indent="0" algn="l" rtl="0">
-              <a:lnSpc>
-                <a:spcPct val="115000"/>
-              </a:lnSpc>
-              <a:spcBef>
-                <a:spcPts val="0"/>
-              </a:spcBef>
-              <a:spcAft>
-                <a:spcPts val="0"/>
-              </a:spcAft>
-              <a:buSzPts val="1800"/>
-              <a:buNone/>
-            </a:pPr>
-            <a:r>
-              <a:rPr lang="es-ES" dirty="0">
-                <a:solidFill>
-                  <a:schemeClr val="dk2"/>
-                </a:solidFill>
-              </a:rPr>
-              <a:t>F</a:t>
-            </a:r>
-            <a:r>
-              <a:rPr lang="en" dirty="0">
-                <a:solidFill>
-                  <a:schemeClr val="dk2"/>
-                </a:solidFill>
-              </a:rPr>
-              <a:t>alse task training</a:t>
-            </a:r>
-            <a:endParaRPr dirty="0">
-              <a:solidFill>
-                <a:schemeClr val="dk2"/>
-              </a:solidFill>
-            </a:endParaRPr>
-          </a:p>
-        </p:txBody>
-      </p:sp>
-      <p:sp>
-        <p:nvSpPr>
-          <p:cNvPr id="3" name="CuadroTexto 2">
-            <a:extLst>
-              <a:ext uri="{FF2B5EF4-FFF2-40B4-BE49-F238E27FC236}">
-                <a16:creationId xmlns:a16="http://schemas.microsoft.com/office/drawing/2014/main" id="{584D6A6C-4882-7422-E750-B3F7E8634DD0}"/>
-              </a:ext>
-            </a:extLst>
-          </p:cNvPr>
-          <p:cNvSpPr txBox="1"/>
-          <p:nvPr/>
-        </p:nvSpPr>
-        <p:spPr>
-          <a:xfrm>
-            <a:off x="2732887" y="1983377"/>
-            <a:ext cx="3104147" cy="383823"/>
-          </a:xfrm>
-          <a:prstGeom prst="rect">
-            <a:avLst/>
-          </a:prstGeom>
-          <a:noFill/>
-        </p:spPr>
-        <p:txBody>
-          <a:bodyPr wrap="square">
-            <a:spAutoFit/>
-          </a:bodyPr>
-          <a:lstStyle/>
-          <a:p>
-            <a:pPr marL="0" lvl="0" indent="0" algn="l" rtl="0">
-              <a:lnSpc>
-                <a:spcPct val="115000"/>
-              </a:lnSpc>
-              <a:spcBef>
-                <a:spcPts val="0"/>
-              </a:spcBef>
-              <a:spcAft>
-                <a:spcPts val="0"/>
-              </a:spcAft>
-              <a:buSzPts val="1800"/>
-              <a:buNone/>
-            </a:pPr>
-            <a:r>
-              <a:rPr lang="en" sz="1800" dirty="0">
-                <a:solidFill>
-                  <a:schemeClr val="dk2"/>
-                </a:solidFill>
-              </a:rPr>
-              <a:t>Representation learning </a:t>
-            </a:r>
-          </a:p>
-        </p:txBody>
-      </p:sp>
-    </p:spTree>
-  </p:cSld>
-  <p:clrMapOvr>
-    <a:masterClrMapping/>
-  </p:clrMapOvr>
-</p:sld>
-</file>
-
-<file path=ppt/slides/slide20.xml><?xml version="1.0" encoding="utf-8"?>
+<file path=ppt/slides/slide23.xml><?xml version="1.0" encoding="utf-8"?>
 <p:sld xmlns:a="http://schemas.openxmlformats.org/drawingml/2006/main" xmlns:r="http://schemas.openxmlformats.org/officeDocument/2006/relationships" xmlns:p="http://schemas.openxmlformats.org/presentationml/2006/main">
   <p:cSld>
     <p:spTree>
@@ -19373,7 +21897,7 @@
 </p:sld>
 </file>
 
-<file path=ppt/slides/slide21.xml><?xml version="1.0" encoding="utf-8"?>
+<file path=ppt/slides/slide24.xml><?xml version="1.0" encoding="utf-8"?>
 <p:sld xmlns:a="http://schemas.openxmlformats.org/drawingml/2006/main" xmlns:r="http://schemas.openxmlformats.org/officeDocument/2006/relationships" xmlns:p="http://schemas.openxmlformats.org/presentationml/2006/main">
   <p:cSld>
     <p:spTree>
@@ -19884,7 +22408,7 @@
 </p:sld>
 </file>
 
-<file path=ppt/slides/slide22.xml><?xml version="1.0" encoding="utf-8"?>
+<file path=ppt/slides/slide25.xml><?xml version="1.0" encoding="utf-8"?>
 <p:sld xmlns:a="http://schemas.openxmlformats.org/drawingml/2006/main" xmlns:r="http://schemas.openxmlformats.org/officeDocument/2006/relationships" xmlns:p="http://schemas.openxmlformats.org/presentationml/2006/main">
   <p:cSld>
     <p:spTree>
@@ -20571,7 +23095,7 @@
 </p:sld>
 </file>
 
-<file path=ppt/slides/slide23.xml><?xml version="1.0" encoding="utf-8"?>
+<file path=ppt/slides/slide26.xml><?xml version="1.0" encoding="utf-8"?>
 <p:sld xmlns:a="http://schemas.openxmlformats.org/drawingml/2006/main" xmlns:r="http://schemas.openxmlformats.org/officeDocument/2006/relationships" xmlns:p="http://schemas.openxmlformats.org/presentationml/2006/main">
   <p:cSld>
     <p:spTree>
@@ -21617,7 +24141,7 @@
 </p:sld>
 </file>
 
-<file path=ppt/slides/slide24.xml><?xml version="1.0" encoding="utf-8"?>
+<file path=ppt/slides/slide27.xml><?xml version="1.0" encoding="utf-8"?>
 <p:sld xmlns:a="http://schemas.openxmlformats.org/drawingml/2006/main" xmlns:r="http://schemas.openxmlformats.org/officeDocument/2006/relationships" xmlns:p="http://schemas.openxmlformats.org/presentationml/2006/main">
   <p:cSld>
     <p:spTree>
@@ -21852,7 +24376,7 @@
 </p:sld>
 </file>
 
-<file path=ppt/slides/slide25.xml><?xml version="1.0" encoding="utf-8"?>
+<file path=ppt/slides/slide28.xml><?xml version="1.0" encoding="utf-8"?>
 <p:sld xmlns:a="http://schemas.openxmlformats.org/drawingml/2006/main" xmlns:r="http://schemas.openxmlformats.org/officeDocument/2006/relationships" xmlns:p="http://schemas.openxmlformats.org/presentationml/2006/main">
   <p:cSld>
     <p:spTree>
@@ -22174,7 +24698,7 @@
 </p:sld>
 </file>
 
-<file path=ppt/slides/slide26.xml><?xml version="1.0" encoding="utf-8"?>
+<file path=ppt/slides/slide29.xml><?xml version="1.0" encoding="utf-8"?>
 <p:sld xmlns:a="http://schemas.openxmlformats.org/drawingml/2006/main" xmlns:r="http://schemas.openxmlformats.org/officeDocument/2006/relationships" xmlns:p="http://schemas.openxmlformats.org/presentationml/2006/main">
   <p:cSld>
     <p:spTree>
@@ -22513,245 +25037,6 @@
 </p:sld>
 </file>
 
-<file path=ppt/slides/slide27.xml><?xml version="1.0" encoding="utf-8"?>
-<p:sld xmlns:a="http://schemas.openxmlformats.org/drawingml/2006/main" xmlns:r="http://schemas.openxmlformats.org/officeDocument/2006/relationships" xmlns:p="http://schemas.openxmlformats.org/presentationml/2006/main">
-  <p:cSld>
-    <p:spTree>
-      <p:nvGrpSpPr>
-        <p:cNvPr id="1" name="Shape 293"/>
-        <p:cNvGrpSpPr/>
-        <p:nvPr/>
-      </p:nvGrpSpPr>
-      <p:grpSpPr>
-        <a:xfrm>
-          <a:off x="0" y="0"/>
-          <a:ext cx="0" cy="0"/>
-          <a:chOff x="0" y="0"/>
-          <a:chExt cx="0" cy="0"/>
-        </a:xfrm>
-      </p:grpSpPr>
-      <p:sp>
-        <p:nvSpPr>
-          <p:cNvPr id="294" name="Google Shape;294;g2f19d644e1e_1_184"/>
-          <p:cNvSpPr txBox="1"/>
-          <p:nvPr/>
-        </p:nvSpPr>
-        <p:spPr>
-          <a:xfrm>
-            <a:off x="-119743" y="0"/>
-            <a:ext cx="9383486" cy="814403"/>
-          </a:xfrm>
-          <a:prstGeom prst="rect">
-            <a:avLst/>
-          </a:prstGeom>
-          <a:noFill/>
-          <a:ln>
-            <a:noFill/>
-          </a:ln>
-        </p:spPr>
-        <p:txBody>
-          <a:bodyPr spcFirstLastPara="1" wrap="square" lIns="68575" tIns="34275" rIns="68575" bIns="34275" anchor="t" anchorCtr="0">
-            <a:noAutofit/>
-          </a:bodyPr>
-          <a:lstStyle/>
-          <a:p>
-            <a:pPr marL="0" marR="0" lvl="0" indent="0" algn="ctr" rtl="0">
-              <a:lnSpc>
-                <a:spcPct val="120000"/>
-              </a:lnSpc>
-              <a:spcBef>
-                <a:spcPts val="0"/>
-              </a:spcBef>
-              <a:spcAft>
-                <a:spcPts val="0"/>
-              </a:spcAft>
-              <a:buClr>
-                <a:schemeClr val="dk1"/>
-              </a:buClr>
-              <a:buSzPts val="3000"/>
-              <a:buFont typeface="Arial"/>
-              <a:buNone/>
-            </a:pPr>
-            <a:r>
-              <a:rPr lang="en" sz="2400" dirty="0">
-                <a:solidFill>
-                  <a:schemeClr val="dk2"/>
-                </a:solidFill>
-                <a:latin typeface="Twentieth Century"/>
-                <a:ea typeface="Twentieth Century"/>
-                <a:cs typeface="Twentieth Century"/>
-                <a:sym typeface="Twentieth Century"/>
-              </a:rPr>
-              <a:t>embeddings</a:t>
-            </a:r>
-            <a:endParaRPr sz="2400" dirty="0">
-              <a:solidFill>
-                <a:schemeClr val="dk2"/>
-              </a:solidFill>
-              <a:latin typeface="Twentieth Century"/>
-              <a:ea typeface="Twentieth Century"/>
-              <a:cs typeface="Twentieth Century"/>
-              <a:sym typeface="Twentieth Century"/>
-            </a:endParaRPr>
-          </a:p>
-        </p:txBody>
-      </p:sp>
-      <p:sp>
-        <p:nvSpPr>
-          <p:cNvPr id="295" name="Google Shape;295;g2f19d644e1e_1_184"/>
-          <p:cNvSpPr txBox="1"/>
-          <p:nvPr/>
-        </p:nvSpPr>
-        <p:spPr>
-          <a:xfrm>
-            <a:off x="173979" y="781835"/>
-            <a:ext cx="8641496" cy="814403"/>
-          </a:xfrm>
-          <a:prstGeom prst="rect">
-            <a:avLst/>
-          </a:prstGeom>
-          <a:noFill/>
-          <a:ln>
-            <a:noFill/>
-          </a:ln>
-        </p:spPr>
-        <p:txBody>
-          <a:bodyPr spcFirstLastPara="1" wrap="square" lIns="68575" tIns="34275" rIns="68575" bIns="34275" anchor="t" anchorCtr="0">
-            <a:noAutofit/>
-          </a:bodyPr>
-          <a:lstStyle/>
-          <a:p>
-            <a:pPr marL="0" marR="0" lvl="0" indent="0" algn="l" rtl="0">
-              <a:lnSpc>
-                <a:spcPct val="90000"/>
-              </a:lnSpc>
-              <a:spcBef>
-                <a:spcPts val="0"/>
-              </a:spcBef>
-              <a:spcAft>
-                <a:spcPts val="0"/>
-              </a:spcAft>
-              <a:buClr>
-                <a:schemeClr val="dk1"/>
-              </a:buClr>
-              <a:buSzPts val="2100"/>
-              <a:buFont typeface="Arial"/>
-              <a:buNone/>
-            </a:pPr>
-            <a:r>
-              <a:rPr lang="en" sz="2100" dirty="0">
-                <a:solidFill>
-                  <a:schemeClr val="dk2"/>
-                </a:solidFill>
-                <a:latin typeface="Twentieth Century"/>
-                <a:ea typeface="Twentieth Century"/>
-                <a:cs typeface="Twentieth Century"/>
-                <a:sym typeface="Twentieth Century"/>
-              </a:rPr>
-              <a:t>Embeddings </a:t>
-            </a:r>
-            <a:r>
-              <a:rPr lang="en" sz="2100" dirty="0">
-                <a:solidFill>
-                  <a:schemeClr val="dk2"/>
-                </a:solidFill>
-                <a:latin typeface="Twentieth Century"/>
-                <a:ea typeface="Twentieth Century"/>
-                <a:cs typeface="Twentieth Century"/>
-                <a:sym typeface="Wingdings" panose="05000000000000000000" pitchFamily="2" charset="2"/>
-              </a:rPr>
-              <a:t></a:t>
-            </a:r>
-            <a:r>
-              <a:rPr lang="en" sz="2100" dirty="0">
-                <a:solidFill>
-                  <a:schemeClr val="dk2"/>
-                </a:solidFill>
-                <a:latin typeface="Twentieth Century"/>
-                <a:ea typeface="Twentieth Century"/>
-                <a:cs typeface="Twentieth Century"/>
-                <a:sym typeface="Twentieth Century"/>
-              </a:rPr>
-              <a:t> no solo se aplica a palabras….</a:t>
-            </a:r>
-            <a:endParaRPr sz="2100" dirty="0">
-              <a:solidFill>
-                <a:schemeClr val="dk2"/>
-              </a:solidFill>
-              <a:latin typeface="Twentieth Century"/>
-              <a:ea typeface="Twentieth Century"/>
-              <a:cs typeface="Twentieth Century"/>
-              <a:sym typeface="Twentieth Century"/>
-            </a:endParaRPr>
-          </a:p>
-        </p:txBody>
-      </p:sp>
-      <p:sp>
-        <p:nvSpPr>
-          <p:cNvPr id="296" name="Google Shape;296;g2f19d644e1e_1_184"/>
-          <p:cNvSpPr/>
-          <p:nvPr/>
-        </p:nvSpPr>
-        <p:spPr>
-          <a:xfrm>
-            <a:off x="3661676" y="1939493"/>
-            <a:ext cx="1492235" cy="438581"/>
-          </a:xfrm>
-          <a:prstGeom prst="rect">
-            <a:avLst/>
-          </a:prstGeom>
-          <a:noFill/>
-          <a:ln>
-            <a:noFill/>
-          </a:ln>
-        </p:spPr>
-        <p:txBody>
-          <a:bodyPr spcFirstLastPara="1" wrap="square" lIns="68575" tIns="34275" rIns="68575" bIns="34275" anchor="t" anchorCtr="0">
-            <a:noAutofit/>
-          </a:bodyPr>
-          <a:lstStyle/>
-          <a:p>
-            <a:pPr marL="0" marR="0" lvl="0" indent="0" algn="l" rtl="0">
-              <a:spcBef>
-                <a:spcPts val="0"/>
-              </a:spcBef>
-              <a:spcAft>
-                <a:spcPts val="0"/>
-              </a:spcAft>
-              <a:buNone/>
-            </a:pPr>
-            <a:r>
-              <a:rPr lang="en" sz="2400">
-                <a:solidFill>
-                  <a:srgbClr val="FF0000"/>
-                </a:solidFill>
-                <a:latin typeface="Twentieth Century"/>
-                <a:ea typeface="Twentieth Century"/>
-                <a:cs typeface="Twentieth Century"/>
-                <a:sym typeface="Twentieth Century"/>
-              </a:rPr>
-              <a:t>ver colab</a:t>
-            </a:r>
-            <a:endParaRPr sz="2400">
-              <a:solidFill>
-                <a:srgbClr val="FF0000"/>
-              </a:solidFill>
-              <a:latin typeface="Twentieth Century"/>
-              <a:ea typeface="Twentieth Century"/>
-              <a:cs typeface="Twentieth Century"/>
-              <a:sym typeface="Twentieth Century"/>
-            </a:endParaRPr>
-          </a:p>
-        </p:txBody>
-      </p:sp>
-    </p:spTree>
-  </p:cSld>
-  <p:clrMapOvr>
-    <a:masterClrMapping/>
-  </p:clrMapOvr>
-</p:sld>
-</file>
-
 <file path=ppt/slides/slide3.xml><?xml version="1.0" encoding="utf-8"?>
 <p:sld xmlns:a="http://schemas.openxmlformats.org/drawingml/2006/main" xmlns:r="http://schemas.openxmlformats.org/officeDocument/2006/relationships" xmlns:p="http://schemas.openxmlformats.org/presentationml/2006/main">
   <p:cSld>
@@ -23103,6 +25388,245 @@
         <p14:creationId xmlns:p14="http://schemas.microsoft.com/office/powerpoint/2010/main" val="3698410795"/>
       </p:ext>
     </p:extLst>
+  </p:cSld>
+  <p:clrMapOvr>
+    <a:masterClrMapping/>
+  </p:clrMapOvr>
+</p:sld>
+</file>
+
+<file path=ppt/slides/slide30.xml><?xml version="1.0" encoding="utf-8"?>
+<p:sld xmlns:a="http://schemas.openxmlformats.org/drawingml/2006/main" xmlns:r="http://schemas.openxmlformats.org/officeDocument/2006/relationships" xmlns:p="http://schemas.openxmlformats.org/presentationml/2006/main">
+  <p:cSld>
+    <p:spTree>
+      <p:nvGrpSpPr>
+        <p:cNvPr id="1" name="Shape 293"/>
+        <p:cNvGrpSpPr/>
+        <p:nvPr/>
+      </p:nvGrpSpPr>
+      <p:grpSpPr>
+        <a:xfrm>
+          <a:off x="0" y="0"/>
+          <a:ext cx="0" cy="0"/>
+          <a:chOff x="0" y="0"/>
+          <a:chExt cx="0" cy="0"/>
+        </a:xfrm>
+      </p:grpSpPr>
+      <p:sp>
+        <p:nvSpPr>
+          <p:cNvPr id="294" name="Google Shape;294;g2f19d644e1e_1_184"/>
+          <p:cNvSpPr txBox="1"/>
+          <p:nvPr/>
+        </p:nvSpPr>
+        <p:spPr>
+          <a:xfrm>
+            <a:off x="-119743" y="0"/>
+            <a:ext cx="9383486" cy="814403"/>
+          </a:xfrm>
+          <a:prstGeom prst="rect">
+            <a:avLst/>
+          </a:prstGeom>
+          <a:noFill/>
+          <a:ln>
+            <a:noFill/>
+          </a:ln>
+        </p:spPr>
+        <p:txBody>
+          <a:bodyPr spcFirstLastPara="1" wrap="square" lIns="68575" tIns="34275" rIns="68575" bIns="34275" anchor="t" anchorCtr="0">
+            <a:noAutofit/>
+          </a:bodyPr>
+          <a:lstStyle/>
+          <a:p>
+            <a:pPr marL="0" marR="0" lvl="0" indent="0" algn="ctr" rtl="0">
+              <a:lnSpc>
+                <a:spcPct val="120000"/>
+              </a:lnSpc>
+              <a:spcBef>
+                <a:spcPts val="0"/>
+              </a:spcBef>
+              <a:spcAft>
+                <a:spcPts val="0"/>
+              </a:spcAft>
+              <a:buClr>
+                <a:schemeClr val="dk1"/>
+              </a:buClr>
+              <a:buSzPts val="3000"/>
+              <a:buFont typeface="Arial"/>
+              <a:buNone/>
+            </a:pPr>
+            <a:r>
+              <a:rPr lang="en" sz="2400" dirty="0">
+                <a:solidFill>
+                  <a:schemeClr val="dk2"/>
+                </a:solidFill>
+                <a:latin typeface="Twentieth Century"/>
+                <a:ea typeface="Twentieth Century"/>
+                <a:cs typeface="Twentieth Century"/>
+                <a:sym typeface="Twentieth Century"/>
+              </a:rPr>
+              <a:t>embeddings</a:t>
+            </a:r>
+            <a:endParaRPr sz="2400" dirty="0">
+              <a:solidFill>
+                <a:schemeClr val="dk2"/>
+              </a:solidFill>
+              <a:latin typeface="Twentieth Century"/>
+              <a:ea typeface="Twentieth Century"/>
+              <a:cs typeface="Twentieth Century"/>
+              <a:sym typeface="Twentieth Century"/>
+            </a:endParaRPr>
+          </a:p>
+        </p:txBody>
+      </p:sp>
+      <p:sp>
+        <p:nvSpPr>
+          <p:cNvPr id="295" name="Google Shape;295;g2f19d644e1e_1_184"/>
+          <p:cNvSpPr txBox="1"/>
+          <p:nvPr/>
+        </p:nvSpPr>
+        <p:spPr>
+          <a:xfrm>
+            <a:off x="173979" y="781835"/>
+            <a:ext cx="8641496" cy="814403"/>
+          </a:xfrm>
+          <a:prstGeom prst="rect">
+            <a:avLst/>
+          </a:prstGeom>
+          <a:noFill/>
+          <a:ln>
+            <a:noFill/>
+          </a:ln>
+        </p:spPr>
+        <p:txBody>
+          <a:bodyPr spcFirstLastPara="1" wrap="square" lIns="68575" tIns="34275" rIns="68575" bIns="34275" anchor="t" anchorCtr="0">
+            <a:noAutofit/>
+          </a:bodyPr>
+          <a:lstStyle/>
+          <a:p>
+            <a:pPr marL="0" marR="0" lvl="0" indent="0" algn="l" rtl="0">
+              <a:lnSpc>
+                <a:spcPct val="90000"/>
+              </a:lnSpc>
+              <a:spcBef>
+                <a:spcPts val="0"/>
+              </a:spcBef>
+              <a:spcAft>
+                <a:spcPts val="0"/>
+              </a:spcAft>
+              <a:buClr>
+                <a:schemeClr val="dk1"/>
+              </a:buClr>
+              <a:buSzPts val="2100"/>
+              <a:buFont typeface="Arial"/>
+              <a:buNone/>
+            </a:pPr>
+            <a:r>
+              <a:rPr lang="en" sz="2100" dirty="0">
+                <a:solidFill>
+                  <a:schemeClr val="dk2"/>
+                </a:solidFill>
+                <a:latin typeface="Twentieth Century"/>
+                <a:ea typeface="Twentieth Century"/>
+                <a:cs typeface="Twentieth Century"/>
+                <a:sym typeface="Twentieth Century"/>
+              </a:rPr>
+              <a:t>Embeddings </a:t>
+            </a:r>
+            <a:r>
+              <a:rPr lang="en" sz="2100" dirty="0">
+                <a:solidFill>
+                  <a:schemeClr val="dk2"/>
+                </a:solidFill>
+                <a:latin typeface="Twentieth Century"/>
+                <a:ea typeface="Twentieth Century"/>
+                <a:cs typeface="Twentieth Century"/>
+                <a:sym typeface="Wingdings" panose="05000000000000000000" pitchFamily="2" charset="2"/>
+              </a:rPr>
+              <a:t></a:t>
+            </a:r>
+            <a:r>
+              <a:rPr lang="en" sz="2100" dirty="0">
+                <a:solidFill>
+                  <a:schemeClr val="dk2"/>
+                </a:solidFill>
+                <a:latin typeface="Twentieth Century"/>
+                <a:ea typeface="Twentieth Century"/>
+                <a:cs typeface="Twentieth Century"/>
+                <a:sym typeface="Twentieth Century"/>
+              </a:rPr>
+              <a:t> no solo se aplica a palabras….</a:t>
+            </a:r>
+            <a:endParaRPr sz="2100" dirty="0">
+              <a:solidFill>
+                <a:schemeClr val="dk2"/>
+              </a:solidFill>
+              <a:latin typeface="Twentieth Century"/>
+              <a:ea typeface="Twentieth Century"/>
+              <a:cs typeface="Twentieth Century"/>
+              <a:sym typeface="Twentieth Century"/>
+            </a:endParaRPr>
+          </a:p>
+        </p:txBody>
+      </p:sp>
+      <p:sp>
+        <p:nvSpPr>
+          <p:cNvPr id="296" name="Google Shape;296;g2f19d644e1e_1_184"/>
+          <p:cNvSpPr/>
+          <p:nvPr/>
+        </p:nvSpPr>
+        <p:spPr>
+          <a:xfrm>
+            <a:off x="3661676" y="1939493"/>
+            <a:ext cx="1492235" cy="438581"/>
+          </a:xfrm>
+          <a:prstGeom prst="rect">
+            <a:avLst/>
+          </a:prstGeom>
+          <a:noFill/>
+          <a:ln>
+            <a:noFill/>
+          </a:ln>
+        </p:spPr>
+        <p:txBody>
+          <a:bodyPr spcFirstLastPara="1" wrap="square" lIns="68575" tIns="34275" rIns="68575" bIns="34275" anchor="t" anchorCtr="0">
+            <a:noAutofit/>
+          </a:bodyPr>
+          <a:lstStyle/>
+          <a:p>
+            <a:pPr marL="0" marR="0" lvl="0" indent="0" algn="l" rtl="0">
+              <a:spcBef>
+                <a:spcPts val="0"/>
+              </a:spcBef>
+              <a:spcAft>
+                <a:spcPts val="0"/>
+              </a:spcAft>
+              <a:buNone/>
+            </a:pPr>
+            <a:r>
+              <a:rPr lang="en" sz="2400">
+                <a:solidFill>
+                  <a:srgbClr val="FF0000"/>
+                </a:solidFill>
+                <a:latin typeface="Twentieth Century"/>
+                <a:ea typeface="Twentieth Century"/>
+                <a:cs typeface="Twentieth Century"/>
+                <a:sym typeface="Twentieth Century"/>
+              </a:rPr>
+              <a:t>ver colab</a:t>
+            </a:r>
+            <a:endParaRPr sz="2400">
+              <a:solidFill>
+                <a:srgbClr val="FF0000"/>
+              </a:solidFill>
+              <a:latin typeface="Twentieth Century"/>
+              <a:ea typeface="Twentieth Century"/>
+              <a:cs typeface="Twentieth Century"/>
+              <a:sym typeface="Twentieth Century"/>
+            </a:endParaRPr>
+          </a:p>
+        </p:txBody>
+      </p:sp>
+    </p:spTree>
   </p:cSld>
   <p:clrMapOvr>
     <a:masterClrMapping/>

</xml_diff>